<commit_message>
Improve presentation design and tech stack slide
Co-authored-by: Copilot <223556219+Copilot@users.noreply.github.com>
</commit_message>
<xml_diff>
--- a/AI_Operations_Assistant_Presentation.pptx
+++ b/AI_Operations_Assistant_Presentation.pptx
@@ -3111,7 +3111,7 @@
         <p:spPr>
           <a:xfrm>
             <a:off x="0" y="0"/>
-            <a:ext cx="12191695" cy="457200"/>
+            <a:ext cx="12191695" cy="411480"/>
           </a:xfrm>
           <a:prstGeom prst="rect">
             <a:avLst/>
@@ -3147,1162 +3147,20 @@
       </p:sp>
       <p:sp>
         <p:nvSpPr>
-          <p:cNvPr id="3" name="TextBox 2"/>
-          <p:cNvSpPr txBox="1"/>
-          <p:nvPr/>
-        </p:nvSpPr>
-        <p:spPr>
-          <a:xfrm>
-            <a:off x="731520" y="1188720"/>
-            <a:ext cx="10789920" cy="1188720"/>
-          </a:xfrm>
-          <a:prstGeom prst="rect">
-            <a:avLst/>
-          </a:prstGeom>
-          <a:noFill/>
-        </p:spPr>
-        <p:txBody>
-          <a:bodyPr wrap="none">
-            <a:spAutoFit/>
-          </a:bodyPr>
-          <a:lstStyle/>
-          <a:p>
-            <a:pPr algn="ctr"/>
-            <a:r>
-              <a:rPr sz="2600" b="1">
-                <a:solidFill>
-                  <a:srgbClr val="0F172A"/>
-                </a:solidFill>
-                <a:latin typeface="Arial"/>
-              </a:rPr>
-              <a:t>AI Operations Assistant Using Agentic AI</a:t>
-            </a:r>
-          </a:p>
-        </p:txBody>
-      </p:sp>
-      <p:sp>
-        <p:nvSpPr>
-          <p:cNvPr id="4" name="TextBox 3"/>
-          <p:cNvSpPr txBox="1"/>
-          <p:nvPr/>
-        </p:nvSpPr>
-        <p:spPr>
-          <a:xfrm>
-            <a:off x="731520" y="2286000"/>
-            <a:ext cx="10789920" cy="548640"/>
-          </a:xfrm>
-          <a:prstGeom prst="rect">
-            <a:avLst/>
-          </a:prstGeom>
-          <a:noFill/>
-        </p:spPr>
-        <p:txBody>
-          <a:bodyPr wrap="none">
-            <a:spAutoFit/>
-          </a:bodyPr>
-          <a:lstStyle/>
-          <a:p>
-            <a:pPr algn="ctr"/>
-            <a:r>
-              <a:rPr sz="1500">
-                <a:solidFill>
-                  <a:srgbClr val="475569"/>
-                </a:solidFill>
-                <a:latin typeface="Arial"/>
-              </a:rPr>
-              <a:t>Capstone Project Presentation</a:t>
-            </a:r>
-          </a:p>
-        </p:txBody>
-      </p:sp>
-      <p:sp>
-        <p:nvSpPr>
-          <p:cNvPr id="5" name="TextBox 4"/>
-          <p:cNvSpPr txBox="1"/>
-          <p:nvPr/>
-        </p:nvSpPr>
-        <p:spPr>
-          <a:xfrm>
-            <a:off x="731520" y="4389120"/>
-            <a:ext cx="10789920" cy="731520"/>
-          </a:xfrm>
-          <a:prstGeom prst="rect">
-            <a:avLst/>
-          </a:prstGeom>
-          <a:noFill/>
-        </p:spPr>
-        <p:txBody>
-          <a:bodyPr wrap="none">
-            <a:spAutoFit/>
-          </a:bodyPr>
-          <a:lstStyle/>
-          <a:p>
-            <a:pPr algn="ctr"/>
-            <a:r>
-              <a:rPr sz="1600" b="1">
-                <a:solidFill>
-                  <a:srgbClr val="005EB8"/>
-                </a:solidFill>
-                <a:latin typeface="Arial"/>
-              </a:rPr>
-              <a:t>Owner: Ajay Kumar | Email: helloajay21@gmail.com | Batch 1</a:t>
-            </a:r>
-          </a:p>
-        </p:txBody>
-      </p:sp>
-      <p:sp>
-        <p:nvSpPr>
-          <p:cNvPr id="6" name="TextBox 5"/>
-          <p:cNvSpPr txBox="1"/>
-          <p:nvPr/>
-        </p:nvSpPr>
-        <p:spPr>
-          <a:xfrm>
-            <a:off x="731520" y="5120640"/>
-            <a:ext cx="10789920" cy="365760"/>
-          </a:xfrm>
-          <a:prstGeom prst="rect">
-            <a:avLst/>
-          </a:prstGeom>
-          <a:noFill/>
-        </p:spPr>
-        <p:txBody>
-          <a:bodyPr wrap="none">
-            <a:spAutoFit/>
-          </a:bodyPr>
-          <a:lstStyle/>
-          <a:p>
-            <a:pPr algn="ctr"/>
-            <a:r>
-              <a:rPr sz="1100">
-                <a:solidFill>
-                  <a:srgbClr val="475569"/>
-                </a:solidFill>
-                <a:latin typeface="Arial"/>
-              </a:rPr>
-              <a:t>GitHub: https://github.com/helloajay21-max/-it-support-assistant</a:t>
-            </a:r>
-          </a:p>
-        </p:txBody>
-      </p:sp>
-      <p:sp>
-        <p:nvSpPr>
-          <p:cNvPr id="7" name="TextBox 6"/>
-          <p:cNvSpPr txBox="1"/>
-          <p:nvPr/>
-        </p:nvSpPr>
-        <p:spPr>
-          <a:xfrm>
-            <a:off x="731520" y="5486400"/>
-            <a:ext cx="10789920" cy="365760"/>
-          </a:xfrm>
-          <a:prstGeom prst="rect">
-            <a:avLst/>
-          </a:prstGeom>
-          <a:noFill/>
-        </p:spPr>
-        <p:txBody>
-          <a:bodyPr wrap="none">
-            <a:spAutoFit/>
-          </a:bodyPr>
-          <a:lstStyle/>
-          <a:p>
-            <a:pPr algn="ctr"/>
-            <a:r>
-              <a:rPr sz="1100">
-                <a:solidFill>
-                  <a:srgbClr val="475569"/>
-                </a:solidFill>
-                <a:latin typeface="Arial"/>
-              </a:rPr>
-              <a:t>Azure: https://it-support-ajay-001.azurewebsites.net/</a:t>
-            </a:r>
-          </a:p>
-        </p:txBody>
-      </p:sp>
-      <p:sp>
-        <p:nvSpPr>
-          <p:cNvPr id="8" name="TextBox 7"/>
-          <p:cNvSpPr txBox="1"/>
-          <p:nvPr/>
-        </p:nvSpPr>
-        <p:spPr>
-          <a:xfrm>
-            <a:off x="228600" y="6492240"/>
-            <a:ext cx="11704320" cy="228600"/>
-          </a:xfrm>
-          <a:prstGeom prst="rect">
-            <a:avLst/>
-          </a:prstGeom>
-          <a:noFill/>
-        </p:spPr>
-        <p:txBody>
-          <a:bodyPr wrap="none">
-            <a:spAutoFit/>
-          </a:bodyPr>
-          <a:lstStyle/>
-          <a:p>
-            <a:r>
-              <a:rPr sz="800">
-                <a:solidFill>
-                  <a:srgbClr val="475569"/>
-                </a:solidFill>
-                <a:latin typeface="Arial"/>
-              </a:rPr>
-              <a:t>Owner: Ajay Kumar | Email: helloajay21@gmail.com | Batch 1 | Project: AI Operations Assistant Using Agentic AI | GitHub: https://github.com/helloajay21-max/-it-support-assistant | Azure: https://it-support-ajay-001.azurewebsites.net/</a:t>
-            </a:r>
-          </a:p>
-        </p:txBody>
-      </p:sp>
-    </p:spTree>
-  </p:cSld>
-  <p:clrMapOvr>
-    <a:masterClrMapping/>
-  </p:clrMapOvr>
-</p:sld>
-</file>
-
-<file path=ppt/slides/slide2.xml><?xml version="1.0" encoding="utf-8"?>
-<p:sld xmlns:a="http://schemas.openxmlformats.org/drawingml/2006/main" xmlns:p="http://schemas.openxmlformats.org/presentationml/2006/main" xmlns:r="http://schemas.openxmlformats.org/officeDocument/2006/relationships">
-  <p:cSld>
-    <p:spTree>
-      <p:nvGrpSpPr>
-        <p:cNvPr id="1" name=""/>
-        <p:cNvGrpSpPr/>
-        <p:nvPr/>
-      </p:nvGrpSpPr>
-      <p:grpSpPr/>
-      <p:sp>
-        <p:nvSpPr>
-          <p:cNvPr id="2" name="Title 1"/>
-          <p:cNvSpPr>
-            <a:spLocks noGrp="1"/>
-          </p:cNvSpPr>
-          <p:nvPr>
-            <p:ph type="title"/>
-          </p:nvPr>
-        </p:nvSpPr>
-        <p:spPr/>
-        <p:txBody>
-          <a:bodyPr/>
-          <a:lstStyle/>
-          <a:p>
-            <a:pPr>
-              <a:defRPr sz="2400" b="1">
-                <a:latin typeface="Arial"/>
-              </a:defRPr>
-            </a:pPr>
-            <a:r>
-              <a:t>Problem Statement</a:t>
-            </a:r>
-          </a:p>
-        </p:txBody>
-      </p:sp>
-      <p:sp>
-        <p:nvSpPr>
-          <p:cNvPr id="3" name="TextBox 2"/>
-          <p:cNvSpPr txBox="1"/>
-          <p:nvPr/>
-        </p:nvSpPr>
-        <p:spPr>
-          <a:xfrm>
-            <a:off x="640080" y="1188720"/>
-            <a:ext cx="10972800" cy="4389120"/>
-          </a:xfrm>
-          <a:prstGeom prst="rect">
-            <a:avLst/>
-          </a:prstGeom>
-          <a:noFill/>
-        </p:spPr>
-        <p:txBody>
-          <a:bodyPr wrap="none">
-            <a:spAutoFit/>
-          </a:bodyPr>
-          <a:lstStyle/>
-          <a:p>
-            <a:pPr>
-              <a:spcAft>
-                <a:spcPts val="800"/>
-              </a:spcAft>
-              <a:defRPr sz="2000">
-                <a:latin typeface="Arial"/>
-              </a:defRPr>
-            </a:pPr>
-            <a:r>
-              <a:t>The organization needed a centralized AI-based support assistant for:</a:t>
-            </a:r>
-          </a:p>
-          <a:p>
-            <a:pPr>
-              <a:spcAft>
-                <a:spcPts val="800"/>
-              </a:spcAft>
-              <a:defRPr sz="2000">
-                <a:latin typeface="Arial"/>
-              </a:defRPr>
-            </a:pPr>
-            <a:r>
-              <a:t>• Employee records and profile management</a:t>
-            </a:r>
-          </a:p>
-          <a:p>
-            <a:pPr>
-              <a:spcAft>
-                <a:spcPts val="800"/>
-              </a:spcAft>
-              <a:defRPr sz="2000">
-                <a:latin typeface="Arial"/>
-              </a:defRPr>
-            </a:pPr>
-            <a:r>
-              <a:t>• Ticket tracking and status visibility</a:t>
-            </a:r>
-          </a:p>
-          <a:p>
-            <a:pPr>
-              <a:spcAft>
-                <a:spcPts val="800"/>
-              </a:spcAft>
-              <a:defRPr sz="2000">
-                <a:latin typeface="Arial"/>
-              </a:defRPr>
-            </a:pPr>
-            <a:r>
-              <a:t>• VPN setup requests and email dispatch</a:t>
-            </a:r>
-          </a:p>
-          <a:p>
-            <a:pPr>
-              <a:spcAft>
-                <a:spcPts val="800"/>
-              </a:spcAft>
-              <a:defRPr sz="2000">
-                <a:latin typeface="Arial"/>
-              </a:defRPr>
-            </a:pPr>
-            <a:r>
-              <a:t>• Admin approval/rejection workflows</a:t>
-            </a:r>
-          </a:p>
-          <a:p>
-            <a:pPr>
-              <a:spcAft>
-                <a:spcPts val="800"/>
-              </a:spcAft>
-              <a:defRPr sz="2000">
-                <a:latin typeface="Arial"/>
-              </a:defRPr>
-            </a:pPr>
-            <a:r>
-              <a:t>• Secure user login and password management</a:t>
-            </a:r>
-          </a:p>
-          <a:p>
-            <a:pPr>
-              <a:spcAft>
-                <a:spcPts val="800"/>
-              </a:spcAft>
-              <a:defRPr sz="2000">
-                <a:latin typeface="Arial"/>
-              </a:defRPr>
-            </a:pPr>
-            <a:r>
-              <a:t>• Deployment on Azure with CI/CD</a:t>
-            </a:r>
-          </a:p>
-          <a:p>
-            <a:pPr>
-              <a:spcAft>
-                <a:spcPts val="800"/>
-              </a:spcAft>
-              <a:defRPr sz="2000">
-                <a:latin typeface="Arial"/>
-              </a:defRPr>
-            </a:pPr>
-          </a:p>
-          <a:p>
-            <a:pPr>
-              <a:spcAft>
-                <a:spcPts val="800"/>
-              </a:spcAft>
-              <a:defRPr sz="1800">
-                <a:latin typeface="Arial"/>
-              </a:defRPr>
-            </a:pPr>
-            <a:r>
-              <a:t>Challenges handled:</a:t>
-            </a:r>
-          </a:p>
-          <a:p>
-            <a:pPr>
-              <a:spcAft>
-                <a:spcPts val="800"/>
-              </a:spcAft>
-              <a:defRPr sz="1800">
-                <a:latin typeface="Arial"/>
-              </a:defRPr>
-            </a:pPr>
-            <a:r>
-              <a:t>• Email dispatch failures and SMTP configuration issues</a:t>
-            </a:r>
-          </a:p>
-          <a:p>
-            <a:pPr>
-              <a:spcAft>
-                <a:spcPts val="800"/>
-              </a:spcAft>
-              <a:defRPr sz="1800">
-                <a:latin typeface="Arial"/>
-              </a:defRPr>
-            </a:pPr>
-            <a:r>
-              <a:t>• Incorrect ticket visibility and stale employee mapping</a:t>
-            </a:r>
-          </a:p>
-          <a:p>
-            <a:pPr>
-              <a:spcAft>
-                <a:spcPts val="800"/>
-              </a:spcAft>
-              <a:defRPr sz="1800">
-                <a:latin typeface="Arial"/>
-              </a:defRPr>
-            </a:pPr>
-            <a:r>
-              <a:t>• Security risk due to exposed or plain-text passwords</a:t>
-            </a:r>
-          </a:p>
-          <a:p>
-            <a:pPr>
-              <a:spcAft>
-                <a:spcPts val="800"/>
-              </a:spcAft>
-              <a:defRPr sz="1800">
-                <a:latin typeface="Arial"/>
-              </a:defRPr>
-            </a:pPr>
-            <a:r>
-              <a:t>• Reset-link reliability and expiry handling</a:t>
-            </a:r>
-          </a:p>
-          <a:p>
-            <a:pPr>
-              <a:spcAft>
-                <a:spcPts val="800"/>
-              </a:spcAft>
-              <a:defRPr sz="1800">
-                <a:latin typeface="Arial"/>
-              </a:defRPr>
-            </a:pPr>
-            <a:r>
-              <a:t>• Multi-user access and admin permissions</a:t>
-            </a:r>
-          </a:p>
-        </p:txBody>
-      </p:sp>
-      <p:sp>
-        <p:nvSpPr>
-          <p:cNvPr id="4" name="TextBox 3"/>
-          <p:cNvSpPr txBox="1"/>
-          <p:nvPr/>
-        </p:nvSpPr>
-        <p:spPr>
-          <a:xfrm>
-            <a:off x="228600" y="6492240"/>
-            <a:ext cx="11704320" cy="228600"/>
-          </a:xfrm>
-          <a:prstGeom prst="rect">
-            <a:avLst/>
-          </a:prstGeom>
-          <a:noFill/>
-        </p:spPr>
-        <p:txBody>
-          <a:bodyPr wrap="none">
-            <a:spAutoFit/>
-          </a:bodyPr>
-          <a:lstStyle/>
-          <a:p>
-            <a:r>
-              <a:rPr sz="800">
-                <a:solidFill>
-                  <a:srgbClr val="475569"/>
-                </a:solidFill>
-                <a:latin typeface="Arial"/>
-              </a:rPr>
-              <a:t>Owner: Ajay Kumar | Email: helloajay21@gmail.com | Batch 1 | Project: AI Operations Assistant Using Agentic AI | GitHub: https://github.com/helloajay21-max/-it-support-assistant | Azure: https://it-support-ajay-001.azurewebsites.net/</a:t>
-            </a:r>
-          </a:p>
-        </p:txBody>
-      </p:sp>
-    </p:spTree>
-  </p:cSld>
-  <p:clrMapOvr>
-    <a:masterClrMapping/>
-  </p:clrMapOvr>
-</p:sld>
-</file>
-
-<file path=ppt/slides/slide3.xml><?xml version="1.0" encoding="utf-8"?>
-<p:sld xmlns:a="http://schemas.openxmlformats.org/drawingml/2006/main" xmlns:p="http://schemas.openxmlformats.org/presentationml/2006/main" xmlns:r="http://schemas.openxmlformats.org/officeDocument/2006/relationships">
-  <p:cSld>
-    <p:spTree>
-      <p:nvGrpSpPr>
-        <p:cNvPr id="1" name=""/>
-        <p:cNvGrpSpPr/>
-        <p:nvPr/>
-      </p:nvGrpSpPr>
-      <p:grpSpPr/>
-      <p:sp>
-        <p:nvSpPr>
-          <p:cNvPr id="2" name="Title 1"/>
-          <p:cNvSpPr>
-            <a:spLocks noGrp="1"/>
-          </p:cNvSpPr>
-          <p:nvPr>
-            <p:ph type="title"/>
-          </p:nvPr>
-        </p:nvSpPr>
-        <p:spPr/>
-        <p:txBody>
-          <a:bodyPr/>
-          <a:lstStyle/>
-          <a:p>
-            <a:pPr>
-              <a:defRPr sz="2400">
-                <a:latin typeface="Arial"/>
-              </a:defRPr>
-            </a:pPr>
-            <a:r>
-              <a:t>Solution Overview</a:t>
-            </a:r>
-          </a:p>
-        </p:txBody>
-      </p:sp>
-      <p:sp>
-        <p:nvSpPr>
-          <p:cNvPr id="3" name="TextBox 2"/>
-          <p:cNvSpPr txBox="1"/>
-          <p:nvPr/>
-        </p:nvSpPr>
-        <p:spPr>
-          <a:xfrm>
-            <a:off x="640080" y="1188720"/>
-            <a:ext cx="10972800" cy="4389120"/>
-          </a:xfrm>
-          <a:prstGeom prst="rect">
-            <a:avLst/>
-          </a:prstGeom>
-          <a:noFill/>
-        </p:spPr>
-        <p:txBody>
-          <a:bodyPr wrap="none">
-            <a:spAutoFit/>
-          </a:bodyPr>
-          <a:lstStyle/>
-          <a:p>
-            <a:pPr>
-              <a:spcAft>
-                <a:spcPts val="1000"/>
-              </a:spcAft>
-              <a:defRPr sz="1900">
-                <a:latin typeface="Arial"/>
-              </a:defRPr>
-            </a:pPr>
-            <a:r>
-              <a:t>Developed an AI Operations Assistant with:</a:t>
-            </a:r>
-          </a:p>
-          <a:p>
-            <a:pPr>
-              <a:spcAft>
-                <a:spcPts val="1000"/>
-              </a:spcAft>
-              <a:defRPr sz="1900">
-                <a:latin typeface="Arial"/>
-              </a:defRPr>
-            </a:pPr>
-            <a:r>
-              <a:t>• Secure login and user signup</a:t>
-            </a:r>
-          </a:p>
-          <a:p>
-            <a:pPr>
-              <a:spcAft>
-                <a:spcPts val="1000"/>
-              </a:spcAft>
-              <a:defRPr sz="1900">
-                <a:latin typeface="Arial"/>
-              </a:defRPr>
-            </a:pPr>
-            <a:r>
-              <a:t>• Password hashing in the database</a:t>
-            </a:r>
-          </a:p>
-          <a:p>
-            <a:pPr>
-              <a:spcAft>
-                <a:spcPts val="1000"/>
-              </a:spcAft>
-              <a:defRPr sz="1900">
-                <a:latin typeface="Arial"/>
-              </a:defRPr>
-            </a:pPr>
-            <a:r>
-              <a:t>• Admin-only approval and rejection workflows</a:t>
-            </a:r>
-          </a:p>
-          <a:p>
-            <a:pPr>
-              <a:spcAft>
-                <a:spcPts val="1000"/>
-              </a:spcAft>
-              <a:defRPr sz="1900">
-                <a:latin typeface="Arial"/>
-              </a:defRPr>
-            </a:pPr>
-            <a:r>
-              <a:t>• Direct VPN setup email with credentials</a:t>
-            </a:r>
-          </a:p>
-          <a:p>
-            <a:pPr>
-              <a:spcAft>
-                <a:spcPts val="1000"/>
-              </a:spcAft>
-              <a:defRPr sz="1900">
-                <a:latin typeface="Arial"/>
-              </a:defRPr>
-            </a:pPr>
-            <a:r>
-              <a:t>• Forgot-password reset workflow with secure tokens</a:t>
-            </a:r>
-          </a:p>
-          <a:p>
-            <a:pPr>
-              <a:spcAft>
-                <a:spcPts val="1000"/>
-              </a:spcAft>
-              <a:defRPr sz="1900">
-                <a:latin typeface="Arial"/>
-              </a:defRPr>
-            </a:pPr>
-            <a:r>
-              <a:t>• Normal-user profile update capability</a:t>
-            </a:r>
-          </a:p>
-          <a:p>
-            <a:pPr>
-              <a:spcAft>
-                <a:spcPts val="1000"/>
-              </a:spcAft>
-              <a:defRPr sz="1900">
-                <a:latin typeface="Arial"/>
-              </a:defRPr>
-            </a:pPr>
-            <a:r>
-              <a:t>• Correct employee and ticket visibility</a:t>
-            </a:r>
-          </a:p>
-          <a:p>
-            <a:pPr>
-              <a:spcAft>
-                <a:spcPts val="1000"/>
-              </a:spcAft>
-              <a:defRPr sz="1900">
-                <a:latin typeface="Arial"/>
-              </a:defRPr>
-            </a:pPr>
-            <a:r>
-              <a:t>• Azure deployment with GitHub Actions CI/CD</a:t>
-            </a:r>
-          </a:p>
-        </p:txBody>
-      </p:sp>
-      <p:sp>
-        <p:nvSpPr>
-          <p:cNvPr id="4" name="TextBox 3"/>
-          <p:cNvSpPr txBox="1"/>
-          <p:nvPr/>
-        </p:nvSpPr>
-        <p:spPr>
-          <a:xfrm>
-            <a:off x="228600" y="6492240"/>
-            <a:ext cx="11704320" cy="228600"/>
-          </a:xfrm>
-          <a:prstGeom prst="rect">
-            <a:avLst/>
-          </a:prstGeom>
-          <a:noFill/>
-        </p:spPr>
-        <p:txBody>
-          <a:bodyPr wrap="none">
-            <a:spAutoFit/>
-          </a:bodyPr>
-          <a:lstStyle/>
-          <a:p>
-            <a:r>
-              <a:rPr sz="800">
-                <a:solidFill>
-                  <a:srgbClr val="475569"/>
-                </a:solidFill>
-                <a:latin typeface="Arial"/>
-              </a:rPr>
-              <a:t>Owner: Ajay Kumar | Email: helloajay21@gmail.com | Batch 1 | Project: AI Operations Assistant Using Agentic AI | GitHub: https://github.com/helloajay21-max/-it-support-assistant | Azure: https://it-support-ajay-001.azurewebsites.net/</a:t>
-            </a:r>
-          </a:p>
-        </p:txBody>
-      </p:sp>
-    </p:spTree>
-  </p:cSld>
-  <p:clrMapOvr>
-    <a:masterClrMapping/>
-  </p:clrMapOvr>
-</p:sld>
-</file>
-
-<file path=ppt/slides/slide4.xml><?xml version="1.0" encoding="utf-8"?>
-<p:sld xmlns:a="http://schemas.openxmlformats.org/drawingml/2006/main" xmlns:p="http://schemas.openxmlformats.org/presentationml/2006/main" xmlns:r="http://schemas.openxmlformats.org/officeDocument/2006/relationships">
-  <p:cSld>
-    <p:spTree>
-      <p:nvGrpSpPr>
-        <p:cNvPr id="1" name=""/>
-        <p:cNvGrpSpPr/>
-        <p:nvPr/>
-      </p:nvGrpSpPr>
-      <p:grpSpPr/>
-      <p:sp>
-        <p:nvSpPr>
-          <p:cNvPr id="2" name="Title 1"/>
-          <p:cNvSpPr>
-            <a:spLocks noGrp="1"/>
-          </p:cNvSpPr>
-          <p:nvPr>
-            <p:ph type="title"/>
-          </p:nvPr>
-        </p:nvSpPr>
-        <p:spPr/>
-        <p:txBody>
-          <a:bodyPr/>
-          <a:lstStyle/>
-          <a:p>
-            <a:pPr>
-              <a:defRPr sz="2400">
-                <a:latin typeface="Arial"/>
-              </a:defRPr>
-            </a:pPr>
-            <a:r>
-              <a:t>Key Features Implemented</a:t>
-            </a:r>
-          </a:p>
-        </p:txBody>
-      </p:sp>
-      <p:sp>
-        <p:nvSpPr>
-          <p:cNvPr id="3" name="TextBox 2"/>
-          <p:cNvSpPr txBox="1"/>
-          <p:nvPr/>
-        </p:nvSpPr>
-        <p:spPr>
-          <a:xfrm>
-            <a:off x="640080" y="1371600"/>
-            <a:ext cx="5029200" cy="4389120"/>
-          </a:xfrm>
-          <a:prstGeom prst="rect">
-            <a:avLst/>
-          </a:prstGeom>
-          <a:noFill/>
-        </p:spPr>
-        <p:txBody>
-          <a:bodyPr wrap="none">
-            <a:spAutoFit/>
-          </a:bodyPr>
-          <a:lstStyle/>
-          <a:p>
-            <a:pPr>
-              <a:spcAft>
-                <a:spcPts val="800"/>
-              </a:spcAft>
-              <a:defRPr sz="1800">
-                <a:latin typeface="Arial"/>
-              </a:defRPr>
-            </a:pPr>
-            <a:r>
-              <a:t>1. Secure Authentication</a:t>
-            </a:r>
-          </a:p>
-          <a:p>
-            <a:pPr>
-              <a:spcAft>
-                <a:spcPts val="800"/>
-              </a:spcAft>
-              <a:defRPr sz="1800">
-                <a:latin typeface="Arial"/>
-              </a:defRPr>
-            </a:pPr>
-            <a:r>
-              <a:t>• Login and Sign-up flow</a:t>
-            </a:r>
-          </a:p>
-          <a:p>
-            <a:pPr>
-              <a:spcAft>
-                <a:spcPts val="800"/>
-              </a:spcAft>
-              <a:defRPr sz="1800">
-                <a:latin typeface="Arial"/>
-              </a:defRPr>
-            </a:pPr>
-            <a:r>
-              <a:t>• Hashed passwords in DB</a:t>
-            </a:r>
-          </a:p>
-          <a:p>
-            <a:pPr>
-              <a:spcAft>
-                <a:spcPts val="800"/>
-              </a:spcAft>
-              <a:defRPr sz="1800">
-                <a:latin typeface="Arial"/>
-              </a:defRPr>
-            </a:pPr>
-            <a:r>
-              <a:t>• Admin-only protection</a:t>
-            </a:r>
-          </a:p>
-          <a:p>
-            <a:pPr>
-              <a:spcAft>
-                <a:spcPts val="800"/>
-              </a:spcAft>
-              <a:defRPr sz="1800">
-                <a:latin typeface="Arial"/>
-              </a:defRPr>
-            </a:pPr>
-            <a:r>
-              <a:t>• Welcome message with active user name</a:t>
-            </a:r>
-          </a:p>
-          <a:p>
-            <a:pPr>
-              <a:spcAft>
-                <a:spcPts val="800"/>
-              </a:spcAft>
-              <a:defRPr sz="1800">
-                <a:latin typeface="Arial"/>
-              </a:defRPr>
-            </a:pPr>
-          </a:p>
-          <a:p>
-            <a:pPr>
-              <a:spcAft>
-                <a:spcPts val="800"/>
-              </a:spcAft>
-              <a:defRPr sz="1800">
-                <a:latin typeface="Arial"/>
-              </a:defRPr>
-            </a:pPr>
-            <a:r>
-              <a:t>2. Role-Based Access</a:t>
-            </a:r>
-          </a:p>
-          <a:p>
-            <a:pPr>
-              <a:spcAft>
-                <a:spcPts val="800"/>
-              </a:spcAft>
-              <a:defRPr sz="1800">
-                <a:latin typeface="Arial"/>
-              </a:defRPr>
-            </a:pPr>
-            <a:r>
-              <a:t>• Only Ajay Kumar can approve/reject</a:t>
-            </a:r>
-          </a:p>
-          <a:p>
-            <a:pPr>
-              <a:spcAft>
-                <a:spcPts val="800"/>
-              </a:spcAft>
-              <a:defRPr sz="1800">
-                <a:latin typeface="Arial"/>
-              </a:defRPr>
-            </a:pPr>
-            <a:r>
-              <a:t>• Normal users see same UI but limited actions</a:t>
-            </a:r>
-          </a:p>
-          <a:p>
-            <a:pPr>
-              <a:spcAft>
-                <a:spcPts val="800"/>
-              </a:spcAft>
-              <a:defRPr sz="1800">
-                <a:latin typeface="Arial"/>
-              </a:defRPr>
-            </a:pPr>
-            <a:r>
-              <a:t>• Admin profile protected from deletion</a:t>
-            </a:r>
-          </a:p>
-        </p:txBody>
-      </p:sp>
-      <p:sp>
-        <p:nvSpPr>
-          <p:cNvPr id="4" name="TextBox 3"/>
-          <p:cNvSpPr txBox="1"/>
-          <p:nvPr/>
-        </p:nvSpPr>
-        <p:spPr>
-          <a:xfrm>
-            <a:off x="6126480" y="1371600"/>
-            <a:ext cx="5303520" cy="4389120"/>
-          </a:xfrm>
-          <a:prstGeom prst="rect">
-            <a:avLst/>
-          </a:prstGeom>
-          <a:noFill/>
-        </p:spPr>
-        <p:txBody>
-          <a:bodyPr wrap="none">
-            <a:spAutoFit/>
-          </a:bodyPr>
-          <a:lstStyle/>
-          <a:p>
-            <a:pPr>
-              <a:spcAft>
-                <a:spcPts val="800"/>
-              </a:spcAft>
-              <a:defRPr sz="1800">
-                <a:latin typeface="Arial"/>
-              </a:defRPr>
-            </a:pPr>
-            <a:r>
-              <a:t>3. Email and Ticket Workflow</a:t>
-            </a:r>
-          </a:p>
-          <a:p>
-            <a:pPr>
-              <a:spcAft>
-                <a:spcPts val="800"/>
-              </a:spcAft>
-              <a:defRPr sz="1800">
-                <a:latin typeface="Arial"/>
-              </a:defRPr>
-            </a:pPr>
-            <a:r>
-              <a:t>• Direct VPN email option</a:t>
-            </a:r>
-          </a:p>
-          <a:p>
-            <a:pPr>
-              <a:spcAft>
-                <a:spcPts val="800"/>
-              </a:spcAft>
-              <a:defRPr sz="1800">
-                <a:latin typeface="Arial"/>
-              </a:defRPr>
-            </a:pPr>
-            <a:r>
-              <a:t>• Approval emails with Azure links</a:t>
-            </a:r>
-          </a:p>
-          <a:p>
-            <a:pPr>
-              <a:spcAft>
-                <a:spcPts val="800"/>
-              </a:spcAft>
-              <a:defRPr sz="1800">
-                <a:latin typeface="Arial"/>
-              </a:defRPr>
-            </a:pPr>
-            <a:r>
-              <a:t>• Correct employee and ticket visibility</a:t>
-            </a:r>
-          </a:p>
-          <a:p>
-            <a:pPr>
-              <a:spcAft>
-                <a:spcPts val="800"/>
-              </a:spcAft>
-              <a:defRPr sz="1800">
-                <a:latin typeface="Arial"/>
-              </a:defRPr>
-            </a:pPr>
-            <a:r>
-              <a:t>• Org-wide status review for valid users</a:t>
-            </a:r>
-          </a:p>
-          <a:p>
-            <a:pPr>
-              <a:spcAft>
-                <a:spcPts val="800"/>
-              </a:spcAft>
-              <a:defRPr sz="1800">
-                <a:latin typeface="Arial"/>
-              </a:defRPr>
-            </a:pPr>
-          </a:p>
-          <a:p>
-            <a:pPr>
-              <a:spcAft>
-                <a:spcPts val="800"/>
-              </a:spcAft>
-              <a:defRPr sz="1800">
-                <a:latin typeface="Arial"/>
-              </a:defRPr>
-            </a:pPr>
-            <a:r>
-              <a:t>4. Deployment and Security</a:t>
-            </a:r>
-          </a:p>
-          <a:p>
-            <a:pPr>
-              <a:spcAft>
-                <a:spcPts val="800"/>
-              </a:spcAft>
-              <a:defRPr sz="1800">
-                <a:latin typeface="Arial"/>
-              </a:defRPr>
-            </a:pPr>
-            <a:r>
-              <a:t>• Forgot-password email reset</a:t>
-            </a:r>
-          </a:p>
-          <a:p>
-            <a:pPr>
-              <a:spcAft>
-                <a:spcPts val="800"/>
-              </a:spcAft>
-              <a:defRPr sz="1800">
-                <a:latin typeface="Arial"/>
-              </a:defRPr>
-            </a:pPr>
-            <a:r>
-              <a:t>• Secure token validation</a:t>
-            </a:r>
-          </a:p>
-          <a:p>
-            <a:pPr>
-              <a:spcAft>
-                <a:spcPts val="800"/>
-              </a:spcAft>
-              <a:defRPr sz="1800">
-                <a:latin typeface="Arial"/>
-              </a:defRPr>
-            </a:pPr>
-            <a:r>
-              <a:t>• SQLite repair for duplicate rows</a:t>
-            </a:r>
-          </a:p>
-          <a:p>
-            <a:pPr>
-              <a:spcAft>
-                <a:spcPts val="800"/>
-              </a:spcAft>
-              <a:defRPr sz="1800">
-                <a:latin typeface="Arial"/>
-              </a:defRPr>
-            </a:pPr>
-            <a:r>
-              <a:t>• Azure CI/CD deployment</a:t>
-            </a:r>
-          </a:p>
-        </p:txBody>
-      </p:sp>
-      <p:sp>
-        <p:nvSpPr>
-          <p:cNvPr id="5" name="TextBox 4"/>
-          <p:cNvSpPr txBox="1"/>
-          <p:nvPr/>
-        </p:nvSpPr>
-        <p:spPr>
-          <a:xfrm>
-            <a:off x="228600" y="6492240"/>
-            <a:ext cx="11704320" cy="228600"/>
-          </a:xfrm>
-          <a:prstGeom prst="rect">
-            <a:avLst/>
-          </a:prstGeom>
-          <a:noFill/>
-        </p:spPr>
-        <p:txBody>
-          <a:bodyPr wrap="none">
-            <a:spAutoFit/>
-          </a:bodyPr>
-          <a:lstStyle/>
-          <a:p>
-            <a:r>
-              <a:rPr sz="800">
-                <a:solidFill>
-                  <a:srgbClr val="475569"/>
-                </a:solidFill>
-                <a:latin typeface="Arial"/>
-              </a:rPr>
-              <a:t>Owner: Ajay Kumar | Email: helloajay21@gmail.com | Batch 1 | Project: AI Operations Assistant Using Agentic AI | GitHub: https://github.com/helloajay21-max/-it-support-assistant | Azure: https://it-support-ajay-001.azurewebsites.net/</a:t>
-            </a:r>
-          </a:p>
-        </p:txBody>
-      </p:sp>
-    </p:spTree>
-  </p:cSld>
-  <p:clrMapOvr>
-    <a:masterClrMapping/>
-  </p:clrMapOvr>
-</p:sld>
-</file>
-
-<file path=ppt/slides/slide5.xml><?xml version="1.0" encoding="utf-8"?>
-<p:sld xmlns:a="http://schemas.openxmlformats.org/drawingml/2006/main" xmlns:p="http://schemas.openxmlformats.org/presentationml/2006/main" xmlns:r="http://schemas.openxmlformats.org/officeDocument/2006/relationships">
-  <p:cSld>
-    <p:spTree>
-      <p:nvGrpSpPr>
-        <p:cNvPr id="1" name=""/>
-        <p:cNvGrpSpPr/>
-        <p:nvPr/>
-      </p:nvGrpSpPr>
-      <p:grpSpPr/>
-      <p:sp>
-        <p:nvSpPr>
-          <p:cNvPr id="2" name="Title 1"/>
-          <p:cNvSpPr>
-            <a:spLocks noGrp="1"/>
-          </p:cNvSpPr>
-          <p:nvPr>
-            <p:ph type="title"/>
-          </p:nvPr>
-        </p:nvSpPr>
-        <p:spPr/>
-        <p:txBody>
-          <a:bodyPr/>
-          <a:lstStyle/>
-          <a:p>
-            <a:pPr>
-              <a:defRPr sz="2400">
-                <a:latin typeface="Arial"/>
-              </a:defRPr>
-            </a:pPr>
-            <a:r>
-              <a:t>System Architecture</a:t>
-            </a:r>
-          </a:p>
-        </p:txBody>
-      </p:sp>
-      <p:sp>
-        <p:nvSpPr>
           <p:cNvPr id="3" name="Rounded Rectangle 2"/>
           <p:cNvSpPr/>
           <p:nvPr/>
         </p:nvSpPr>
         <p:spPr>
           <a:xfrm>
-            <a:off x="731520" y="2560320"/>
-            <a:ext cx="1280160" cy="822960"/>
+            <a:off x="822960" y="1005840"/>
+            <a:ext cx="10515600" cy="2926080"/>
           </a:xfrm>
           <a:prstGeom prst="roundRect">
             <a:avLst/>
           </a:prstGeom>
           <a:solidFill>
-            <a:srgbClr val="0EA5E9"/>
+            <a:srgbClr val="F1F5F9"/>
           </a:solidFill>
           <a:ln>
             <a:solidFill>
@@ -4329,38 +3187,100 @@
           <a:lstStyle/>
           <a:p>
             <a:pPr algn="ctr"/>
-            <a:r>
-              <a:rPr sz="1200" b="1">
-                <a:solidFill>
-                  <a:srgbClr val="FFFFFF"/>
+          </a:p>
+        </p:txBody>
+      </p:sp>
+      <p:sp>
+        <p:nvSpPr>
+          <p:cNvPr id="4" name="TextBox 3"/>
+          <p:cNvSpPr txBox="1"/>
+          <p:nvPr/>
+        </p:nvSpPr>
+        <p:spPr>
+          <a:xfrm>
+            <a:off x="1188720" y="1645920"/>
+            <a:ext cx="9601200" cy="822960"/>
+          </a:xfrm>
+          <a:prstGeom prst="rect">
+            <a:avLst/>
+          </a:prstGeom>
+          <a:noFill/>
+        </p:spPr>
+        <p:txBody>
+          <a:bodyPr wrap="none">
+            <a:spAutoFit/>
+          </a:bodyPr>
+          <a:lstStyle/>
+          <a:p>
+            <a:pPr algn="ctr"/>
+            <a:r>
+              <a:rPr sz="2800" b="1">
+                <a:solidFill>
+                  <a:srgbClr val="0F172A"/>
                 </a:solidFill>
                 <a:latin typeface="Arial"/>
               </a:rPr>
-              <a:t>GitHub
-Repo</a:t>
-            </a:r>
-          </a:p>
-        </p:txBody>
-      </p:sp>
-      <p:sp>
-        <p:nvSpPr>
-          <p:cNvPr id="4" name="Right Arrow 3"/>
+              <a:t>AI Operations Assistant Using Agentic AI</a:t>
+            </a:r>
+          </a:p>
+        </p:txBody>
+      </p:sp>
+      <p:sp>
+        <p:nvSpPr>
+          <p:cNvPr id="5" name="TextBox 4"/>
+          <p:cNvSpPr txBox="1"/>
+          <p:nvPr/>
+        </p:nvSpPr>
+        <p:spPr>
+          <a:xfrm>
+            <a:off x="1188720" y="2560320"/>
+            <a:ext cx="9601200" cy="457200"/>
+          </a:xfrm>
+          <a:prstGeom prst="rect">
+            <a:avLst/>
+          </a:prstGeom>
+          <a:noFill/>
+        </p:spPr>
+        <p:txBody>
+          <a:bodyPr wrap="none">
+            <a:spAutoFit/>
+          </a:bodyPr>
+          <a:lstStyle/>
+          <a:p>
+            <a:pPr algn="ctr"/>
+            <a:r>
+              <a:rPr sz="1600">
+                <a:solidFill>
+                  <a:srgbClr val="475569"/>
+                </a:solidFill>
+                <a:latin typeface="Arial"/>
+              </a:rPr>
+              <a:t>Capstone Project Presentation</a:t>
+            </a:r>
+          </a:p>
+        </p:txBody>
+      </p:sp>
+      <p:sp>
+        <p:nvSpPr>
+          <p:cNvPr id="6" name="Rectangle 5"/>
           <p:cNvSpPr/>
           <p:nvPr/>
         </p:nvSpPr>
         <p:spPr>
           <a:xfrm>
-            <a:off x="2011680" y="2852927"/>
-            <a:ext cx="548640" cy="201168"/>
-          </a:xfrm>
-          <a:prstGeom prst="rightArrow">
+            <a:off x="1005840" y="4069080"/>
+            <a:ext cx="10149840" cy="640080"/>
+          </a:xfrm>
+          <a:prstGeom prst="rect">
             <a:avLst/>
           </a:prstGeom>
           <a:solidFill>
-            <a:srgbClr val="475569"/>
+            <a:srgbClr val="DBEAFE"/>
           </a:solidFill>
           <a:ln>
-            <a:noFill/>
+            <a:solidFill>
+              <a:srgbClr val="005EB8"/>
+            </a:solidFill>
           </a:ln>
         </p:spPr>
         <p:style>
@@ -4382,25 +3302,34 @@
           <a:lstStyle/>
           <a:p>
             <a:pPr algn="ctr"/>
-          </a:p>
-        </p:txBody>
-      </p:sp>
-      <p:sp>
-        <p:nvSpPr>
-          <p:cNvPr id="5" name="Rounded Rectangle 4"/>
+            <a:r>
+              <a:rPr sz="1100" b="1">
+                <a:solidFill>
+                  <a:srgbClr val="005EB8"/>
+                </a:solidFill>
+                <a:latin typeface="Arial"/>
+              </a:rPr>
+              <a:t>Tech Stack: LangGraph ? LangChain ? MCP ? Streamlit ? Azure OpenAI ? Docker ? Azure Container Registry ? Azure Container Apps ? GitHub Actions ? SQLite</a:t>
+            </a:r>
+          </a:p>
+        </p:txBody>
+      </p:sp>
+      <p:sp>
+        <p:nvSpPr>
+          <p:cNvPr id="7" name="Rectangle 6"/>
           <p:cNvSpPr/>
           <p:nvPr/>
         </p:nvSpPr>
         <p:spPr>
           <a:xfrm>
-            <a:off x="2468880" y="2560320"/>
-            <a:ext cx="1280160" cy="822960"/>
-          </a:xfrm>
-          <a:prstGeom prst="roundRect">
+            <a:off x="1371600" y="4983480"/>
+            <a:ext cx="9418320" cy="594360"/>
+          </a:xfrm>
+          <a:prstGeom prst="rect">
             <a:avLst/>
           </a:prstGeom>
           <a:solidFill>
-            <a:srgbClr val="0EA5E9"/>
+            <a:srgbClr val="FFFFFF"/>
           </a:solidFill>
           <a:ln>
             <a:solidFill>
@@ -4428,34 +3357,129 @@
           <a:p>
             <a:pPr algn="ctr"/>
             <a:r>
-              <a:rPr sz="1200" b="1">
-                <a:solidFill>
-                  <a:srgbClr val="FFFFFF"/>
+              <a:rPr sz="1600" b="1">
+                <a:solidFill>
+                  <a:srgbClr val="005EB8"/>
                 </a:solidFill>
                 <a:latin typeface="Arial"/>
               </a:rPr>
-              <a:t>GitHub
-Actions</a:t>
-            </a:r>
-          </a:p>
-        </p:txBody>
-      </p:sp>
-      <p:sp>
-        <p:nvSpPr>
-          <p:cNvPr id="6" name="Right Arrow 5"/>
+              <a:t>Owner: Ajay Kumar | Email: helloajay21@gmail.com | Batch 1</a:t>
+            </a:r>
+          </a:p>
+        </p:txBody>
+      </p:sp>
+      <p:sp>
+        <p:nvSpPr>
+          <p:cNvPr id="8" name="TextBox 7"/>
+          <p:cNvSpPr txBox="1"/>
+          <p:nvPr/>
+        </p:nvSpPr>
+        <p:spPr>
+          <a:xfrm>
+            <a:off x="182880" y="6473952"/>
+            <a:ext cx="11795760" cy="256032"/>
+          </a:xfrm>
+          <a:prstGeom prst="rect">
+            <a:avLst/>
+          </a:prstGeom>
+          <a:noFill/>
+        </p:spPr>
+        <p:txBody>
+          <a:bodyPr wrap="none">
+            <a:spAutoFit/>
+          </a:bodyPr>
+          <a:lstStyle/>
+          <a:p>
+            <a:pPr algn="ctr"/>
+            <a:r>
+              <a:rPr sz="900" b="1">
+                <a:solidFill>
+                  <a:srgbClr val="475569"/>
+                </a:solidFill>
+                <a:latin typeface="Arial"/>
+              </a:rPr>
+              <a:t>Owner: Ajay Kumar | Email: helloajay21@gmail.com | Batch 1 | Project: AI Operations Assistant Using Agentic AI | GitHub: https://github.com/helloajay21-max/-it-support-assistant | Azure: https://it-support-ajay-001.azurewebsites.net/</a:t>
+            </a:r>
+          </a:p>
+        </p:txBody>
+      </p:sp>
+    </p:spTree>
+  </p:cSld>
+  <p:clrMapOvr>
+    <a:masterClrMapping/>
+  </p:clrMapOvr>
+</p:sld>
+</file>
+
+<file path=ppt/slides/slide2.xml><?xml version="1.0" encoding="utf-8"?>
+<p:sld xmlns:a="http://schemas.openxmlformats.org/drawingml/2006/main" xmlns:p="http://schemas.openxmlformats.org/presentationml/2006/main" xmlns:r="http://schemas.openxmlformats.org/officeDocument/2006/relationships">
+  <p:cSld>
+    <p:bg>
+      <p:bgPr>
+        <a:solidFill>
+          <a:srgbClr val="FFFFFF"/>
+        </a:solidFill>
+        <a:effectLst/>
+      </p:bgPr>
+    </p:bg>
+    <p:spTree>
+      <p:nvGrpSpPr>
+        <p:cNvPr id="1" name=""/>
+        <p:cNvGrpSpPr/>
+        <p:nvPr/>
+      </p:nvGrpSpPr>
+      <p:grpSpPr/>
+      <p:sp>
+        <p:nvSpPr>
+          <p:cNvPr id="2" name="TextBox 1"/>
+          <p:cNvSpPr txBox="1"/>
+          <p:nvPr/>
+        </p:nvSpPr>
+        <p:spPr>
+          <a:xfrm>
+            <a:off x="548640" y="228600"/>
+            <a:ext cx="8229600" cy="640080"/>
+          </a:xfrm>
+          <a:prstGeom prst="rect">
+            <a:avLst/>
+          </a:prstGeom>
+          <a:noFill/>
+        </p:spPr>
+        <p:txBody>
+          <a:bodyPr wrap="none">
+            <a:spAutoFit/>
+          </a:bodyPr>
+          <a:lstStyle/>
+          <a:p>
+            <a:pPr algn="l"/>
+            <a:r>
+              <a:rPr sz="2400" b="1">
+                <a:solidFill>
+                  <a:srgbClr val="0F172A"/>
+                </a:solidFill>
+                <a:latin typeface="Arial"/>
+              </a:rPr>
+              <a:t>Business Problem &amp; Solution</a:t>
+            </a:r>
+          </a:p>
+        </p:txBody>
+      </p:sp>
+      <p:sp>
+        <p:nvSpPr>
+          <p:cNvPr id="3" name="Rectangle 2"/>
           <p:cNvSpPr/>
           <p:nvPr/>
         </p:nvSpPr>
         <p:spPr>
           <a:xfrm>
-            <a:off x="3749039" y="2852927"/>
-            <a:ext cx="548640" cy="201168"/>
-          </a:xfrm>
-          <a:prstGeom prst="rightArrow">
+            <a:off x="548640" y="868680"/>
+            <a:ext cx="1828800" cy="73152"/>
+          </a:xfrm>
+          <a:prstGeom prst="rect">
             <a:avLst/>
           </a:prstGeom>
           <a:solidFill>
-            <a:srgbClr val="475569"/>
+            <a:srgbClr val="005EB8"/>
           </a:solidFill>
           <a:ln>
             <a:noFill/>
@@ -4485,25 +3509,180 @@
       </p:sp>
       <p:sp>
         <p:nvSpPr>
-          <p:cNvPr id="7" name="Rounded Rectangle 6"/>
+          <p:cNvPr id="4" name="TextBox 3"/>
+          <p:cNvSpPr txBox="1"/>
+          <p:nvPr/>
+        </p:nvSpPr>
+        <p:spPr>
+          <a:xfrm>
+            <a:off x="731520" y="1371600"/>
+            <a:ext cx="10789920" cy="4206240"/>
+          </a:xfrm>
+          <a:prstGeom prst="rect">
+            <a:avLst/>
+          </a:prstGeom>
+          <a:noFill/>
+        </p:spPr>
+        <p:txBody>
+          <a:bodyPr wrap="square">
+            <a:spAutoFit/>
+          </a:bodyPr>
+          <a:lstStyle/>
+          <a:p>
+            <a:pPr algn="just">
+              <a:lnSpc>
+                <a:spcPct val="115000"/>
+              </a:lnSpc>
+              <a:spcAft>
+                <a:spcPts val="600"/>
+              </a:spcAft>
+            </a:pPr>
+            <a:r>
+              <a:rPr sz="2000">
+                <a:solidFill>
+                  <a:srgbClr val="0F172A"/>
+                </a:solidFill>
+                <a:latin typeface="Arial"/>
+              </a:rPr>
+              <a:t>IT support users often need answers, ticket status, ticket creation, and employee-related actions across multiple workflows. Manual navigation and repeated requests increase effort, delay resolution, and reduce productivity.</a:t>
+            </a:r>
+          </a:p>
+          <a:p>
+            <a:pPr algn="just">
+              <a:lnSpc>
+                <a:spcPct val="115000"/>
+              </a:lnSpc>
+              <a:spcAft>
+                <a:spcPts val="600"/>
+              </a:spcAft>
+            </a:pPr>
+            <a:r>
+              <a:rPr sz="2000">
+                <a:solidFill>
+                  <a:srgbClr val="0F172A"/>
+                </a:solidFill>
+                <a:latin typeface="Arial"/>
+              </a:rPr>
+              <a:t>The proposed solution transforms repetitive support activities into an intelligent conversational workflow driven by an agentic AI assistant that understands user intent, maintains conversational state, routes requests to the correct tools, and performs the right operational actions securely.</a:t>
+            </a:r>
+          </a:p>
+        </p:txBody>
+      </p:sp>
+      <p:sp>
+        <p:nvSpPr>
+          <p:cNvPr id="5" name="TextBox 4"/>
+          <p:cNvSpPr txBox="1"/>
+          <p:nvPr/>
+        </p:nvSpPr>
+        <p:spPr>
+          <a:xfrm>
+            <a:off x="164592" y="6473952"/>
+            <a:ext cx="11795760" cy="256032"/>
+          </a:xfrm>
+          <a:prstGeom prst="rect">
+            <a:avLst/>
+          </a:prstGeom>
+          <a:noFill/>
+        </p:spPr>
+        <p:txBody>
+          <a:bodyPr wrap="none">
+            <a:spAutoFit/>
+          </a:bodyPr>
+          <a:lstStyle/>
+          <a:p>
+            <a:pPr algn="ctr"/>
+            <a:r>
+              <a:rPr sz="900" b="1">
+                <a:solidFill>
+                  <a:srgbClr val="475569"/>
+                </a:solidFill>
+                <a:latin typeface="Arial"/>
+              </a:rPr>
+              <a:t>Owner: Ajay Kumar | Email: helloajay21@gmail.com | Batch 1 | Project: AI Operations Assistant Using Agentic AI | GitHub: https://github.com/helloajay21-max/-it-support-assistant | Azure: https://it-support-ajay-001.azurewebsites.net/</a:t>
+            </a:r>
+          </a:p>
+        </p:txBody>
+      </p:sp>
+    </p:spTree>
+  </p:cSld>
+  <p:clrMapOvr>
+    <a:masterClrMapping/>
+  </p:clrMapOvr>
+</p:sld>
+</file>
+
+<file path=ppt/slides/slide3.xml><?xml version="1.0" encoding="utf-8"?>
+<p:sld xmlns:a="http://schemas.openxmlformats.org/drawingml/2006/main" xmlns:p="http://schemas.openxmlformats.org/presentationml/2006/main" xmlns:r="http://schemas.openxmlformats.org/officeDocument/2006/relationships">
+  <p:cSld>
+    <p:bg>
+      <p:bgPr>
+        <a:solidFill>
+          <a:srgbClr val="FFFFFF"/>
+        </a:solidFill>
+        <a:effectLst/>
+      </p:bgPr>
+    </p:bg>
+    <p:spTree>
+      <p:nvGrpSpPr>
+        <p:cNvPr id="1" name=""/>
+        <p:cNvGrpSpPr/>
+        <p:nvPr/>
+      </p:nvGrpSpPr>
+      <p:grpSpPr/>
+      <p:sp>
+        <p:nvSpPr>
+          <p:cNvPr id="2" name="TextBox 1"/>
+          <p:cNvSpPr txBox="1"/>
+          <p:nvPr/>
+        </p:nvSpPr>
+        <p:spPr>
+          <a:xfrm>
+            <a:off x="548640" y="228600"/>
+            <a:ext cx="8229600" cy="640080"/>
+          </a:xfrm>
+          <a:prstGeom prst="rect">
+            <a:avLst/>
+          </a:prstGeom>
+          <a:noFill/>
+        </p:spPr>
+        <p:txBody>
+          <a:bodyPr wrap="none">
+            <a:spAutoFit/>
+          </a:bodyPr>
+          <a:lstStyle/>
+          <a:p>
+            <a:pPr algn="l"/>
+            <a:r>
+              <a:rPr sz="2400" b="1">
+                <a:solidFill>
+                  <a:srgbClr val="0F172A"/>
+                </a:solidFill>
+                <a:latin typeface="Arial"/>
+              </a:rPr>
+              <a:t>Agentic AI Solution Architecture</a:t>
+            </a:r>
+          </a:p>
+        </p:txBody>
+      </p:sp>
+      <p:sp>
+        <p:nvSpPr>
+          <p:cNvPr id="3" name="Rectangle 2"/>
           <p:cNvSpPr/>
           <p:nvPr/>
         </p:nvSpPr>
         <p:spPr>
           <a:xfrm>
-            <a:off x="4206240" y="2560320"/>
-            <a:ext cx="1280160" cy="822960"/>
-          </a:xfrm>
-          <a:prstGeom prst="roundRect">
+            <a:off x="548640" y="868680"/>
+            <a:ext cx="1828800" cy="73152"/>
+          </a:xfrm>
+          <a:prstGeom prst="rect">
             <a:avLst/>
           </a:prstGeom>
           <a:solidFill>
-            <a:srgbClr val="0EA5E9"/>
+            <a:srgbClr val="005EB8"/>
           </a:solidFill>
           <a:ln>
-            <a:solidFill>
-              <a:srgbClr val="005EB8"/>
-            </a:solidFill>
+            <a:noFill/>
           </a:ln>
         </p:spPr>
         <p:style>
@@ -4525,38 +3704,30 @@
           <a:lstStyle/>
           <a:p>
             <a:pPr algn="ctr"/>
-            <a:r>
-              <a:rPr sz="1200" b="1">
-                <a:solidFill>
-                  <a:srgbClr val="FFFFFF"/>
-                </a:solidFill>
-                <a:latin typeface="Arial"/>
-              </a:rPr>
-              <a:t>Docker
-Hub</a:t>
-            </a:r>
-          </a:p>
-        </p:txBody>
-      </p:sp>
-      <p:sp>
-        <p:nvSpPr>
-          <p:cNvPr id="8" name="Right Arrow 7"/>
+          </a:p>
+        </p:txBody>
+      </p:sp>
+      <p:sp>
+        <p:nvSpPr>
+          <p:cNvPr id="4" name="Rounded Rectangle 3"/>
           <p:cNvSpPr/>
           <p:nvPr/>
         </p:nvSpPr>
         <p:spPr>
           <a:xfrm>
-            <a:off x="5486400" y="2852927"/>
-            <a:ext cx="548640" cy="201168"/>
-          </a:xfrm>
-          <a:prstGeom prst="rightArrow">
+            <a:off x="731520" y="2560320"/>
+            <a:ext cx="1371600" cy="822960"/>
+          </a:xfrm>
+          <a:prstGeom prst="roundRect">
             <a:avLst/>
           </a:prstGeom>
           <a:solidFill>
-            <a:srgbClr val="475569"/>
+            <a:srgbClr val="005EB8"/>
           </a:solidFill>
           <a:ln>
-            <a:noFill/>
+            <a:solidFill>
+              <a:srgbClr val="005EB8"/>
+            </a:solidFill>
           </a:ln>
         </p:spPr>
         <p:style>
@@ -4578,30 +3749,37 @@
           <a:lstStyle/>
           <a:p>
             <a:pPr algn="ctr"/>
-          </a:p>
-        </p:txBody>
-      </p:sp>
-      <p:sp>
-        <p:nvSpPr>
-          <p:cNvPr id="9" name="Rounded Rectangle 8"/>
+            <a:r>
+              <a:rPr sz="1100" b="1">
+                <a:solidFill>
+                  <a:srgbClr val="FFFFFF"/>
+                </a:solidFill>
+                <a:latin typeface="Arial"/>
+              </a:rPr>
+              <a:t>Streamlit UI</a:t>
+            </a:r>
+          </a:p>
+        </p:txBody>
+      </p:sp>
+      <p:sp>
+        <p:nvSpPr>
+          <p:cNvPr id="5" name="Right Arrow 4"/>
           <p:cNvSpPr/>
           <p:nvPr/>
         </p:nvSpPr>
         <p:spPr>
           <a:xfrm>
-            <a:off x="5943600" y="2560320"/>
-            <a:ext cx="1280160" cy="822960"/>
-          </a:xfrm>
-          <a:prstGeom prst="roundRect">
+            <a:off x="2103120" y="2880360"/>
+            <a:ext cx="457200" cy="182880"/>
+          </a:xfrm>
+          <a:prstGeom prst="rightArrow">
             <a:avLst/>
           </a:prstGeom>
           <a:solidFill>
-            <a:srgbClr val="0EA5E9"/>
+            <a:srgbClr val="475569"/>
           </a:solidFill>
           <a:ln>
-            <a:solidFill>
-              <a:srgbClr val="005EB8"/>
-            </a:solidFill>
+            <a:noFill/>
           </a:ln>
         </p:spPr>
         <p:style>
@@ -4623,38 +3801,30 @@
           <a:lstStyle/>
           <a:p>
             <a:pPr algn="ctr"/>
-            <a:r>
-              <a:rPr sz="1200" b="1">
-                <a:solidFill>
-                  <a:srgbClr val="FFFFFF"/>
-                </a:solidFill>
-                <a:latin typeface="Arial"/>
-              </a:rPr>
-              <a:t>Azure
-App Service</a:t>
-            </a:r>
-          </a:p>
-        </p:txBody>
-      </p:sp>
-      <p:sp>
-        <p:nvSpPr>
-          <p:cNvPr id="10" name="Right Arrow 9"/>
+          </a:p>
+        </p:txBody>
+      </p:sp>
+      <p:sp>
+        <p:nvSpPr>
+          <p:cNvPr id="6" name="Rounded Rectangle 5"/>
           <p:cNvSpPr/>
           <p:nvPr/>
         </p:nvSpPr>
         <p:spPr>
           <a:xfrm>
-            <a:off x="7223760" y="2852927"/>
-            <a:ext cx="548640" cy="201168"/>
-          </a:xfrm>
-          <a:prstGeom prst="rightArrow">
+            <a:off x="2468880" y="2560320"/>
+            <a:ext cx="1554480" cy="822960"/>
+          </a:xfrm>
+          <a:prstGeom prst="roundRect">
             <a:avLst/>
           </a:prstGeom>
           <a:solidFill>
-            <a:srgbClr val="475569"/>
+            <a:srgbClr val="005EB8"/>
           </a:solidFill>
           <a:ln>
-            <a:noFill/>
+            <a:solidFill>
+              <a:srgbClr val="005EB8"/>
+            </a:solidFill>
           </a:ln>
         </p:spPr>
         <p:style>
@@ -4676,30 +3846,37 @@
           <a:lstStyle/>
           <a:p>
             <a:pPr algn="ctr"/>
-          </a:p>
-        </p:txBody>
-      </p:sp>
-      <p:sp>
-        <p:nvSpPr>
-          <p:cNvPr id="11" name="Rounded Rectangle 10"/>
+            <a:r>
+              <a:rPr sz="1100" b="1">
+                <a:solidFill>
+                  <a:srgbClr val="FFFFFF"/>
+                </a:solidFill>
+                <a:latin typeface="Arial"/>
+              </a:rPr>
+              <a:t>Intent + State</a:t>
+            </a:r>
+          </a:p>
+        </p:txBody>
+      </p:sp>
+      <p:sp>
+        <p:nvSpPr>
+          <p:cNvPr id="7" name="Right Arrow 6"/>
           <p:cNvSpPr/>
           <p:nvPr/>
         </p:nvSpPr>
         <p:spPr>
           <a:xfrm>
-            <a:off x="7680960" y="2560320"/>
-            <a:ext cx="1280160" cy="822960"/>
-          </a:xfrm>
-          <a:prstGeom prst="roundRect">
+            <a:off x="4023360" y="2880360"/>
+            <a:ext cx="457200" cy="182880"/>
+          </a:xfrm>
+          <a:prstGeom prst="rightArrow">
             <a:avLst/>
           </a:prstGeom>
           <a:solidFill>
-            <a:srgbClr val="0EA5E9"/>
+            <a:srgbClr val="475569"/>
           </a:solidFill>
           <a:ln>
-            <a:solidFill>
-              <a:srgbClr val="005EB8"/>
-            </a:solidFill>
+            <a:noFill/>
           </a:ln>
         </p:spPr>
         <p:style>
@@ -4721,38 +3898,30 @@
           <a:lstStyle/>
           <a:p>
             <a:pPr algn="ctr"/>
-            <a:r>
-              <a:rPr sz="1200" b="1">
-                <a:solidFill>
-                  <a:srgbClr val="FFFFFF"/>
-                </a:solidFill>
-                <a:latin typeface="Arial"/>
-              </a:rPr>
-              <a:t>Streamlit
-UI</a:t>
-            </a:r>
-          </a:p>
-        </p:txBody>
-      </p:sp>
-      <p:sp>
-        <p:nvSpPr>
-          <p:cNvPr id="12" name="Right Arrow 11"/>
+          </a:p>
+        </p:txBody>
+      </p:sp>
+      <p:sp>
+        <p:nvSpPr>
+          <p:cNvPr id="8" name="Rounded Rectangle 7"/>
           <p:cNvSpPr/>
           <p:nvPr/>
         </p:nvSpPr>
         <p:spPr>
           <a:xfrm>
-            <a:off x="8961120" y="2852927"/>
-            <a:ext cx="548640" cy="201168"/>
-          </a:xfrm>
-          <a:prstGeom prst="rightArrow">
+            <a:off x="4389120" y="2560320"/>
+            <a:ext cx="1645920" cy="822960"/>
+          </a:xfrm>
+          <a:prstGeom prst="roundRect">
             <a:avLst/>
           </a:prstGeom>
           <a:solidFill>
-            <a:srgbClr val="475569"/>
+            <a:srgbClr val="005EB8"/>
           </a:solidFill>
           <a:ln>
-            <a:noFill/>
+            <a:solidFill>
+              <a:srgbClr val="005EB8"/>
+            </a:solidFill>
           </a:ln>
         </p:spPr>
         <p:style>
@@ -4774,30 +3943,37 @@
           <a:lstStyle/>
           <a:p>
             <a:pPr algn="ctr"/>
-          </a:p>
-        </p:txBody>
-      </p:sp>
-      <p:sp>
-        <p:nvSpPr>
-          <p:cNvPr id="13" name="Rounded Rectangle 12"/>
+            <a:r>
+              <a:rPr sz="1100" b="1">
+                <a:solidFill>
+                  <a:srgbClr val="FFFFFF"/>
+                </a:solidFill>
+                <a:latin typeface="Arial"/>
+              </a:rPr>
+              <a:t>LangGraph Router</a:t>
+            </a:r>
+          </a:p>
+        </p:txBody>
+      </p:sp>
+      <p:sp>
+        <p:nvSpPr>
+          <p:cNvPr id="9" name="Right Arrow 8"/>
           <p:cNvSpPr/>
           <p:nvPr/>
         </p:nvSpPr>
         <p:spPr>
           <a:xfrm>
-            <a:off x="9601200" y="2560320"/>
-            <a:ext cx="1280160" cy="822960"/>
-          </a:xfrm>
-          <a:prstGeom prst="roundRect">
+            <a:off x="6035040" y="2880360"/>
+            <a:ext cx="457200" cy="182880"/>
+          </a:xfrm>
+          <a:prstGeom prst="rightArrow">
             <a:avLst/>
           </a:prstGeom>
           <a:solidFill>
-            <a:srgbClr val="0EA5E9"/>
+            <a:srgbClr val="475569"/>
           </a:solidFill>
           <a:ln>
-            <a:solidFill>
-              <a:srgbClr val="005EB8"/>
-            </a:solidFill>
+            <a:noFill/>
           </a:ln>
         </p:spPr>
         <p:style>
@@ -4819,39 +3995,29 @@
           <a:lstStyle/>
           <a:p>
             <a:pPr algn="ctr"/>
-            <a:r>
-              <a:rPr sz="1200" b="1">
-                <a:solidFill>
-                  <a:srgbClr val="FFFFFF"/>
-                </a:solidFill>
-                <a:latin typeface="Arial"/>
-              </a:rPr>
-              <a:t>SQLite
-DB</a:t>
-            </a:r>
-          </a:p>
-        </p:txBody>
-      </p:sp>
-      <p:sp>
-        <p:nvSpPr>
-          <p:cNvPr id="14" name="Rounded Rectangle 13"/>
+          </a:p>
+        </p:txBody>
+      </p:sp>
+      <p:sp>
+        <p:nvSpPr>
+          <p:cNvPr id="10" name="Rounded Rectangle 9"/>
           <p:cNvSpPr/>
           <p:nvPr/>
         </p:nvSpPr>
         <p:spPr>
           <a:xfrm>
-            <a:off x="2743200" y="4297680"/>
-            <a:ext cx="2011680" cy="822960"/>
+            <a:off x="6309360" y="2560320"/>
+            <a:ext cx="1645920" cy="822960"/>
           </a:xfrm>
           <a:prstGeom prst="roundRect">
             <a:avLst/>
           </a:prstGeom>
           <a:solidFill>
-            <a:srgbClr val="F1F5F9"/>
+            <a:srgbClr val="005EB8"/>
           </a:solidFill>
           <a:ln>
             <a:solidFill>
-              <a:srgbClr val="475569"/>
+              <a:srgbClr val="005EB8"/>
             </a:solidFill>
           </a:ln>
         </p:spPr>
@@ -4873,37 +4039,126 @@
           <a:bodyPr rtlCol="0" anchor="ctr"/>
           <a:lstStyle/>
           <a:p>
-            <a:pPr algn="ctr">
-              <a:defRPr sz="1200" b="1">
+            <a:pPr algn="ctr"/>
+            <a:r>
+              <a:rPr sz="1100" b="1">
+                <a:solidFill>
+                  <a:srgbClr val="FFFFFF"/>
+                </a:solidFill>
                 <a:latin typeface="Arial"/>
-              </a:defRPr>
-            </a:pPr>
-            <a:r>
-              <a:t>Users</a:t>
-            </a:r>
-          </a:p>
-          <a:p>
-            <a:pPr algn="ctr">
-              <a:defRPr sz="1200" b="1">
+              </a:rPr>
+              <a:t>MCP / Tool Layer</a:t>
+            </a:r>
+          </a:p>
+        </p:txBody>
+      </p:sp>
+      <p:sp>
+        <p:nvSpPr>
+          <p:cNvPr id="11" name="Right Arrow 10"/>
+          <p:cNvSpPr/>
+          <p:nvPr/>
+        </p:nvSpPr>
+        <p:spPr>
+          <a:xfrm>
+            <a:off x="7955280" y="2880360"/>
+            <a:ext cx="457200" cy="182880"/>
+          </a:xfrm>
+          <a:prstGeom prst="rightArrow">
+            <a:avLst/>
+          </a:prstGeom>
+          <a:solidFill>
+            <a:srgbClr val="475569"/>
+          </a:solidFill>
+          <a:ln>
+            <a:noFill/>
+          </a:ln>
+        </p:spPr>
+        <p:style>
+          <a:lnRef idx="1">
+            <a:schemeClr val="accent1"/>
+          </a:lnRef>
+          <a:fillRef idx="3">
+            <a:schemeClr val="accent1"/>
+          </a:fillRef>
+          <a:effectRef idx="2">
+            <a:schemeClr val="accent1"/>
+          </a:effectRef>
+          <a:fontRef idx="minor">
+            <a:schemeClr val="lt1"/>
+          </a:fontRef>
+        </p:style>
+        <p:txBody>
+          <a:bodyPr rtlCol="0" anchor="ctr"/>
+          <a:lstStyle/>
+          <a:p>
+            <a:pPr algn="ctr"/>
+          </a:p>
+        </p:txBody>
+      </p:sp>
+      <p:sp>
+        <p:nvSpPr>
+          <p:cNvPr id="12" name="Rounded Rectangle 11"/>
+          <p:cNvSpPr/>
+          <p:nvPr/>
+        </p:nvSpPr>
+        <p:spPr>
+          <a:xfrm>
+            <a:off x="8229600" y="2560320"/>
+            <a:ext cx="1828800" cy="822960"/>
+          </a:xfrm>
+          <a:prstGeom prst="roundRect">
+            <a:avLst/>
+          </a:prstGeom>
+          <a:solidFill>
+            <a:srgbClr val="005EB8"/>
+          </a:solidFill>
+          <a:ln>
+            <a:solidFill>
+              <a:srgbClr val="005EB8"/>
+            </a:solidFill>
+          </a:ln>
+        </p:spPr>
+        <p:style>
+          <a:lnRef idx="1">
+            <a:schemeClr val="accent1"/>
+          </a:lnRef>
+          <a:fillRef idx="3">
+            <a:schemeClr val="accent1"/>
+          </a:fillRef>
+          <a:effectRef idx="2">
+            <a:schemeClr val="accent1"/>
+          </a:effectRef>
+          <a:fontRef idx="minor">
+            <a:schemeClr val="lt1"/>
+          </a:fontRef>
+        </p:style>
+        <p:txBody>
+          <a:bodyPr rtlCol="0" anchor="ctr"/>
+          <a:lstStyle/>
+          <a:p>
+            <a:pPr algn="ctr"/>
+            <a:r>
+              <a:rPr sz="1100" b="1">
+                <a:solidFill>
+                  <a:srgbClr val="FFFFFF"/>
+                </a:solidFill>
                 <a:latin typeface="Arial"/>
-              </a:defRPr>
-            </a:pPr>
-            <a:r>
-              <a:t>Admin / Employees</a:t>
-            </a:r>
-          </a:p>
-        </p:txBody>
-      </p:sp>
-      <p:sp>
-        <p:nvSpPr>
-          <p:cNvPr id="15" name="TextBox 14"/>
+              </a:rPr>
+              <a:t>Operational Systems</a:t>
+            </a:r>
+          </a:p>
+        </p:txBody>
+      </p:sp>
+      <p:sp>
+        <p:nvSpPr>
+          <p:cNvPr id="13" name="TextBox 12"/>
           <p:cNvSpPr txBox="1"/>
           <p:nvPr/>
         </p:nvSpPr>
         <p:spPr>
           <a:xfrm>
-            <a:off x="640080" y="914400"/>
-            <a:ext cx="10972800" cy="457200"/>
+            <a:off x="731520" y="3931920"/>
+            <a:ext cx="10698480" cy="1828800"/>
           </a:xfrm>
           <a:prstGeom prst="rect">
             <a:avLst/>
@@ -4916,30 +4171,93 @@
           </a:bodyPr>
           <a:lstStyle/>
           <a:p>
-            <a:pPr algn="ctr">
-              <a:defRPr sz="1200">
-                <a:solidFill>
-                  <a:srgbClr val="475569"/>
+            <a:pPr algn="just">
+              <a:lnSpc>
+                <a:spcPct val="115000"/>
+              </a:lnSpc>
+              <a:spcAft>
+                <a:spcPts val="600"/>
+              </a:spcAft>
+            </a:pPr>
+            <a:r>
+              <a:rPr sz="1700">
+                <a:solidFill>
+                  <a:srgbClr val="0F172A"/>
                 </a:solidFill>
                 <a:latin typeface="Arial"/>
-              </a:defRPr>
+              </a:rPr>
+              <a:t>Understand: Natural-language intent and request context</a:t>
+            </a:r>
+          </a:p>
+          <a:p>
+            <a:pPr algn="just">
+              <a:lnSpc>
+                <a:spcPct val="115000"/>
+              </a:lnSpc>
+              <a:spcAft>
+                <a:spcPts val="600"/>
+              </a:spcAft>
             </a:pPr>
             <a:r>
-              <a:t>GitHub → Actions → Docker → Azure App Service → Streamlit App → SQLite DB → Users</a:t>
-            </a:r>
-          </a:p>
-        </p:txBody>
-      </p:sp>
-      <p:sp>
-        <p:nvSpPr>
-          <p:cNvPr id="16" name="TextBox 15"/>
+              <a:rPr sz="1700">
+                <a:solidFill>
+                  <a:srgbClr val="0F172A"/>
+                </a:solidFill>
+                <a:latin typeface="Arial"/>
+              </a:rPr>
+              <a:t>Orchestrate: LangGraph reasoning, state management, and conditional routing</a:t>
+            </a:r>
+          </a:p>
+          <a:p>
+            <a:pPr algn="just">
+              <a:lnSpc>
+                <a:spcPct val="115000"/>
+              </a:lnSpc>
+              <a:spcAft>
+                <a:spcPts val="600"/>
+              </a:spcAft>
+            </a:pPr>
+            <a:r>
+              <a:rPr sz="1600">
+                <a:solidFill>
+                  <a:srgbClr val="0F172A"/>
+                </a:solidFill>
+                <a:latin typeface="Arial"/>
+              </a:rPr>
+              <a:t>Act: Knowledge lookup, ticket operations, employee actions, VPN requests, and email dispatch</a:t>
+            </a:r>
+          </a:p>
+          <a:p>
+            <a:pPr algn="just">
+              <a:lnSpc>
+                <a:spcPct val="115000"/>
+              </a:lnSpc>
+              <a:spcAft>
+                <a:spcPts val="600"/>
+              </a:spcAft>
+            </a:pPr>
+            <a:r>
+              <a:rPr sz="1600">
+                <a:solidFill>
+                  <a:srgbClr val="0F172A"/>
+                </a:solidFill>
+                <a:latin typeface="Arial"/>
+              </a:rPr>
+              <a:t>Result: Context-aware responses with workflow execution and secure validation</a:t>
+            </a:r>
+          </a:p>
+        </p:txBody>
+      </p:sp>
+      <p:sp>
+        <p:nvSpPr>
+          <p:cNvPr id="14" name="TextBox 13"/>
           <p:cNvSpPr txBox="1"/>
           <p:nvPr/>
         </p:nvSpPr>
         <p:spPr>
           <a:xfrm>
-            <a:off x="228600" y="6492240"/>
-            <a:ext cx="11704320" cy="228600"/>
+            <a:off x="164592" y="6473952"/>
+            <a:ext cx="11795760" cy="256032"/>
           </a:xfrm>
           <a:prstGeom prst="rect">
             <a:avLst/>
@@ -4952,8 +4270,848 @@
           </a:bodyPr>
           <a:lstStyle/>
           <a:p>
-            <a:r>
-              <a:rPr sz="800">
+            <a:pPr algn="ctr"/>
+            <a:r>
+              <a:rPr sz="900" b="1">
+                <a:solidFill>
+                  <a:srgbClr val="475569"/>
+                </a:solidFill>
+                <a:latin typeface="Arial"/>
+              </a:rPr>
+              <a:t>Owner: Ajay Kumar | Email: helloajay21@gmail.com | Batch 1 | Project: AI Operations Assistant Using Agentic AI | GitHub: https://github.com/helloajay21-max/-it-support-assistant | Azure: https://it-support-ajay-001.azurewebsites.net/</a:t>
+            </a:r>
+          </a:p>
+        </p:txBody>
+      </p:sp>
+    </p:spTree>
+  </p:cSld>
+  <p:clrMapOvr>
+    <a:masterClrMapping/>
+  </p:clrMapOvr>
+</p:sld>
+</file>
+
+<file path=ppt/slides/slide4.xml><?xml version="1.0" encoding="utf-8"?>
+<p:sld xmlns:a="http://schemas.openxmlformats.org/drawingml/2006/main" xmlns:p="http://schemas.openxmlformats.org/presentationml/2006/main" xmlns:r="http://schemas.openxmlformats.org/officeDocument/2006/relationships">
+  <p:cSld>
+    <p:bg>
+      <p:bgPr>
+        <a:solidFill>
+          <a:srgbClr val="FFFFFF"/>
+        </a:solidFill>
+        <a:effectLst/>
+      </p:bgPr>
+    </p:bg>
+    <p:spTree>
+      <p:nvGrpSpPr>
+        <p:cNvPr id="1" name=""/>
+        <p:cNvGrpSpPr/>
+        <p:nvPr/>
+      </p:nvGrpSpPr>
+      <p:grpSpPr/>
+      <p:sp>
+        <p:nvSpPr>
+          <p:cNvPr id="2" name="TextBox 1"/>
+          <p:cNvSpPr txBox="1"/>
+          <p:nvPr/>
+        </p:nvSpPr>
+        <p:spPr>
+          <a:xfrm>
+            <a:off x="548640" y="228600"/>
+            <a:ext cx="8229600" cy="640080"/>
+          </a:xfrm>
+          <a:prstGeom prst="rect">
+            <a:avLst/>
+          </a:prstGeom>
+          <a:noFill/>
+        </p:spPr>
+        <p:txBody>
+          <a:bodyPr wrap="none">
+            <a:spAutoFit/>
+          </a:bodyPr>
+          <a:lstStyle/>
+          <a:p>
+            <a:pPr algn="l"/>
+            <a:r>
+              <a:rPr sz="2400" b="1">
+                <a:solidFill>
+                  <a:srgbClr val="0F172A"/>
+                </a:solidFill>
+                <a:latin typeface="Arial"/>
+              </a:rPr>
+              <a:t>Core Capabilities</a:t>
+            </a:r>
+          </a:p>
+        </p:txBody>
+      </p:sp>
+      <p:sp>
+        <p:nvSpPr>
+          <p:cNvPr id="3" name="Rectangle 2"/>
+          <p:cNvSpPr/>
+          <p:nvPr/>
+        </p:nvSpPr>
+        <p:spPr>
+          <a:xfrm>
+            <a:off x="548640" y="868680"/>
+            <a:ext cx="1828800" cy="73152"/>
+          </a:xfrm>
+          <a:prstGeom prst="rect">
+            <a:avLst/>
+          </a:prstGeom>
+          <a:solidFill>
+            <a:srgbClr val="005EB8"/>
+          </a:solidFill>
+          <a:ln>
+            <a:noFill/>
+          </a:ln>
+        </p:spPr>
+        <p:style>
+          <a:lnRef idx="1">
+            <a:schemeClr val="accent1"/>
+          </a:lnRef>
+          <a:fillRef idx="3">
+            <a:schemeClr val="accent1"/>
+          </a:fillRef>
+          <a:effectRef idx="2">
+            <a:schemeClr val="accent1"/>
+          </a:effectRef>
+          <a:fontRef idx="minor">
+            <a:schemeClr val="lt1"/>
+          </a:fontRef>
+        </p:style>
+        <p:txBody>
+          <a:bodyPr rtlCol="0" anchor="ctr"/>
+          <a:lstStyle/>
+          <a:p>
+            <a:pPr algn="ctr"/>
+          </a:p>
+        </p:txBody>
+      </p:sp>
+      <p:sp>
+        <p:nvSpPr>
+          <p:cNvPr id="4" name="TextBox 3"/>
+          <p:cNvSpPr txBox="1"/>
+          <p:nvPr/>
+        </p:nvSpPr>
+        <p:spPr>
+          <a:xfrm>
+            <a:off x="640080" y="1371600"/>
+            <a:ext cx="5212080" cy="4389120"/>
+          </a:xfrm>
+          <a:prstGeom prst="rect">
+            <a:avLst/>
+          </a:prstGeom>
+          <a:noFill/>
+        </p:spPr>
+        <p:txBody>
+          <a:bodyPr wrap="square">
+            <a:spAutoFit/>
+          </a:bodyPr>
+          <a:lstStyle/>
+          <a:p>
+            <a:pPr algn="l">
+              <a:spcAft>
+                <a:spcPts val="600"/>
+              </a:spcAft>
+            </a:pPr>
+            <a:r>
+              <a:rPr sz="1800" b="1">
+                <a:solidFill>
+                  <a:srgbClr val="005EB8"/>
+                </a:solidFill>
+                <a:latin typeface="Arial"/>
+              </a:rPr>
+              <a:t>Operational Functions</a:t>
+            </a:r>
+          </a:p>
+          <a:p>
+            <a:pPr algn="just">
+              <a:lnSpc>
+                <a:spcPct val="112000"/>
+              </a:lnSpc>
+              <a:spcAft>
+                <a:spcPts val="600"/>
+              </a:spcAft>
+            </a:pPr>
+            <a:r>
+              <a:rPr sz="1500">
+                <a:solidFill>
+                  <a:srgbClr val="0F172A"/>
+                </a:solidFill>
+                <a:latin typeface="Arial"/>
+              </a:rPr>
+              <a:t>Knowledge search and IT guidance lookup</a:t>
+            </a:r>
+          </a:p>
+          <a:p>
+            <a:pPr algn="just">
+              <a:lnSpc>
+                <a:spcPct val="112000"/>
+              </a:lnSpc>
+              <a:spcAft>
+                <a:spcPts val="600"/>
+              </a:spcAft>
+            </a:pPr>
+            <a:r>
+              <a:rPr sz="1500">
+                <a:solidFill>
+                  <a:srgbClr val="0F172A"/>
+                </a:solidFill>
+                <a:latin typeface="Arial"/>
+              </a:rPr>
+              <a:t>Ticket lookup, creation, and status tracking</a:t>
+            </a:r>
+          </a:p>
+          <a:p>
+            <a:pPr algn="just">
+              <a:lnSpc>
+                <a:spcPct val="112000"/>
+              </a:lnSpc>
+              <a:spcAft>
+                <a:spcPts val="600"/>
+              </a:spcAft>
+            </a:pPr>
+            <a:r>
+              <a:rPr sz="1500">
+                <a:solidFill>
+                  <a:srgbClr val="0F172A"/>
+                </a:solidFill>
+                <a:latin typeface="Arial"/>
+              </a:rPr>
+              <a:t>Employee registration, identity validation, and DB persistence</a:t>
+            </a:r>
+          </a:p>
+          <a:p>
+            <a:pPr algn="just">
+              <a:lnSpc>
+                <a:spcPct val="112000"/>
+              </a:lnSpc>
+              <a:spcAft>
+                <a:spcPts val="600"/>
+              </a:spcAft>
+            </a:pPr>
+            <a:r>
+              <a:rPr sz="1500">
+                <a:solidFill>
+                  <a:srgbClr val="0F172A"/>
+                </a:solidFill>
+                <a:latin typeface="Arial"/>
+              </a:rPr>
+              <a:t>VPN first-time setup and password reset workflows</a:t>
+            </a:r>
+          </a:p>
+          <a:p>
+            <a:pPr algn="just">
+              <a:lnSpc>
+                <a:spcPct val="112000"/>
+              </a:lnSpc>
+              <a:spcAft>
+                <a:spcPts val="600"/>
+              </a:spcAft>
+            </a:pPr>
+            <a:r>
+              <a:rPr sz="1500">
+                <a:solidFill>
+                  <a:srgbClr val="0F172A"/>
+                </a:solidFill>
+                <a:latin typeface="Arial"/>
+              </a:rPr>
+              <a:t>Email dispatch for password and approval actions</a:t>
+            </a:r>
+          </a:p>
+        </p:txBody>
+      </p:sp>
+      <p:sp>
+        <p:nvSpPr>
+          <p:cNvPr id="5" name="TextBox 4"/>
+          <p:cNvSpPr txBox="1"/>
+          <p:nvPr/>
+        </p:nvSpPr>
+        <p:spPr>
+          <a:xfrm>
+            <a:off x="6217920" y="1371600"/>
+            <a:ext cx="5029200" cy="4389120"/>
+          </a:xfrm>
+          <a:prstGeom prst="rect">
+            <a:avLst/>
+          </a:prstGeom>
+          <a:noFill/>
+        </p:spPr>
+        <p:txBody>
+          <a:bodyPr wrap="square">
+            <a:spAutoFit/>
+          </a:bodyPr>
+          <a:lstStyle/>
+          <a:p>
+            <a:pPr algn="l">
+              <a:spcAft>
+                <a:spcPts val="600"/>
+              </a:spcAft>
+            </a:pPr>
+            <a:r>
+              <a:rPr sz="1800" b="1">
+                <a:solidFill>
+                  <a:srgbClr val="005EB8"/>
+                </a:solidFill>
+                <a:latin typeface="Arial"/>
+              </a:rPr>
+              <a:t>Security and Governance</a:t>
+            </a:r>
+          </a:p>
+          <a:p>
+            <a:pPr algn="just">
+              <a:lnSpc>
+                <a:spcPct val="112000"/>
+              </a:lnSpc>
+              <a:spcAft>
+                <a:spcPts val="600"/>
+              </a:spcAft>
+            </a:pPr>
+            <a:r>
+              <a:rPr sz="1500">
+                <a:solidFill>
+                  <a:srgbClr val="0F172A"/>
+                </a:solidFill>
+                <a:latin typeface="Arial"/>
+              </a:rPr>
+              <a:t>Secure login and sign-up with hashed passwords</a:t>
+            </a:r>
+          </a:p>
+          <a:p>
+            <a:pPr algn="just">
+              <a:lnSpc>
+                <a:spcPct val="112000"/>
+              </a:lnSpc>
+              <a:spcAft>
+                <a:spcPts val="600"/>
+              </a:spcAft>
+            </a:pPr>
+            <a:r>
+              <a:rPr sz="1500">
+                <a:solidFill>
+                  <a:srgbClr val="0F172A"/>
+                </a:solidFill>
+                <a:latin typeface="Arial"/>
+              </a:rPr>
+              <a:t>Admin-only approval and rejection control</a:t>
+            </a:r>
+          </a:p>
+          <a:p>
+            <a:pPr algn="just">
+              <a:lnSpc>
+                <a:spcPct val="112000"/>
+              </a:lnSpc>
+              <a:spcAft>
+                <a:spcPts val="600"/>
+              </a:spcAft>
+            </a:pPr>
+            <a:r>
+              <a:rPr sz="1500">
+                <a:solidFill>
+                  <a:srgbClr val="0F172A"/>
+                </a:solidFill>
+                <a:latin typeface="Arial"/>
+              </a:rPr>
+              <a:t>Protected admin profile and user-level access rules</a:t>
+            </a:r>
+          </a:p>
+          <a:p>
+            <a:pPr algn="just">
+              <a:lnSpc>
+                <a:spcPct val="112000"/>
+              </a:lnSpc>
+              <a:spcAft>
+                <a:spcPts val="600"/>
+              </a:spcAft>
+            </a:pPr>
+            <a:r>
+              <a:rPr sz="1500">
+                <a:solidFill>
+                  <a:srgbClr val="0F172A"/>
+                </a:solidFill>
+                <a:latin typeface="Arial"/>
+              </a:rPr>
+              <a:t>Password reset token handling with expiry and validation</a:t>
+            </a:r>
+          </a:p>
+          <a:p>
+            <a:pPr algn="just">
+              <a:lnSpc>
+                <a:spcPct val="112000"/>
+              </a:lnSpc>
+              <a:spcAft>
+                <a:spcPts val="600"/>
+              </a:spcAft>
+            </a:pPr>
+            <a:r>
+              <a:rPr sz="1500">
+                <a:solidFill>
+                  <a:srgbClr val="0F172A"/>
+                </a:solidFill>
+                <a:latin typeface="Arial"/>
+              </a:rPr>
+              <a:t>Safe DB initialization and production deployment hardening</a:t>
+            </a:r>
+          </a:p>
+        </p:txBody>
+      </p:sp>
+      <p:sp>
+        <p:nvSpPr>
+          <p:cNvPr id="6" name="TextBox 5"/>
+          <p:cNvSpPr txBox="1"/>
+          <p:nvPr/>
+        </p:nvSpPr>
+        <p:spPr>
+          <a:xfrm>
+            <a:off x="164592" y="6473952"/>
+            <a:ext cx="11795760" cy="256032"/>
+          </a:xfrm>
+          <a:prstGeom prst="rect">
+            <a:avLst/>
+          </a:prstGeom>
+          <a:noFill/>
+        </p:spPr>
+        <p:txBody>
+          <a:bodyPr wrap="none">
+            <a:spAutoFit/>
+          </a:bodyPr>
+          <a:lstStyle/>
+          <a:p>
+            <a:pPr algn="ctr"/>
+            <a:r>
+              <a:rPr sz="900" b="1">
+                <a:solidFill>
+                  <a:srgbClr val="475569"/>
+                </a:solidFill>
+                <a:latin typeface="Arial"/>
+              </a:rPr>
+              <a:t>Owner: Ajay Kumar | Email: helloajay21@gmail.com | Batch 1 | Project: AI Operations Assistant Using Agentic AI | GitHub: https://github.com/helloajay21-max/-it-support-assistant | Azure: https://it-support-ajay-001.azurewebsites.net/</a:t>
+            </a:r>
+          </a:p>
+        </p:txBody>
+      </p:sp>
+    </p:spTree>
+  </p:cSld>
+  <p:clrMapOvr>
+    <a:masterClrMapping/>
+  </p:clrMapOvr>
+</p:sld>
+</file>
+
+<file path=ppt/slides/slide5.xml><?xml version="1.0" encoding="utf-8"?>
+<p:sld xmlns:a="http://schemas.openxmlformats.org/drawingml/2006/main" xmlns:p="http://schemas.openxmlformats.org/presentationml/2006/main" xmlns:r="http://schemas.openxmlformats.org/officeDocument/2006/relationships">
+  <p:cSld>
+    <p:bg>
+      <p:bgPr>
+        <a:solidFill>
+          <a:srgbClr val="FFFFFF"/>
+        </a:solidFill>
+        <a:effectLst/>
+      </p:bgPr>
+    </p:bg>
+    <p:spTree>
+      <p:nvGrpSpPr>
+        <p:cNvPr id="1" name=""/>
+        <p:cNvGrpSpPr/>
+        <p:nvPr/>
+      </p:nvGrpSpPr>
+      <p:grpSpPr/>
+      <p:sp>
+        <p:nvSpPr>
+          <p:cNvPr id="2" name="TextBox 1"/>
+          <p:cNvSpPr txBox="1"/>
+          <p:nvPr/>
+        </p:nvSpPr>
+        <p:spPr>
+          <a:xfrm>
+            <a:off x="548640" y="228600"/>
+            <a:ext cx="8229600" cy="640080"/>
+          </a:xfrm>
+          <a:prstGeom prst="rect">
+            <a:avLst/>
+          </a:prstGeom>
+          <a:noFill/>
+        </p:spPr>
+        <p:txBody>
+          <a:bodyPr wrap="none">
+            <a:spAutoFit/>
+          </a:bodyPr>
+          <a:lstStyle/>
+          <a:p>
+            <a:pPr algn="l"/>
+            <a:r>
+              <a:rPr sz="2400" b="1">
+                <a:solidFill>
+                  <a:srgbClr val="0F172A"/>
+                </a:solidFill>
+                <a:latin typeface="Arial"/>
+              </a:rPr>
+              <a:t>Technology Stack</a:t>
+            </a:r>
+          </a:p>
+        </p:txBody>
+      </p:sp>
+      <p:sp>
+        <p:nvSpPr>
+          <p:cNvPr id="3" name="Rectangle 2"/>
+          <p:cNvSpPr/>
+          <p:nvPr/>
+        </p:nvSpPr>
+        <p:spPr>
+          <a:xfrm>
+            <a:off x="548640" y="868680"/>
+            <a:ext cx="1828800" cy="73152"/>
+          </a:xfrm>
+          <a:prstGeom prst="rect">
+            <a:avLst/>
+          </a:prstGeom>
+          <a:solidFill>
+            <a:srgbClr val="005EB8"/>
+          </a:solidFill>
+          <a:ln>
+            <a:noFill/>
+          </a:ln>
+        </p:spPr>
+        <p:style>
+          <a:lnRef idx="1">
+            <a:schemeClr val="accent1"/>
+          </a:lnRef>
+          <a:fillRef idx="3">
+            <a:schemeClr val="accent1"/>
+          </a:fillRef>
+          <a:effectRef idx="2">
+            <a:schemeClr val="accent1"/>
+          </a:effectRef>
+          <a:fontRef idx="minor">
+            <a:schemeClr val="lt1"/>
+          </a:fontRef>
+        </p:style>
+        <p:txBody>
+          <a:bodyPr rtlCol="0" anchor="ctr"/>
+          <a:lstStyle/>
+          <a:p>
+            <a:pPr algn="ctr"/>
+          </a:p>
+        </p:txBody>
+      </p:sp>
+      <p:sp>
+        <p:nvSpPr>
+          <p:cNvPr id="4" name="TextBox 3"/>
+          <p:cNvSpPr txBox="1"/>
+          <p:nvPr/>
+        </p:nvSpPr>
+        <p:spPr>
+          <a:xfrm>
+            <a:off x="731520" y="1463040"/>
+            <a:ext cx="5212080" cy="3840480"/>
+          </a:xfrm>
+          <a:prstGeom prst="rect">
+            <a:avLst/>
+          </a:prstGeom>
+          <a:noFill/>
+        </p:spPr>
+        <p:txBody>
+          <a:bodyPr wrap="none">
+            <a:spAutoFit/>
+          </a:bodyPr>
+          <a:lstStyle/>
+          <a:p>
+            <a:pPr algn="l">
+              <a:lnSpc>
+                <a:spcPct val="115000"/>
+              </a:lnSpc>
+              <a:spcAft>
+                <a:spcPts val="800"/>
+              </a:spcAft>
+            </a:pPr>
+            <a:r>
+              <a:rPr sz="1800">
+                <a:solidFill>
+                  <a:srgbClr val="0F172A"/>
+                </a:solidFill>
+                <a:latin typeface="Arial"/>
+              </a:rPr>
+              <a:t>Frontend / Experience: Streamlit</a:t>
+            </a:r>
+          </a:p>
+          <a:p>
+            <a:pPr algn="l">
+              <a:lnSpc>
+                <a:spcPct val="115000"/>
+              </a:lnSpc>
+              <a:spcAft>
+                <a:spcPts val="800"/>
+              </a:spcAft>
+            </a:pPr>
+            <a:r>
+              <a:rPr sz="1800">
+                <a:solidFill>
+                  <a:srgbClr val="0F172A"/>
+                </a:solidFill>
+                <a:latin typeface="Arial"/>
+              </a:rPr>
+              <a:t>Agent Orchestration: LangGraph, LangChain</a:t>
+            </a:r>
+          </a:p>
+          <a:p>
+            <a:pPr algn="l">
+              <a:lnSpc>
+                <a:spcPct val="115000"/>
+              </a:lnSpc>
+              <a:spcAft>
+                <a:spcPts val="800"/>
+              </a:spcAft>
+            </a:pPr>
+            <a:r>
+              <a:rPr sz="1800">
+                <a:solidFill>
+                  <a:srgbClr val="0F172A"/>
+                </a:solidFill>
+                <a:latin typeface="Arial"/>
+              </a:rPr>
+              <a:t>Tool Integration: MCP / Tool layer</a:t>
+            </a:r>
+          </a:p>
+          <a:p>
+            <a:pPr algn="l">
+              <a:lnSpc>
+                <a:spcPct val="115000"/>
+              </a:lnSpc>
+              <a:spcAft>
+                <a:spcPts val="800"/>
+              </a:spcAft>
+            </a:pPr>
+            <a:r>
+              <a:rPr sz="1800">
+                <a:solidFill>
+                  <a:srgbClr val="0F172A"/>
+                </a:solidFill>
+                <a:latin typeface="Arial"/>
+              </a:rPr>
+              <a:t>AI Model Layer: Azure OpenAI</a:t>
+            </a:r>
+          </a:p>
+          <a:p>
+            <a:pPr algn="l">
+              <a:lnSpc>
+                <a:spcPct val="115000"/>
+              </a:lnSpc>
+              <a:spcAft>
+                <a:spcPts val="800"/>
+              </a:spcAft>
+            </a:pPr>
+            <a:r>
+              <a:rPr sz="1800">
+                <a:solidFill>
+                  <a:srgbClr val="0F172A"/>
+                </a:solidFill>
+                <a:latin typeface="Arial"/>
+              </a:rPr>
+              <a:t>Application Runtime: Python</a:t>
+            </a:r>
+          </a:p>
+          <a:p>
+            <a:pPr algn="l">
+              <a:lnSpc>
+                <a:spcPct val="115000"/>
+              </a:lnSpc>
+              <a:spcAft>
+                <a:spcPts val="800"/>
+              </a:spcAft>
+            </a:pPr>
+            <a:r>
+              <a:rPr sz="1800">
+                <a:solidFill>
+                  <a:srgbClr val="0F172A"/>
+                </a:solidFill>
+                <a:latin typeface="Arial"/>
+              </a:rPr>
+              <a:t>Database: SQLite</a:t>
+            </a:r>
+          </a:p>
+          <a:p>
+            <a:pPr algn="l">
+              <a:lnSpc>
+                <a:spcPct val="115000"/>
+              </a:lnSpc>
+              <a:spcAft>
+                <a:spcPts val="800"/>
+              </a:spcAft>
+            </a:pPr>
+            <a:r>
+              <a:rPr sz="1800">
+                <a:solidFill>
+                  <a:srgbClr val="0F172A"/>
+                </a:solidFill>
+                <a:latin typeface="Arial"/>
+              </a:rPr>
+              <a:t>Email &amp; Notifications: SMTP / Email service</a:t>
+            </a:r>
+          </a:p>
+        </p:txBody>
+      </p:sp>
+      <p:sp>
+        <p:nvSpPr>
+          <p:cNvPr id="5" name="TextBox 4"/>
+          <p:cNvSpPr txBox="1"/>
+          <p:nvPr/>
+        </p:nvSpPr>
+        <p:spPr>
+          <a:xfrm>
+            <a:off x="6309360" y="1463040"/>
+            <a:ext cx="5120640" cy="3840480"/>
+          </a:xfrm>
+          <a:prstGeom prst="rect">
+            <a:avLst/>
+          </a:prstGeom>
+          <a:noFill/>
+        </p:spPr>
+        <p:txBody>
+          <a:bodyPr wrap="none">
+            <a:spAutoFit/>
+          </a:bodyPr>
+          <a:lstStyle/>
+          <a:p>
+            <a:pPr algn="l">
+              <a:lnSpc>
+                <a:spcPct val="115000"/>
+              </a:lnSpc>
+              <a:spcAft>
+                <a:spcPts val="800"/>
+              </a:spcAft>
+            </a:pPr>
+            <a:r>
+              <a:rPr sz="1800">
+                <a:solidFill>
+                  <a:srgbClr val="0F172A"/>
+                </a:solidFill>
+                <a:latin typeface="Arial"/>
+              </a:rPr>
+              <a:t>Containerization: Docker</a:t>
+            </a:r>
+          </a:p>
+          <a:p>
+            <a:pPr algn="l">
+              <a:lnSpc>
+                <a:spcPct val="115000"/>
+              </a:lnSpc>
+              <a:spcAft>
+                <a:spcPts val="800"/>
+              </a:spcAft>
+            </a:pPr>
+            <a:r>
+              <a:rPr sz="1800">
+                <a:solidFill>
+                  <a:srgbClr val="0F172A"/>
+                </a:solidFill>
+                <a:latin typeface="Arial"/>
+              </a:rPr>
+              <a:t>Cloud Platform: Microsoft Azure</a:t>
+            </a:r>
+          </a:p>
+          <a:p>
+            <a:pPr algn="l">
+              <a:lnSpc>
+                <a:spcPct val="115000"/>
+              </a:lnSpc>
+              <a:spcAft>
+                <a:spcPts val="800"/>
+              </a:spcAft>
+            </a:pPr>
+            <a:r>
+              <a:rPr sz="1800">
+                <a:solidFill>
+                  <a:srgbClr val="0F172A"/>
+                </a:solidFill>
+                <a:latin typeface="Arial"/>
+              </a:rPr>
+              <a:t>Azure Services: App Service, Container Apps, Container Registry</a:t>
+            </a:r>
+          </a:p>
+          <a:p>
+            <a:pPr algn="l">
+              <a:lnSpc>
+                <a:spcPct val="115000"/>
+              </a:lnSpc>
+              <a:spcAft>
+                <a:spcPts val="800"/>
+              </a:spcAft>
+            </a:pPr>
+            <a:r>
+              <a:rPr sz="1800">
+                <a:solidFill>
+                  <a:srgbClr val="0F172A"/>
+                </a:solidFill>
+                <a:latin typeface="Arial"/>
+              </a:rPr>
+              <a:t>Deployment Automation: GitHub Actions</a:t>
+            </a:r>
+          </a:p>
+          <a:p>
+            <a:pPr algn="l">
+              <a:lnSpc>
+                <a:spcPct val="115000"/>
+              </a:lnSpc>
+              <a:spcAft>
+                <a:spcPts val="800"/>
+              </a:spcAft>
+            </a:pPr>
+            <a:r>
+              <a:rPr sz="1800">
+                <a:solidFill>
+                  <a:srgbClr val="0F172A"/>
+                </a:solidFill>
+                <a:latin typeface="Arial"/>
+              </a:rPr>
+              <a:t>Source Control: GitHub</a:t>
+            </a:r>
+          </a:p>
+          <a:p>
+            <a:pPr algn="l">
+              <a:lnSpc>
+                <a:spcPct val="115000"/>
+              </a:lnSpc>
+              <a:spcAft>
+                <a:spcPts val="800"/>
+              </a:spcAft>
+            </a:pPr>
+            <a:r>
+              <a:rPr sz="1800">
+                <a:solidFill>
+                  <a:srgbClr val="0F172A"/>
+                </a:solidFill>
+                <a:latin typeface="Arial"/>
+              </a:rPr>
+              <a:t>Production Pattern: CI/CD + environment secrets</a:t>
+            </a:r>
+          </a:p>
+        </p:txBody>
+      </p:sp>
+      <p:sp>
+        <p:nvSpPr>
+          <p:cNvPr id="6" name="TextBox 5"/>
+          <p:cNvSpPr txBox="1"/>
+          <p:nvPr/>
+        </p:nvSpPr>
+        <p:spPr>
+          <a:xfrm>
+            <a:off x="164592" y="6473952"/>
+            <a:ext cx="11795760" cy="256032"/>
+          </a:xfrm>
+          <a:prstGeom prst="rect">
+            <a:avLst/>
+          </a:prstGeom>
+          <a:noFill/>
+        </p:spPr>
+        <p:txBody>
+          <a:bodyPr wrap="none">
+            <a:spAutoFit/>
+          </a:bodyPr>
+          <a:lstStyle/>
+          <a:p>
+            <a:pPr algn="ctr"/>
+            <a:r>
+              <a:rPr sz="900" b="1">
                 <a:solidFill>
                   <a:srgbClr val="475569"/>
                 </a:solidFill>
@@ -4975,6 +5133,14 @@
 <file path=ppt/slides/slide6.xml><?xml version="1.0" encoding="utf-8"?>
 <p:sld xmlns:a="http://schemas.openxmlformats.org/drawingml/2006/main" xmlns:p="http://schemas.openxmlformats.org/presentationml/2006/main" xmlns:r="http://schemas.openxmlformats.org/officeDocument/2006/relationships">
   <p:cSld>
+    <p:bg>
+      <p:bgPr>
+        <a:solidFill>
+          <a:srgbClr val="FFFFFF"/>
+        </a:solidFill>
+        <a:effectLst/>
+      </p:bgPr>
+    </p:bg>
     <p:spTree>
       <p:nvGrpSpPr>
         <p:cNvPr id="1" name=""/>
@@ -4984,40 +5150,14 @@
       <p:grpSpPr/>
       <p:sp>
         <p:nvSpPr>
-          <p:cNvPr id="2" name="Title 1"/>
-          <p:cNvSpPr>
-            <a:spLocks noGrp="1"/>
-          </p:cNvSpPr>
-          <p:nvPr>
-            <p:ph type="title"/>
-          </p:nvPr>
-        </p:nvSpPr>
-        <p:spPr/>
-        <p:txBody>
-          <a:bodyPr/>
-          <a:lstStyle/>
-          <a:p>
-            <a:pPr>
-              <a:defRPr sz="2400">
-                <a:latin typeface="Arial"/>
-              </a:defRPr>
-            </a:pPr>
-            <a:r>
-              <a:t>Deployment &amp; Live URL</a:t>
-            </a:r>
-          </a:p>
-        </p:txBody>
-      </p:sp>
-      <p:sp>
-        <p:nvSpPr>
-          <p:cNvPr id="3" name="TextBox 2"/>
+          <p:cNvPr id="2" name="TextBox 1"/>
           <p:cNvSpPr txBox="1"/>
           <p:nvPr/>
         </p:nvSpPr>
         <p:spPr>
           <a:xfrm>
-            <a:off x="731520" y="1371600"/>
-            <a:ext cx="10789920" cy="4389120"/>
+            <a:off x="548640" y="228600"/>
+            <a:ext cx="8229600" cy="640080"/>
           </a:xfrm>
           <a:prstGeom prst="rect">
             <a:avLst/>
@@ -5030,154 +5170,59 @@
           </a:bodyPr>
           <a:lstStyle/>
           <a:p>
-            <a:pPr>
-              <a:spcAft>
-                <a:spcPts val="700"/>
-              </a:spcAft>
-              <a:defRPr sz="2000">
+            <a:pPr algn="l"/>
+            <a:r>
+              <a:rPr sz="2400" b="1">
+                <a:solidFill>
+                  <a:srgbClr val="0F172A"/>
+                </a:solidFill>
                 <a:latin typeface="Arial"/>
-              </a:defRPr>
-            </a:pPr>
-            <a:r>
-              <a:t>Live Application URL:</a:t>
-            </a:r>
-          </a:p>
-          <a:p>
-            <a:pPr>
-              <a:spcAft>
-                <a:spcPts val="700"/>
-              </a:spcAft>
-              <a:defRPr sz="1800">
-                <a:latin typeface="Arial"/>
-              </a:defRPr>
-            </a:pPr>
-            <a:r>
-              <a:t>https://it-support-ajay-001.azurewebsites.net/</a:t>
-            </a:r>
-          </a:p>
-          <a:p>
-            <a:pPr>
-              <a:spcAft>
-                <a:spcPts val="700"/>
-              </a:spcAft>
-              <a:defRPr sz="1800">
-                <a:latin typeface="Arial"/>
-              </a:defRPr>
-            </a:pPr>
-          </a:p>
-          <a:p>
-            <a:pPr>
-              <a:spcAft>
-                <a:spcPts val="700"/>
-              </a:spcAft>
-              <a:defRPr sz="2000">
-                <a:latin typeface="Arial"/>
-              </a:defRPr>
-            </a:pPr>
-            <a:r>
-              <a:t>GitHub Repository:</a:t>
-            </a:r>
-          </a:p>
-          <a:p>
-            <a:pPr>
-              <a:spcAft>
-                <a:spcPts val="700"/>
-              </a:spcAft>
-              <a:defRPr sz="1800">
-                <a:latin typeface="Arial"/>
-              </a:defRPr>
-            </a:pPr>
-            <a:r>
-              <a:t>https://github.com/helloajay21-max/-it-support-assistant</a:t>
-            </a:r>
-          </a:p>
-          <a:p>
-            <a:pPr>
-              <a:spcAft>
-                <a:spcPts val="700"/>
-              </a:spcAft>
-              <a:defRPr sz="1800">
-                <a:latin typeface="Arial"/>
-              </a:defRPr>
-            </a:pPr>
-          </a:p>
-          <a:p>
-            <a:pPr>
-              <a:spcAft>
-                <a:spcPts val="700"/>
-              </a:spcAft>
-              <a:defRPr sz="2000">
-                <a:latin typeface="Arial"/>
-              </a:defRPr>
-            </a:pPr>
-            <a:r>
-              <a:t>Deployment Model:</a:t>
-            </a:r>
-          </a:p>
-          <a:p>
-            <a:pPr>
-              <a:spcAft>
-                <a:spcPts val="700"/>
-              </a:spcAft>
-              <a:defRPr sz="1800">
-                <a:latin typeface="Arial"/>
-              </a:defRPr>
-            </a:pPr>
-            <a:r>
-              <a:t>• GitHub push triggers GitHub Actions</a:t>
-            </a:r>
-          </a:p>
-          <a:p>
-            <a:pPr>
-              <a:spcAft>
-                <a:spcPts val="700"/>
-              </a:spcAft>
-              <a:defRPr sz="1800">
-                <a:latin typeface="Arial"/>
-              </a:defRPr>
-            </a:pPr>
-            <a:r>
-              <a:t>• Docker image is built and pushed to Docker Hub</a:t>
-            </a:r>
-          </a:p>
-          <a:p>
-            <a:pPr>
-              <a:spcAft>
-                <a:spcPts val="700"/>
-              </a:spcAft>
-              <a:defRPr sz="1800">
-                <a:latin typeface="Arial"/>
-              </a:defRPr>
-            </a:pPr>
-            <a:r>
-              <a:t>• Azure Web App is updated automatically</a:t>
-            </a:r>
-          </a:p>
-          <a:p>
-            <a:pPr>
-              <a:spcAft>
-                <a:spcPts val="700"/>
-              </a:spcAft>
-              <a:defRPr sz="1800">
-                <a:latin typeface="Arial"/>
-              </a:defRPr>
-            </a:pPr>
-            <a:r>
-              <a:t>• Application restarts after successful deployment</a:t>
-            </a:r>
-          </a:p>
-          <a:p>
-            <a:pPr>
-              <a:spcAft>
-                <a:spcPts val="700"/>
-              </a:spcAft>
-              <a:defRPr sz="1800">
-                <a:latin typeface="Arial"/>
-              </a:defRPr>
-            </a:pPr>
-            <a:r>
-              <a:t>• Secrets remain stored in GitHub and Azure settings</a:t>
-            </a:r>
+              </a:rPr>
+              <a:t>Containerization and CI/CD</a:t>
+            </a:r>
+          </a:p>
+        </p:txBody>
+      </p:sp>
+      <p:sp>
+        <p:nvSpPr>
+          <p:cNvPr id="3" name="Rectangle 2"/>
+          <p:cNvSpPr/>
+          <p:nvPr/>
+        </p:nvSpPr>
+        <p:spPr>
+          <a:xfrm>
+            <a:off x="548640" y="868680"/>
+            <a:ext cx="1828800" cy="73152"/>
+          </a:xfrm>
+          <a:prstGeom prst="rect">
+            <a:avLst/>
+          </a:prstGeom>
+          <a:solidFill>
+            <a:srgbClr val="005EB8"/>
+          </a:solidFill>
+          <a:ln>
+            <a:noFill/>
+          </a:ln>
+        </p:spPr>
+        <p:style>
+          <a:lnRef idx="1">
+            <a:schemeClr val="accent1"/>
+          </a:lnRef>
+          <a:fillRef idx="3">
+            <a:schemeClr val="accent1"/>
+          </a:fillRef>
+          <a:effectRef idx="2">
+            <a:schemeClr val="accent1"/>
+          </a:effectRef>
+          <a:fontRef idx="minor">
+            <a:schemeClr val="lt1"/>
+          </a:fontRef>
+        </p:style>
+        <p:txBody>
+          <a:bodyPr rtlCol="0" anchor="ctr"/>
+          <a:lstStyle/>
+          <a:p>
+            <a:pPr algn="ctr"/>
           </a:p>
         </p:txBody>
       </p:sp>
@@ -5189,8 +5234,8 @@
         </p:nvSpPr>
         <p:spPr>
           <a:xfrm>
-            <a:off x="228600" y="6492240"/>
-            <a:ext cx="11704320" cy="228600"/>
+            <a:off x="731520" y="1371600"/>
+            <a:ext cx="10698480" cy="4206240"/>
           </a:xfrm>
           <a:prstGeom prst="rect">
             <a:avLst/>
@@ -5198,13 +5243,75 @@
           <a:noFill/>
         </p:spPr>
         <p:txBody>
+          <a:bodyPr wrap="square">
+            <a:spAutoFit/>
+          </a:bodyPr>
+          <a:lstStyle/>
+          <a:p>
+            <a:pPr algn="just">
+              <a:lnSpc>
+                <a:spcPct val="115000"/>
+              </a:lnSpc>
+              <a:spcAft>
+                <a:spcPts val="600"/>
+              </a:spcAft>
+            </a:pPr>
+            <a:r>
+              <a:rPr sz="1900">
+                <a:solidFill>
+                  <a:srgbClr val="0F172A"/>
+                </a:solidFill>
+                <a:latin typeface="Arial"/>
+              </a:rPr>
+              <a:t>Source code is managed in GitHub and built into a reproducible Docker image. The pipeline automates image creation, pushes it to the registry, and deploys the application to Azure. This enables consistent, repeatable delivery and production deployment without manual configuration inside the source code.</a:t>
+            </a:r>
+          </a:p>
+          <a:p>
+            <a:pPr algn="just">
+              <a:lnSpc>
+                <a:spcPct val="115000"/>
+              </a:lnSpc>
+              <a:spcAft>
+                <a:spcPts val="600"/>
+              </a:spcAft>
+            </a:pPr>
+            <a:r>
+              <a:rPr sz="1900">
+                <a:solidFill>
+                  <a:srgbClr val="0F172A"/>
+                </a:solidFill>
+                <a:latin typeface="Arial"/>
+              </a:rPr>
+              <a:t>The deployment workflow integrates Azure App Service and container-based runtime services while keeping environment-specific values such as API keys, SMTP configuration, and the admin password in secure GitHub and Azure settings.</a:t>
+            </a:r>
+          </a:p>
+        </p:txBody>
+      </p:sp>
+      <p:sp>
+        <p:nvSpPr>
+          <p:cNvPr id="5" name="TextBox 4"/>
+          <p:cNvSpPr txBox="1"/>
+          <p:nvPr/>
+        </p:nvSpPr>
+        <p:spPr>
+          <a:xfrm>
+            <a:off x="164592" y="6473952"/>
+            <a:ext cx="11795760" cy="256032"/>
+          </a:xfrm>
+          <a:prstGeom prst="rect">
+            <a:avLst/>
+          </a:prstGeom>
+          <a:noFill/>
+        </p:spPr>
+        <p:txBody>
           <a:bodyPr wrap="none">
             <a:spAutoFit/>
           </a:bodyPr>
           <a:lstStyle/>
           <a:p>
-            <a:r>
-              <a:rPr sz="800">
+            <a:pPr algn="ctr"/>
+            <a:r>
+              <a:rPr sz="900" b="1">
                 <a:solidFill>
                   <a:srgbClr val="475569"/>
                 </a:solidFill>
@@ -5226,6 +5333,14 @@
 <file path=ppt/slides/slide7.xml><?xml version="1.0" encoding="utf-8"?>
 <p:sld xmlns:a="http://schemas.openxmlformats.org/drawingml/2006/main" xmlns:p="http://schemas.openxmlformats.org/presentationml/2006/main" xmlns:r="http://schemas.openxmlformats.org/officeDocument/2006/relationships">
   <p:cSld>
+    <p:bg>
+      <p:bgPr>
+        <a:solidFill>
+          <a:srgbClr val="FFFFFF"/>
+        </a:solidFill>
+        <a:effectLst/>
+      </p:bgPr>
+    </p:bg>
     <p:spTree>
       <p:nvGrpSpPr>
         <p:cNvPr id="1" name=""/>
@@ -5235,40 +5350,14 @@
       <p:grpSpPr/>
       <p:sp>
         <p:nvSpPr>
-          <p:cNvPr id="2" name="Title 1"/>
-          <p:cNvSpPr>
-            <a:spLocks noGrp="1"/>
-          </p:cNvSpPr>
-          <p:nvPr>
-            <p:ph type="title"/>
-          </p:nvPr>
-        </p:nvSpPr>
-        <p:spPr/>
-        <p:txBody>
-          <a:bodyPr/>
-          <a:lstStyle/>
-          <a:p>
-            <a:pPr>
-              <a:defRPr sz="2400">
-                <a:latin typeface="Arial"/>
-              </a:defRPr>
-            </a:pPr>
-            <a:r>
-              <a:t>Results and Conclusion</a:t>
-            </a:r>
-          </a:p>
-        </p:txBody>
-      </p:sp>
-      <p:sp>
-        <p:nvSpPr>
-          <p:cNvPr id="3" name="TextBox 2"/>
+          <p:cNvPr id="2" name="TextBox 1"/>
           <p:cNvSpPr txBox="1"/>
           <p:nvPr/>
         </p:nvSpPr>
         <p:spPr>
           <a:xfrm>
-            <a:off x="731520" y="1280160"/>
-            <a:ext cx="10789920" cy="4389120"/>
+            <a:off x="548640" y="228600"/>
+            <a:ext cx="8229600" cy="640080"/>
           </a:xfrm>
           <a:prstGeom prst="rect">
             <a:avLst/>
@@ -5281,157 +5370,59 @@
           </a:bodyPr>
           <a:lstStyle/>
           <a:p>
-            <a:pPr>
-              <a:spcAft>
-                <a:spcPts val="800"/>
-              </a:spcAft>
-              <a:defRPr sz="1900">
+            <a:pPr algn="l"/>
+            <a:r>
+              <a:rPr sz="2400" b="1">
+                <a:solidFill>
+                  <a:srgbClr val="0F172A"/>
+                </a:solidFill>
                 <a:latin typeface="Arial"/>
-              </a:defRPr>
-            </a:pPr>
-            <a:r>
-              <a:t>The AI Operations Assistant now provides:</a:t>
-            </a:r>
-          </a:p>
-          <a:p>
-            <a:pPr>
-              <a:spcAft>
-                <a:spcPts val="800"/>
-              </a:spcAft>
-              <a:defRPr sz="1900">
-                <a:latin typeface="Arial"/>
-              </a:defRPr>
-            </a:pPr>
-            <a:r>
-              <a:t>• Secure multi-user login and access control</a:t>
-            </a:r>
-          </a:p>
-          <a:p>
-            <a:pPr>
-              <a:spcAft>
-                <a:spcPts val="800"/>
-              </a:spcAft>
-              <a:defRPr sz="1900">
-                <a:latin typeface="Arial"/>
-              </a:defRPr>
-            </a:pPr>
-            <a:r>
-              <a:t>• Admin-only approval/rejection workflow</a:t>
-            </a:r>
-          </a:p>
-          <a:p>
-            <a:pPr>
-              <a:spcAft>
-                <a:spcPts val="800"/>
-              </a:spcAft>
-              <a:defRPr sz="1900">
-                <a:latin typeface="Arial"/>
-              </a:defRPr>
-            </a:pPr>
-            <a:r>
-              <a:t>• Direct VPN setup email with password dispatch</a:t>
-            </a:r>
-          </a:p>
-          <a:p>
-            <a:pPr>
-              <a:spcAft>
-                <a:spcPts val="800"/>
-              </a:spcAft>
-              <a:defRPr sz="1900">
-                <a:latin typeface="Arial"/>
-              </a:defRPr>
-            </a:pPr>
-            <a:r>
-              <a:t>• Forgot-password reset with secure tokens</a:t>
-            </a:r>
-          </a:p>
-          <a:p>
-            <a:pPr>
-              <a:spcAft>
-                <a:spcPts val="800"/>
-              </a:spcAft>
-              <a:defRPr sz="1900">
-                <a:latin typeface="Arial"/>
-              </a:defRPr>
-            </a:pPr>
-            <a:r>
-              <a:t>• Correct ticket and employee visibility</a:t>
-            </a:r>
-          </a:p>
-          <a:p>
-            <a:pPr>
-              <a:spcAft>
-                <a:spcPts val="800"/>
-              </a:spcAft>
-              <a:defRPr sz="1900">
-                <a:latin typeface="Arial"/>
-              </a:defRPr>
-            </a:pPr>
-            <a:r>
-              <a:t>• Encrypted password storage in the database</a:t>
-            </a:r>
-          </a:p>
-          <a:p>
-            <a:pPr>
-              <a:spcAft>
-                <a:spcPts val="800"/>
-              </a:spcAft>
-              <a:defRPr sz="1900">
-                <a:latin typeface="Arial"/>
-              </a:defRPr>
-            </a:pPr>
-            <a:r>
-              <a:t>• Stable Azure deployment using CI/CD</a:t>
-            </a:r>
-          </a:p>
-          <a:p>
-            <a:pPr>
-              <a:spcAft>
-                <a:spcPts val="800"/>
-              </a:spcAft>
-              <a:defRPr sz="1900">
-                <a:latin typeface="Arial"/>
-              </a:defRPr>
-            </a:pPr>
-            <a:r>
-              <a:t>• Live production-ready deployment for the end user</a:t>
-            </a:r>
-          </a:p>
-          <a:p>
-            <a:pPr>
-              <a:spcAft>
-                <a:spcPts val="800"/>
-              </a:spcAft>
-              <a:defRPr sz="1900">
-                <a:latin typeface="Arial"/>
-              </a:defRPr>
-            </a:pPr>
-          </a:p>
-          <a:p>
-            <a:pPr>
-              <a:spcAft>
-                <a:spcPts val="800"/>
-              </a:spcAft>
-              <a:defRPr sz="1900">
-                <a:latin typeface="Arial"/>
-              </a:defRPr>
-            </a:pPr>
-            <a:r>
-              <a:t>Conclusion:</a:t>
-            </a:r>
-          </a:p>
-          <a:p>
-            <a:pPr>
-              <a:spcAft>
-                <a:spcPts val="800"/>
-              </a:spcAft>
-              <a:defRPr sz="1900">
-                <a:latin typeface="Arial"/>
-              </a:defRPr>
-            </a:pPr>
-            <a:r>
-              <a:t>This solution delivers a secure, role-based, operationally useful AI support system that is ready for real-world deployment and business use.</a:t>
-            </a:r>
+              </a:rPr>
+              <a:t>Conclusion</a:t>
+            </a:r>
+          </a:p>
+        </p:txBody>
+      </p:sp>
+      <p:sp>
+        <p:nvSpPr>
+          <p:cNvPr id="3" name="Rectangle 2"/>
+          <p:cNvSpPr/>
+          <p:nvPr/>
+        </p:nvSpPr>
+        <p:spPr>
+          <a:xfrm>
+            <a:off x="548640" y="868680"/>
+            <a:ext cx="1828800" cy="73152"/>
+          </a:xfrm>
+          <a:prstGeom prst="rect">
+            <a:avLst/>
+          </a:prstGeom>
+          <a:solidFill>
+            <a:srgbClr val="005EB8"/>
+          </a:solidFill>
+          <a:ln>
+            <a:noFill/>
+          </a:ln>
+        </p:spPr>
+        <p:style>
+          <a:lnRef idx="1">
+            <a:schemeClr val="accent1"/>
+          </a:lnRef>
+          <a:fillRef idx="3">
+            <a:schemeClr val="accent1"/>
+          </a:fillRef>
+          <a:effectRef idx="2">
+            <a:schemeClr val="accent1"/>
+          </a:effectRef>
+          <a:fontRef idx="minor">
+            <a:schemeClr val="lt1"/>
+          </a:fontRef>
+        </p:style>
+        <p:txBody>
+          <a:bodyPr rtlCol="0" anchor="ctr"/>
+          <a:lstStyle/>
+          <a:p>
+            <a:pPr algn="ctr"/>
           </a:p>
         </p:txBody>
       </p:sp>
@@ -5443,8 +5434,8 @@
         </p:nvSpPr>
         <p:spPr>
           <a:xfrm>
-            <a:off x="228600" y="6492240"/>
-            <a:ext cx="11704320" cy="228600"/>
+            <a:off x="731520" y="1554480"/>
+            <a:ext cx="10698480" cy="4023360"/>
           </a:xfrm>
           <a:prstGeom prst="rect">
             <a:avLst/>
@@ -5452,13 +5443,75 @@
           <a:noFill/>
         </p:spPr>
         <p:txBody>
+          <a:bodyPr wrap="square">
+            <a:spAutoFit/>
+          </a:bodyPr>
+          <a:lstStyle/>
+          <a:p>
+            <a:pPr algn="just">
+              <a:lnSpc>
+                <a:spcPct val="115000"/>
+              </a:lnSpc>
+              <a:spcAft>
+                <a:spcPts val="600"/>
+              </a:spcAft>
+            </a:pPr>
+            <a:r>
+              <a:rPr sz="2000">
+                <a:solidFill>
+                  <a:srgbClr val="0F172A"/>
+                </a:solidFill>
+                <a:latin typeface="Arial"/>
+              </a:rPr>
+              <a:t>The IT Support Assistant delivers an agentic AI-powered support experience combining secure access, action execution, knowledge assistance, ticket handling, employee lifecycle management, VPN operations, and Azure deployment.</a:t>
+            </a:r>
+          </a:p>
+          <a:p>
+            <a:pPr algn="just">
+              <a:lnSpc>
+                <a:spcPct val="115000"/>
+              </a:lnSpc>
+              <a:spcAft>
+                <a:spcPts val="600"/>
+              </a:spcAft>
+            </a:pPr>
+            <a:r>
+              <a:rPr sz="2000">
+                <a:solidFill>
+                  <a:srgbClr val="0F172A"/>
+                </a:solidFill>
+                <a:latin typeface="Arial"/>
+              </a:rPr>
+              <a:t>It provides an enterprise-ready, scalable foundation for intelligent IT operations, with strong governance, secure workflow execution, and practical business value.</a:t>
+            </a:r>
+          </a:p>
+        </p:txBody>
+      </p:sp>
+      <p:sp>
+        <p:nvSpPr>
+          <p:cNvPr id="5" name="TextBox 4"/>
+          <p:cNvSpPr txBox="1"/>
+          <p:nvPr/>
+        </p:nvSpPr>
+        <p:spPr>
+          <a:xfrm>
+            <a:off x="164592" y="6473952"/>
+            <a:ext cx="11795760" cy="256032"/>
+          </a:xfrm>
+          <a:prstGeom prst="rect">
+            <a:avLst/>
+          </a:prstGeom>
+          <a:noFill/>
+        </p:spPr>
+        <p:txBody>
           <a:bodyPr wrap="none">
             <a:spAutoFit/>
           </a:bodyPr>
           <a:lstStyle/>
           <a:p>
-            <a:r>
-              <a:rPr sz="800">
+            <a:pPr algn="ctr"/>
+            <a:r>
+              <a:rPr sz="900" b="1">
                 <a:solidFill>
                   <a:srgbClr val="475569"/>
                 </a:solidFill>

</xml_diff>

<commit_message>
Finalize premium project presentation deck
Co-authored-by: Copilot <223556219+Copilot@users.noreply.github.com>
</commit_message>
<xml_diff>
--- a/AI_Operations_Assistant_Presentation.pptx
+++ b/AI_Operations_Assistant_Presentation.pptx
@@ -3111,7 +3111,7 @@
         <p:spPr>
           <a:xfrm>
             <a:off x="0" y="0"/>
-            <a:ext cx="12191695" cy="411480"/>
+            <a:ext cx="12191695" cy="384048"/>
           </a:xfrm>
           <a:prstGeom prst="rect">
             <a:avLst/>
@@ -3153,14 +3153,14 @@
         </p:nvSpPr>
         <p:spPr>
           <a:xfrm>
-            <a:off x="822960" y="1005840"/>
-            <a:ext cx="10515600" cy="2926080"/>
+            <a:off x="822960" y="1097280"/>
+            <a:ext cx="10515600" cy="3017520"/>
           </a:xfrm>
           <a:prstGeom prst="roundRect">
             <a:avLst/>
           </a:prstGeom>
           <a:solidFill>
-            <a:srgbClr val="F1F5F9"/>
+            <a:srgbClr val="F0F7FF"/>
           </a:solidFill>
           <a:ln>
             <a:solidFill>
@@ -3198,8 +3198,8 @@
         </p:nvSpPr>
         <p:spPr>
           <a:xfrm>
-            <a:off x="1188720" y="1645920"/>
-            <a:ext cx="9601200" cy="822960"/>
+            <a:off x="1097280" y="1645920"/>
+            <a:ext cx="9692640" cy="914400"/>
           </a:xfrm>
           <a:prstGeom prst="rect">
             <a:avLst/>
@@ -3233,8 +3233,8 @@
         </p:nvSpPr>
         <p:spPr>
           <a:xfrm>
-            <a:off x="1188720" y="2560320"/>
-            <a:ext cx="9601200" cy="457200"/>
+            <a:off x="1097280" y="2560320"/>
+            <a:ext cx="9692640" cy="457200"/>
           </a:xfrm>
           <a:prstGeom prst="rect">
             <a:avLst/>
@@ -3268,14 +3268,14 @@
         </p:nvSpPr>
         <p:spPr>
           <a:xfrm>
-            <a:off x="1005840" y="4069080"/>
-            <a:ext cx="10149840" cy="640080"/>
+            <a:off x="1097280" y="4023360"/>
+            <a:ext cx="9966960" cy="685800"/>
           </a:xfrm>
           <a:prstGeom prst="rect">
             <a:avLst/>
           </a:prstGeom>
           <a:solidFill>
-            <a:srgbClr val="DBEAFE"/>
+            <a:srgbClr val="E0EFFF"/>
           </a:solidFill>
           <a:ln>
             <a:solidFill>
@@ -3322,8 +3322,8 @@
         </p:nvSpPr>
         <p:spPr>
           <a:xfrm>
-            <a:off x="1371600" y="4983480"/>
-            <a:ext cx="9418320" cy="594360"/>
+            <a:off x="1280160" y="4983480"/>
+            <a:ext cx="9601200" cy="548640"/>
           </a:xfrm>
           <a:prstGeom prst="rect">
             <a:avLst/>
@@ -3376,8 +3376,8 @@
         </p:nvSpPr>
         <p:spPr>
           <a:xfrm>
-            <a:off x="182880" y="6473952"/>
-            <a:ext cx="11795760" cy="256032"/>
+            <a:off x="137160" y="6473952"/>
+            <a:ext cx="11795760" cy="237744"/>
           </a:xfrm>
           <a:prstGeom prst="rect">
             <a:avLst/>
@@ -3431,49 +3431,14 @@
       <p:grpSpPr/>
       <p:sp>
         <p:nvSpPr>
-          <p:cNvPr id="2" name="TextBox 1"/>
-          <p:cNvSpPr txBox="1"/>
-          <p:nvPr/>
-        </p:nvSpPr>
-        <p:spPr>
-          <a:xfrm>
-            <a:off x="548640" y="228600"/>
-            <a:ext cx="8229600" cy="640080"/>
-          </a:xfrm>
-          <a:prstGeom prst="rect">
-            <a:avLst/>
-          </a:prstGeom>
-          <a:noFill/>
-        </p:spPr>
-        <p:txBody>
-          <a:bodyPr wrap="none">
-            <a:spAutoFit/>
-          </a:bodyPr>
-          <a:lstStyle/>
-          <a:p>
-            <a:pPr algn="l"/>
-            <a:r>
-              <a:rPr sz="2400" b="1">
-                <a:solidFill>
-                  <a:srgbClr val="0F172A"/>
-                </a:solidFill>
-                <a:latin typeface="Arial"/>
-              </a:rPr>
-              <a:t>Business Problem &amp; Solution</a:t>
-            </a:r>
-          </a:p>
-        </p:txBody>
-      </p:sp>
-      <p:sp>
-        <p:nvSpPr>
-          <p:cNvPr id="3" name="Rectangle 2"/>
+          <p:cNvPr id="2" name="Rectangle 1"/>
           <p:cNvSpPr/>
           <p:nvPr/>
         </p:nvSpPr>
         <p:spPr>
           <a:xfrm>
-            <a:off x="548640" y="868680"/>
-            <a:ext cx="1828800" cy="73152"/>
+            <a:off x="0" y="0"/>
+            <a:ext cx="12191695" cy="384048"/>
           </a:xfrm>
           <a:prstGeom prst="rect">
             <a:avLst/>
@@ -3509,14 +3474,14 @@
       </p:sp>
       <p:sp>
         <p:nvSpPr>
-          <p:cNvPr id="4" name="TextBox 3"/>
+          <p:cNvPr id="3" name="TextBox 2"/>
           <p:cNvSpPr txBox="1"/>
           <p:nvPr/>
         </p:nvSpPr>
         <p:spPr>
           <a:xfrm>
-            <a:off x="731520" y="1371600"/>
-            <a:ext cx="10789920" cy="4206240"/>
+            <a:off x="548640" y="502920"/>
+            <a:ext cx="7315200" cy="640080"/>
           </a:xfrm>
           <a:prstGeom prst="rect">
             <a:avLst/>
@@ -3524,6 +3489,84 @@
           <a:noFill/>
         </p:spPr>
         <p:txBody>
+          <a:bodyPr wrap="none">
+            <a:spAutoFit/>
+          </a:bodyPr>
+          <a:lstStyle/>
+          <a:p>
+            <a:pPr algn="l"/>
+            <a:r>
+              <a:rPr sz="2400" b="1">
+                <a:solidFill>
+                  <a:srgbClr val="0F172A"/>
+                </a:solidFill>
+                <a:latin typeface="Arial"/>
+              </a:rPr>
+              <a:t>Business Problem &amp; Solution</a:t>
+            </a:r>
+          </a:p>
+        </p:txBody>
+      </p:sp>
+      <p:sp>
+        <p:nvSpPr>
+          <p:cNvPr id="4" name="Rectangle 3"/>
+          <p:cNvSpPr/>
+          <p:nvPr/>
+        </p:nvSpPr>
+        <p:spPr>
+          <a:xfrm>
+            <a:off x="548640" y="914400"/>
+            <a:ext cx="1920240" cy="73152"/>
+          </a:xfrm>
+          <a:prstGeom prst="rect">
+            <a:avLst/>
+          </a:prstGeom>
+          <a:solidFill>
+            <a:srgbClr val="0EA5E9"/>
+          </a:solidFill>
+          <a:ln>
+            <a:noFill/>
+          </a:ln>
+        </p:spPr>
+        <p:style>
+          <a:lnRef idx="1">
+            <a:schemeClr val="accent1"/>
+          </a:lnRef>
+          <a:fillRef idx="3">
+            <a:schemeClr val="accent1"/>
+          </a:fillRef>
+          <a:effectRef idx="2">
+            <a:schemeClr val="accent1"/>
+          </a:effectRef>
+          <a:fontRef idx="minor">
+            <a:schemeClr val="lt1"/>
+          </a:fontRef>
+        </p:style>
+        <p:txBody>
+          <a:bodyPr rtlCol="0" anchor="ctr"/>
+          <a:lstStyle/>
+          <a:p>
+            <a:pPr algn="ctr"/>
+          </a:p>
+        </p:txBody>
+      </p:sp>
+      <p:sp>
+        <p:nvSpPr>
+          <p:cNvPr id="5" name="TextBox 4"/>
+          <p:cNvSpPr txBox="1"/>
+          <p:nvPr/>
+        </p:nvSpPr>
+        <p:spPr>
+          <a:xfrm>
+            <a:off x="731520" y="1371600"/>
+            <a:ext cx="10698480" cy="4297680"/>
+          </a:xfrm>
+          <a:prstGeom prst="rect">
+            <a:avLst/>
+          </a:prstGeom>
+          <a:noFill/>
+        </p:spPr>
+        <p:txBody>
           <a:bodyPr wrap="square">
             <a:spAutoFit/>
           </a:bodyPr>
@@ -3531,14 +3574,14 @@
           <a:p>
             <a:pPr algn="just">
               <a:lnSpc>
-                <a:spcPct val="115000"/>
+                <a:spcPct val="110000"/>
               </a:lnSpc>
               <a:spcAft>
-                <a:spcPts val="600"/>
+                <a:spcPts val="800"/>
               </a:spcAft>
             </a:pPr>
             <a:r>
-              <a:rPr sz="2000">
+              <a:rPr sz="2000" b="0">
                 <a:solidFill>
                   <a:srgbClr val="0F172A"/>
                 </a:solidFill>
@@ -3550,14 +3593,14 @@
           <a:p>
             <a:pPr algn="just">
               <a:lnSpc>
-                <a:spcPct val="115000"/>
+                <a:spcPct val="110000"/>
               </a:lnSpc>
               <a:spcAft>
-                <a:spcPts val="600"/>
+                <a:spcPts val="800"/>
               </a:spcAft>
             </a:pPr>
             <a:r>
-              <a:rPr sz="2000">
+              <a:rPr sz="2000" b="0">
                 <a:solidFill>
                   <a:srgbClr val="0F172A"/>
                 </a:solidFill>
@@ -3570,14 +3613,14 @@
       </p:sp>
       <p:sp>
         <p:nvSpPr>
-          <p:cNvPr id="5" name="TextBox 4"/>
+          <p:cNvPr id="6" name="TextBox 5"/>
           <p:cNvSpPr txBox="1"/>
           <p:nvPr/>
         </p:nvSpPr>
         <p:spPr>
           <a:xfrm>
-            <a:off x="164592" y="6473952"/>
-            <a:ext cx="11795760" cy="256032"/>
+            <a:off x="137160" y="6473952"/>
+            <a:ext cx="11795760" cy="237744"/>
           </a:xfrm>
           <a:prstGeom prst="rect">
             <a:avLst/>
@@ -3631,49 +3674,14 @@
       <p:grpSpPr/>
       <p:sp>
         <p:nvSpPr>
-          <p:cNvPr id="2" name="TextBox 1"/>
-          <p:cNvSpPr txBox="1"/>
-          <p:nvPr/>
-        </p:nvSpPr>
-        <p:spPr>
-          <a:xfrm>
-            <a:off x="548640" y="228600"/>
-            <a:ext cx="8229600" cy="640080"/>
-          </a:xfrm>
-          <a:prstGeom prst="rect">
-            <a:avLst/>
-          </a:prstGeom>
-          <a:noFill/>
-        </p:spPr>
-        <p:txBody>
-          <a:bodyPr wrap="none">
-            <a:spAutoFit/>
-          </a:bodyPr>
-          <a:lstStyle/>
-          <a:p>
-            <a:pPr algn="l"/>
-            <a:r>
-              <a:rPr sz="2400" b="1">
-                <a:solidFill>
-                  <a:srgbClr val="0F172A"/>
-                </a:solidFill>
-                <a:latin typeface="Arial"/>
-              </a:rPr>
-              <a:t>Agentic AI Solution Architecture</a:t>
-            </a:r>
-          </a:p>
-        </p:txBody>
-      </p:sp>
-      <p:sp>
-        <p:nvSpPr>
-          <p:cNvPr id="3" name="Rectangle 2"/>
+          <p:cNvPr id="2" name="Rectangle 1"/>
           <p:cNvSpPr/>
           <p:nvPr/>
         </p:nvSpPr>
         <p:spPr>
           <a:xfrm>
-            <a:off x="548640" y="868680"/>
-            <a:ext cx="1828800" cy="73152"/>
+            <a:off x="0" y="0"/>
+            <a:ext cx="12191695" cy="384048"/>
           </a:xfrm>
           <a:prstGeom prst="rect">
             <a:avLst/>
@@ -3709,13 +3717,91 @@
       </p:sp>
       <p:sp>
         <p:nvSpPr>
-          <p:cNvPr id="4" name="Rounded Rectangle 3"/>
+          <p:cNvPr id="3" name="TextBox 2"/>
+          <p:cNvSpPr txBox="1"/>
+          <p:nvPr/>
+        </p:nvSpPr>
+        <p:spPr>
+          <a:xfrm>
+            <a:off x="548640" y="502920"/>
+            <a:ext cx="7315200" cy="640080"/>
+          </a:xfrm>
+          <a:prstGeom prst="rect">
+            <a:avLst/>
+          </a:prstGeom>
+          <a:noFill/>
+        </p:spPr>
+        <p:txBody>
+          <a:bodyPr wrap="none">
+            <a:spAutoFit/>
+          </a:bodyPr>
+          <a:lstStyle/>
+          <a:p>
+            <a:pPr algn="l"/>
+            <a:r>
+              <a:rPr sz="2400" b="1">
+                <a:solidFill>
+                  <a:srgbClr val="0F172A"/>
+                </a:solidFill>
+                <a:latin typeface="Arial"/>
+              </a:rPr>
+              <a:t>Agentic AI Solution Architecture</a:t>
+            </a:r>
+          </a:p>
+        </p:txBody>
+      </p:sp>
+      <p:sp>
+        <p:nvSpPr>
+          <p:cNvPr id="4" name="Rectangle 3"/>
           <p:cNvSpPr/>
           <p:nvPr/>
         </p:nvSpPr>
         <p:spPr>
           <a:xfrm>
-            <a:off x="731520" y="2560320"/>
+            <a:off x="548640" y="914400"/>
+            <a:ext cx="1920240" cy="73152"/>
+          </a:xfrm>
+          <a:prstGeom prst="rect">
+            <a:avLst/>
+          </a:prstGeom>
+          <a:solidFill>
+            <a:srgbClr val="0EA5E9"/>
+          </a:solidFill>
+          <a:ln>
+            <a:noFill/>
+          </a:ln>
+        </p:spPr>
+        <p:style>
+          <a:lnRef idx="1">
+            <a:schemeClr val="accent1"/>
+          </a:lnRef>
+          <a:fillRef idx="3">
+            <a:schemeClr val="accent1"/>
+          </a:fillRef>
+          <a:effectRef idx="2">
+            <a:schemeClr val="accent1"/>
+          </a:effectRef>
+          <a:fontRef idx="minor">
+            <a:schemeClr val="lt1"/>
+          </a:fontRef>
+        </p:style>
+        <p:txBody>
+          <a:bodyPr rtlCol="0" anchor="ctr"/>
+          <a:lstStyle/>
+          <a:p>
+            <a:pPr algn="ctr"/>
+          </a:p>
+        </p:txBody>
+      </p:sp>
+      <p:sp>
+        <p:nvSpPr>
+          <p:cNvPr id="5" name="Rounded Rectangle 4"/>
+          <p:cNvSpPr/>
+          <p:nvPr/>
+        </p:nvSpPr>
+        <p:spPr>
+          <a:xfrm>
+            <a:off x="731520" y="2377440"/>
             <a:ext cx="1371600" cy="822960"/>
           </a:xfrm>
           <a:prstGeom prst="roundRect">
@@ -3763,13 +3849,13 @@
       </p:sp>
       <p:sp>
         <p:nvSpPr>
-          <p:cNvPr id="5" name="Right Arrow 4"/>
+          <p:cNvPr id="6" name="Right Arrow 5"/>
           <p:cNvSpPr/>
           <p:nvPr/>
         </p:nvSpPr>
         <p:spPr>
           <a:xfrm>
-            <a:off x="2103120" y="2880360"/>
+            <a:off x="2103120" y="2697480"/>
             <a:ext cx="457200" cy="182880"/>
           </a:xfrm>
           <a:prstGeom prst="rightArrow">
@@ -3806,14 +3892,14 @@
       </p:sp>
       <p:sp>
         <p:nvSpPr>
-          <p:cNvPr id="6" name="Rounded Rectangle 5"/>
+          <p:cNvPr id="7" name="Rounded Rectangle 6"/>
           <p:cNvSpPr/>
           <p:nvPr/>
         </p:nvSpPr>
         <p:spPr>
           <a:xfrm>
-            <a:off x="2468880" y="2560320"/>
-            <a:ext cx="1554480" cy="822960"/>
+            <a:off x="2377440" y="2377440"/>
+            <a:ext cx="1463040" cy="822960"/>
           </a:xfrm>
           <a:prstGeom prst="roundRect">
             <a:avLst/>
@@ -3860,13 +3946,13 @@
       </p:sp>
       <p:sp>
         <p:nvSpPr>
-          <p:cNvPr id="7" name="Right Arrow 6"/>
+          <p:cNvPr id="8" name="Right Arrow 7"/>
           <p:cNvSpPr/>
           <p:nvPr/>
         </p:nvSpPr>
         <p:spPr>
           <a:xfrm>
-            <a:off x="4023360" y="2880360"/>
+            <a:off x="3840480" y="2697480"/>
             <a:ext cx="457200" cy="182880"/>
           </a:xfrm>
           <a:prstGeom prst="rightArrow">
@@ -3903,14 +3989,14 @@
       </p:sp>
       <p:sp>
         <p:nvSpPr>
-          <p:cNvPr id="8" name="Rounded Rectangle 7"/>
+          <p:cNvPr id="9" name="Rounded Rectangle 8"/>
           <p:cNvSpPr/>
           <p:nvPr/>
         </p:nvSpPr>
         <p:spPr>
           <a:xfrm>
-            <a:off x="4389120" y="2560320"/>
-            <a:ext cx="1645920" cy="822960"/>
+            <a:off x="4114800" y="2377440"/>
+            <a:ext cx="1554480" cy="822960"/>
           </a:xfrm>
           <a:prstGeom prst="roundRect">
             <a:avLst/>
@@ -3957,13 +4043,13 @@
       </p:sp>
       <p:sp>
         <p:nvSpPr>
-          <p:cNvPr id="9" name="Right Arrow 8"/>
+          <p:cNvPr id="10" name="Right Arrow 9"/>
           <p:cNvSpPr/>
           <p:nvPr/>
         </p:nvSpPr>
         <p:spPr>
           <a:xfrm>
-            <a:off x="6035040" y="2880360"/>
+            <a:off x="5669280" y="2697480"/>
             <a:ext cx="457200" cy="182880"/>
           </a:xfrm>
           <a:prstGeom prst="rightArrow">
@@ -4000,13 +4086,13 @@
       </p:sp>
       <p:sp>
         <p:nvSpPr>
-          <p:cNvPr id="10" name="Rounded Rectangle 9"/>
+          <p:cNvPr id="11" name="Rounded Rectangle 10"/>
           <p:cNvSpPr/>
           <p:nvPr/>
         </p:nvSpPr>
         <p:spPr>
           <a:xfrm>
-            <a:off x="6309360" y="2560320"/>
+            <a:off x="6035040" y="2377440"/>
             <a:ext cx="1645920" cy="822960"/>
           </a:xfrm>
           <a:prstGeom prst="roundRect">
@@ -4054,13 +4140,13 @@
       </p:sp>
       <p:sp>
         <p:nvSpPr>
-          <p:cNvPr id="11" name="Right Arrow 10"/>
+          <p:cNvPr id="12" name="Right Arrow 11"/>
           <p:cNvSpPr/>
           <p:nvPr/>
         </p:nvSpPr>
         <p:spPr>
           <a:xfrm>
-            <a:off x="7955280" y="2880360"/>
+            <a:off x="7680960" y="2697480"/>
             <a:ext cx="457200" cy="182880"/>
           </a:xfrm>
           <a:prstGeom prst="rightArrow">
@@ -4097,13 +4183,13 @@
       </p:sp>
       <p:sp>
         <p:nvSpPr>
-          <p:cNvPr id="12" name="Rounded Rectangle 11"/>
+          <p:cNvPr id="13" name="Rounded Rectangle 12"/>
           <p:cNvSpPr/>
           <p:nvPr/>
         </p:nvSpPr>
         <p:spPr>
           <a:xfrm>
-            <a:off x="8229600" y="2560320"/>
+            <a:off x="8138160" y="2377440"/>
             <a:ext cx="1828800" cy="822960"/>
           </a:xfrm>
           <a:prstGeom prst="roundRect">
@@ -4151,14 +4237,14 @@
       </p:sp>
       <p:sp>
         <p:nvSpPr>
-          <p:cNvPr id="13" name="TextBox 12"/>
+          <p:cNvPr id="14" name="TextBox 13"/>
           <p:cNvSpPr txBox="1"/>
           <p:nvPr/>
         </p:nvSpPr>
         <p:spPr>
           <a:xfrm>
             <a:off x="731520" y="3931920"/>
-            <a:ext cx="10698480" cy="1828800"/>
+            <a:ext cx="10789920" cy="1920240"/>
           </a:xfrm>
           <a:prstGeom prst="rect">
             <a:avLst/>
@@ -4166,21 +4252,21 @@
           <a:noFill/>
         </p:spPr>
         <p:txBody>
-          <a:bodyPr wrap="none">
+          <a:bodyPr wrap="square">
             <a:spAutoFit/>
           </a:bodyPr>
           <a:lstStyle/>
           <a:p>
             <a:pPr algn="just">
               <a:lnSpc>
-                <a:spcPct val="115000"/>
+                <a:spcPct val="110000"/>
               </a:lnSpc>
               <a:spcAft>
-                <a:spcPts val="600"/>
+                <a:spcPts val="800"/>
               </a:spcAft>
             </a:pPr>
             <a:r>
-              <a:rPr sz="1700">
+              <a:rPr sz="1700" b="0">
                 <a:solidFill>
                   <a:srgbClr val="0F172A"/>
                 </a:solidFill>
@@ -4188,61 +4274,16 @@
               </a:rPr>
               <a:t>Understand: Natural-language intent and request context</a:t>
             </a:r>
-          </a:p>
-          <a:p>
-            <a:pPr algn="just">
-              <a:lnSpc>
-                <a:spcPct val="115000"/>
-              </a:lnSpc>
-              <a:spcAft>
-                <a:spcPts val="600"/>
-              </a:spcAft>
-            </a:pPr>
-            <a:r>
-              <a:rPr sz="1700">
-                <a:solidFill>
-                  <a:srgbClr val="0F172A"/>
-                </a:solidFill>
-                <a:latin typeface="Arial"/>
-              </a:rPr>
+            <a:br/>
+            <a:r>
               <a:t>Orchestrate: LangGraph reasoning, state management, and conditional routing</a:t>
             </a:r>
-          </a:p>
-          <a:p>
-            <a:pPr algn="just">
-              <a:lnSpc>
-                <a:spcPct val="115000"/>
-              </a:lnSpc>
-              <a:spcAft>
-                <a:spcPts val="600"/>
-              </a:spcAft>
-            </a:pPr>
-            <a:r>
-              <a:rPr sz="1600">
-                <a:solidFill>
-                  <a:srgbClr val="0F172A"/>
-                </a:solidFill>
-                <a:latin typeface="Arial"/>
-              </a:rPr>
+            <a:br/>
+            <a:r>
               <a:t>Act: Knowledge lookup, ticket operations, employee actions, VPN requests, and email dispatch</a:t>
             </a:r>
-          </a:p>
-          <a:p>
-            <a:pPr algn="just">
-              <a:lnSpc>
-                <a:spcPct val="115000"/>
-              </a:lnSpc>
-              <a:spcAft>
-                <a:spcPts val="600"/>
-              </a:spcAft>
-            </a:pPr>
-            <a:r>
-              <a:rPr sz="1600">
-                <a:solidFill>
-                  <a:srgbClr val="0F172A"/>
-                </a:solidFill>
-                <a:latin typeface="Arial"/>
-              </a:rPr>
+            <a:br/>
+            <a:r>
               <a:t>Result: Context-aware responses with workflow execution and secure validation</a:t>
             </a:r>
           </a:p>
@@ -4250,14 +4291,14 @@
       </p:sp>
       <p:sp>
         <p:nvSpPr>
-          <p:cNvPr id="14" name="TextBox 13"/>
+          <p:cNvPr id="15" name="TextBox 14"/>
           <p:cNvSpPr txBox="1"/>
           <p:nvPr/>
         </p:nvSpPr>
         <p:spPr>
           <a:xfrm>
-            <a:off x="164592" y="6473952"/>
-            <a:ext cx="11795760" cy="256032"/>
+            <a:off x="137160" y="6473952"/>
+            <a:ext cx="11795760" cy="237744"/>
           </a:xfrm>
           <a:prstGeom prst="rect">
             <a:avLst/>
@@ -4311,49 +4352,14 @@
       <p:grpSpPr/>
       <p:sp>
         <p:nvSpPr>
-          <p:cNvPr id="2" name="TextBox 1"/>
-          <p:cNvSpPr txBox="1"/>
-          <p:nvPr/>
-        </p:nvSpPr>
-        <p:spPr>
-          <a:xfrm>
-            <a:off x="548640" y="228600"/>
-            <a:ext cx="8229600" cy="640080"/>
-          </a:xfrm>
-          <a:prstGeom prst="rect">
-            <a:avLst/>
-          </a:prstGeom>
-          <a:noFill/>
-        </p:spPr>
-        <p:txBody>
-          <a:bodyPr wrap="none">
-            <a:spAutoFit/>
-          </a:bodyPr>
-          <a:lstStyle/>
-          <a:p>
-            <a:pPr algn="l"/>
-            <a:r>
-              <a:rPr sz="2400" b="1">
-                <a:solidFill>
-                  <a:srgbClr val="0F172A"/>
-                </a:solidFill>
-                <a:latin typeface="Arial"/>
-              </a:rPr>
-              <a:t>Core Capabilities</a:t>
-            </a:r>
-          </a:p>
-        </p:txBody>
-      </p:sp>
-      <p:sp>
-        <p:nvSpPr>
-          <p:cNvPr id="3" name="Rectangle 2"/>
+          <p:cNvPr id="2" name="Rectangle 1"/>
           <p:cNvSpPr/>
           <p:nvPr/>
         </p:nvSpPr>
         <p:spPr>
           <a:xfrm>
-            <a:off x="548640" y="868680"/>
-            <a:ext cx="1828800" cy="73152"/>
+            <a:off x="0" y="0"/>
+            <a:ext cx="12191695" cy="384048"/>
           </a:xfrm>
           <a:prstGeom prst="rect">
             <a:avLst/>
@@ -4389,14 +4395,14 @@
       </p:sp>
       <p:sp>
         <p:nvSpPr>
-          <p:cNvPr id="4" name="TextBox 3"/>
+          <p:cNvPr id="3" name="TextBox 2"/>
           <p:cNvSpPr txBox="1"/>
           <p:nvPr/>
         </p:nvSpPr>
         <p:spPr>
           <a:xfrm>
-            <a:off x="640080" y="1371600"/>
-            <a:ext cx="5212080" cy="4389120"/>
+            <a:off x="548640" y="502920"/>
+            <a:ext cx="7315200" cy="640080"/>
           </a:xfrm>
           <a:prstGeom prst="rect">
             <a:avLst/>
@@ -4404,120 +4410,64 @@
           <a:noFill/>
         </p:spPr>
         <p:txBody>
-          <a:bodyPr wrap="square">
+          <a:bodyPr wrap="none">
             <a:spAutoFit/>
           </a:bodyPr>
           <a:lstStyle/>
           <a:p>
-            <a:pPr algn="l">
-              <a:spcAft>
-                <a:spcPts val="600"/>
-              </a:spcAft>
-            </a:pPr>
-            <a:r>
-              <a:rPr sz="1800" b="1">
-                <a:solidFill>
-                  <a:srgbClr val="005EB8"/>
+            <a:pPr algn="l"/>
+            <a:r>
+              <a:rPr sz="2400" b="1">
+                <a:solidFill>
+                  <a:srgbClr val="0F172A"/>
                 </a:solidFill>
                 <a:latin typeface="Arial"/>
               </a:rPr>
-              <a:t>Operational Functions</a:t>
-            </a:r>
-          </a:p>
-          <a:p>
-            <a:pPr algn="just">
-              <a:lnSpc>
-                <a:spcPct val="112000"/>
-              </a:lnSpc>
-              <a:spcAft>
-                <a:spcPts val="600"/>
-              </a:spcAft>
-            </a:pPr>
-            <a:r>
-              <a:rPr sz="1500">
-                <a:solidFill>
-                  <a:srgbClr val="0F172A"/>
-                </a:solidFill>
-                <a:latin typeface="Arial"/>
-              </a:rPr>
-              <a:t>Knowledge search and IT guidance lookup</a:t>
-            </a:r>
-          </a:p>
-          <a:p>
-            <a:pPr algn="just">
-              <a:lnSpc>
-                <a:spcPct val="112000"/>
-              </a:lnSpc>
-              <a:spcAft>
-                <a:spcPts val="600"/>
-              </a:spcAft>
-            </a:pPr>
-            <a:r>
-              <a:rPr sz="1500">
-                <a:solidFill>
-                  <a:srgbClr val="0F172A"/>
-                </a:solidFill>
-                <a:latin typeface="Arial"/>
-              </a:rPr>
-              <a:t>Ticket lookup, creation, and status tracking</a:t>
-            </a:r>
-          </a:p>
-          <a:p>
-            <a:pPr algn="just">
-              <a:lnSpc>
-                <a:spcPct val="112000"/>
-              </a:lnSpc>
-              <a:spcAft>
-                <a:spcPts val="600"/>
-              </a:spcAft>
-            </a:pPr>
-            <a:r>
-              <a:rPr sz="1500">
-                <a:solidFill>
-                  <a:srgbClr val="0F172A"/>
-                </a:solidFill>
-                <a:latin typeface="Arial"/>
-              </a:rPr>
-              <a:t>Employee registration, identity validation, and DB persistence</a:t>
-            </a:r>
-          </a:p>
-          <a:p>
-            <a:pPr algn="just">
-              <a:lnSpc>
-                <a:spcPct val="112000"/>
-              </a:lnSpc>
-              <a:spcAft>
-                <a:spcPts val="600"/>
-              </a:spcAft>
-            </a:pPr>
-            <a:r>
-              <a:rPr sz="1500">
-                <a:solidFill>
-                  <a:srgbClr val="0F172A"/>
-                </a:solidFill>
-                <a:latin typeface="Arial"/>
-              </a:rPr>
-              <a:t>VPN first-time setup and password reset workflows</a:t>
-            </a:r>
-          </a:p>
-          <a:p>
-            <a:pPr algn="just">
-              <a:lnSpc>
-                <a:spcPct val="112000"/>
-              </a:lnSpc>
-              <a:spcAft>
-                <a:spcPts val="600"/>
-              </a:spcAft>
-            </a:pPr>
-            <a:r>
-              <a:rPr sz="1500">
-                <a:solidFill>
-                  <a:srgbClr val="0F172A"/>
-                </a:solidFill>
-                <a:latin typeface="Arial"/>
-              </a:rPr>
-              <a:t>Email dispatch for password and approval actions</a:t>
-            </a:r>
+              <a:t>Technology Stack</a:t>
+            </a:r>
+          </a:p>
+        </p:txBody>
+      </p:sp>
+      <p:sp>
+        <p:nvSpPr>
+          <p:cNvPr id="4" name="Rectangle 3"/>
+          <p:cNvSpPr/>
+          <p:nvPr/>
+        </p:nvSpPr>
+        <p:spPr>
+          <a:xfrm>
+            <a:off x="548640" y="914400"/>
+            <a:ext cx="1920240" cy="73152"/>
+          </a:xfrm>
+          <a:prstGeom prst="rect">
+            <a:avLst/>
+          </a:prstGeom>
+          <a:solidFill>
+            <a:srgbClr val="0EA5E9"/>
+          </a:solidFill>
+          <a:ln>
+            <a:noFill/>
+          </a:ln>
+        </p:spPr>
+        <p:style>
+          <a:lnRef idx="1">
+            <a:schemeClr val="accent1"/>
+          </a:lnRef>
+          <a:fillRef idx="3">
+            <a:schemeClr val="accent1"/>
+          </a:fillRef>
+          <a:effectRef idx="2">
+            <a:schemeClr val="accent1"/>
+          </a:effectRef>
+          <a:fontRef idx="minor">
+            <a:schemeClr val="lt1"/>
+          </a:fontRef>
+        </p:style>
+        <p:txBody>
+          <a:bodyPr rtlCol="0" anchor="ctr"/>
+          <a:lstStyle/>
+          <a:p>
+            <a:pPr algn="ctr"/>
           </a:p>
         </p:txBody>
       </p:sp>
@@ -4529,8 +4479,8 @@
         </p:nvSpPr>
         <p:spPr>
           <a:xfrm>
-            <a:off x="6217920" y="1371600"/>
-            <a:ext cx="5029200" cy="4389120"/>
+            <a:off x="731520" y="1463040"/>
+            <a:ext cx="5212080" cy="3749039"/>
           </a:xfrm>
           <a:prstGeom prst="rect">
             <a:avLst/>
@@ -4538,119 +4488,141 @@
           <a:noFill/>
         </p:spPr>
         <p:txBody>
-          <a:bodyPr wrap="square">
+          <a:bodyPr wrap="none">
             <a:spAutoFit/>
           </a:bodyPr>
           <a:lstStyle/>
           <a:p>
             <a:pPr algn="l">
+              <a:lnSpc>
+                <a:spcPct val="110000"/>
+              </a:lnSpc>
               <a:spcAft>
-                <a:spcPts val="600"/>
+                <a:spcPts val="800"/>
               </a:spcAft>
             </a:pPr>
             <a:r>
-              <a:rPr sz="1800" b="1">
-                <a:solidFill>
-                  <a:srgbClr val="005EB8"/>
+              <a:rPr sz="1800">
+                <a:solidFill>
+                  <a:srgbClr val="0F172A"/>
                 </a:solidFill>
                 <a:latin typeface="Arial"/>
               </a:rPr>
-              <a:t>Security and Governance</a:t>
-            </a:r>
-          </a:p>
-          <a:p>
-            <a:pPr algn="just">
+              <a:t>Frontend / Experience: Streamlit</a:t>
+            </a:r>
+          </a:p>
+          <a:p>
+            <a:pPr algn="l">
               <a:lnSpc>
-                <a:spcPct val="112000"/>
+                <a:spcPct val="110000"/>
               </a:lnSpc>
               <a:spcAft>
-                <a:spcPts val="600"/>
+                <a:spcPts val="800"/>
               </a:spcAft>
             </a:pPr>
             <a:r>
-              <a:rPr sz="1500">
+              <a:rPr sz="1800">
                 <a:solidFill>
                   <a:srgbClr val="0F172A"/>
                 </a:solidFill>
                 <a:latin typeface="Arial"/>
               </a:rPr>
-              <a:t>Secure login and sign-up with hashed passwords</a:t>
-            </a:r>
-          </a:p>
-          <a:p>
-            <a:pPr algn="just">
+              <a:t>Agent Orchestration: LangGraph, LangChain</a:t>
+            </a:r>
+          </a:p>
+          <a:p>
+            <a:pPr algn="l">
               <a:lnSpc>
-                <a:spcPct val="112000"/>
+                <a:spcPct val="110000"/>
               </a:lnSpc>
               <a:spcAft>
-                <a:spcPts val="600"/>
+                <a:spcPts val="800"/>
               </a:spcAft>
             </a:pPr>
             <a:r>
-              <a:rPr sz="1500">
+              <a:rPr sz="1800">
                 <a:solidFill>
                   <a:srgbClr val="0F172A"/>
                 </a:solidFill>
                 <a:latin typeface="Arial"/>
               </a:rPr>
-              <a:t>Admin-only approval and rejection control</a:t>
-            </a:r>
-          </a:p>
-          <a:p>
-            <a:pPr algn="just">
+              <a:t>Tool Integration: MCP / Tool layer</a:t>
+            </a:r>
+          </a:p>
+          <a:p>
+            <a:pPr algn="l">
               <a:lnSpc>
-                <a:spcPct val="112000"/>
+                <a:spcPct val="110000"/>
               </a:lnSpc>
               <a:spcAft>
-                <a:spcPts val="600"/>
+                <a:spcPts val="800"/>
               </a:spcAft>
             </a:pPr>
             <a:r>
-              <a:rPr sz="1500">
+              <a:rPr sz="1800">
                 <a:solidFill>
                   <a:srgbClr val="0F172A"/>
                 </a:solidFill>
                 <a:latin typeface="Arial"/>
               </a:rPr>
-              <a:t>Protected admin profile and user-level access rules</a:t>
-            </a:r>
-          </a:p>
-          <a:p>
-            <a:pPr algn="just">
+              <a:t>AI Model Layer: Azure OpenAI</a:t>
+            </a:r>
+          </a:p>
+          <a:p>
+            <a:pPr algn="l">
               <a:lnSpc>
-                <a:spcPct val="112000"/>
+                <a:spcPct val="110000"/>
               </a:lnSpc>
               <a:spcAft>
-                <a:spcPts val="600"/>
+                <a:spcPts val="800"/>
               </a:spcAft>
             </a:pPr>
             <a:r>
-              <a:rPr sz="1500">
+              <a:rPr sz="1800">
                 <a:solidFill>
                   <a:srgbClr val="0F172A"/>
                 </a:solidFill>
                 <a:latin typeface="Arial"/>
               </a:rPr>
-              <a:t>Password reset token handling with expiry and validation</a:t>
-            </a:r>
-          </a:p>
-          <a:p>
-            <a:pPr algn="just">
+              <a:t>Application Runtime: Python</a:t>
+            </a:r>
+          </a:p>
+          <a:p>
+            <a:pPr algn="l">
               <a:lnSpc>
-                <a:spcPct val="112000"/>
+                <a:spcPct val="110000"/>
               </a:lnSpc>
               <a:spcAft>
-                <a:spcPts val="600"/>
+                <a:spcPts val="800"/>
               </a:spcAft>
             </a:pPr>
             <a:r>
-              <a:rPr sz="1500">
+              <a:rPr sz="1800">
                 <a:solidFill>
                   <a:srgbClr val="0F172A"/>
                 </a:solidFill>
                 <a:latin typeface="Arial"/>
               </a:rPr>
-              <a:t>Safe DB initialization and production deployment hardening</a:t>
+              <a:t>Database: SQLite</a:t>
+            </a:r>
+          </a:p>
+          <a:p>
+            <a:pPr algn="l">
+              <a:lnSpc>
+                <a:spcPct val="110000"/>
+              </a:lnSpc>
+              <a:spcAft>
+                <a:spcPts val="800"/>
+              </a:spcAft>
+            </a:pPr>
+            <a:r>
+              <a:rPr sz="1800">
+                <a:solidFill>
+                  <a:srgbClr val="0F172A"/>
+                </a:solidFill>
+                <a:latin typeface="Arial"/>
+              </a:rPr>
+              <a:t>Email &amp; Notifications: SMTP / Email service</a:t>
             </a:r>
           </a:p>
         </p:txBody>
@@ -4663,8 +4635,145 @@
         </p:nvSpPr>
         <p:spPr>
           <a:xfrm>
-            <a:off x="164592" y="6473952"/>
-            <a:ext cx="11795760" cy="256032"/>
+            <a:off x="6309360" y="1463040"/>
+            <a:ext cx="4937760" cy="3749039"/>
+          </a:xfrm>
+          <a:prstGeom prst="rect">
+            <a:avLst/>
+          </a:prstGeom>
+          <a:noFill/>
+        </p:spPr>
+        <p:txBody>
+          <a:bodyPr wrap="none">
+            <a:spAutoFit/>
+          </a:bodyPr>
+          <a:lstStyle/>
+          <a:p>
+            <a:pPr algn="l">
+              <a:lnSpc>
+                <a:spcPct val="110000"/>
+              </a:lnSpc>
+              <a:spcAft>
+                <a:spcPts val="800"/>
+              </a:spcAft>
+            </a:pPr>
+            <a:r>
+              <a:rPr sz="1800">
+                <a:solidFill>
+                  <a:srgbClr val="0F172A"/>
+                </a:solidFill>
+                <a:latin typeface="Arial"/>
+              </a:rPr>
+              <a:t>Containerization: Docker</a:t>
+            </a:r>
+          </a:p>
+          <a:p>
+            <a:pPr algn="l">
+              <a:lnSpc>
+                <a:spcPct val="110000"/>
+              </a:lnSpc>
+              <a:spcAft>
+                <a:spcPts val="800"/>
+              </a:spcAft>
+            </a:pPr>
+            <a:r>
+              <a:rPr sz="1800">
+                <a:solidFill>
+                  <a:srgbClr val="0F172A"/>
+                </a:solidFill>
+                <a:latin typeface="Arial"/>
+              </a:rPr>
+              <a:t>Cloud Platform: Microsoft Azure</a:t>
+            </a:r>
+          </a:p>
+          <a:p>
+            <a:pPr algn="l">
+              <a:lnSpc>
+                <a:spcPct val="110000"/>
+              </a:lnSpc>
+              <a:spcAft>
+                <a:spcPts val="800"/>
+              </a:spcAft>
+            </a:pPr>
+            <a:r>
+              <a:rPr sz="1800">
+                <a:solidFill>
+                  <a:srgbClr val="0F172A"/>
+                </a:solidFill>
+                <a:latin typeface="Arial"/>
+              </a:rPr>
+              <a:t>Azure Services: App Service, Container Apps, Container Registry</a:t>
+            </a:r>
+          </a:p>
+          <a:p>
+            <a:pPr algn="l">
+              <a:lnSpc>
+                <a:spcPct val="110000"/>
+              </a:lnSpc>
+              <a:spcAft>
+                <a:spcPts val="800"/>
+              </a:spcAft>
+            </a:pPr>
+            <a:r>
+              <a:rPr sz="1800">
+                <a:solidFill>
+                  <a:srgbClr val="0F172A"/>
+                </a:solidFill>
+                <a:latin typeface="Arial"/>
+              </a:rPr>
+              <a:t>Deployment Automation: GitHub Actions</a:t>
+            </a:r>
+          </a:p>
+          <a:p>
+            <a:pPr algn="l">
+              <a:lnSpc>
+                <a:spcPct val="110000"/>
+              </a:lnSpc>
+              <a:spcAft>
+                <a:spcPts val="800"/>
+              </a:spcAft>
+            </a:pPr>
+            <a:r>
+              <a:rPr sz="1800">
+                <a:solidFill>
+                  <a:srgbClr val="0F172A"/>
+                </a:solidFill>
+                <a:latin typeface="Arial"/>
+              </a:rPr>
+              <a:t>Source Control: GitHub</a:t>
+            </a:r>
+          </a:p>
+          <a:p>
+            <a:pPr algn="l">
+              <a:lnSpc>
+                <a:spcPct val="110000"/>
+              </a:lnSpc>
+              <a:spcAft>
+                <a:spcPts val="800"/>
+              </a:spcAft>
+            </a:pPr>
+            <a:r>
+              <a:rPr sz="1800">
+                <a:solidFill>
+                  <a:srgbClr val="0F172A"/>
+                </a:solidFill>
+                <a:latin typeface="Arial"/>
+              </a:rPr>
+              <a:t>Production Pattern: CI/CD + environment secrets</a:t>
+            </a:r>
+          </a:p>
+        </p:txBody>
+      </p:sp>
+      <p:sp>
+        <p:nvSpPr>
+          <p:cNvPr id="7" name="TextBox 6"/>
+          <p:cNvSpPr txBox="1"/>
+          <p:nvPr/>
+        </p:nvSpPr>
+        <p:spPr>
+          <a:xfrm>
+            <a:off x="137160" y="6473952"/>
+            <a:ext cx="11795760" cy="237744"/>
           </a:xfrm>
           <a:prstGeom prst="rect">
             <a:avLst/>
@@ -4718,49 +4827,14 @@
       <p:grpSpPr/>
       <p:sp>
         <p:nvSpPr>
-          <p:cNvPr id="2" name="TextBox 1"/>
-          <p:cNvSpPr txBox="1"/>
-          <p:nvPr/>
-        </p:nvSpPr>
-        <p:spPr>
-          <a:xfrm>
-            <a:off x="548640" y="228600"/>
-            <a:ext cx="8229600" cy="640080"/>
-          </a:xfrm>
-          <a:prstGeom prst="rect">
-            <a:avLst/>
-          </a:prstGeom>
-          <a:noFill/>
-        </p:spPr>
-        <p:txBody>
-          <a:bodyPr wrap="none">
-            <a:spAutoFit/>
-          </a:bodyPr>
-          <a:lstStyle/>
-          <a:p>
-            <a:pPr algn="l"/>
-            <a:r>
-              <a:rPr sz="2400" b="1">
-                <a:solidFill>
-                  <a:srgbClr val="0F172A"/>
-                </a:solidFill>
-                <a:latin typeface="Arial"/>
-              </a:rPr>
-              <a:t>Technology Stack</a:t>
-            </a:r>
-          </a:p>
-        </p:txBody>
-      </p:sp>
-      <p:sp>
-        <p:nvSpPr>
-          <p:cNvPr id="3" name="Rectangle 2"/>
+          <p:cNvPr id="2" name="Rectangle 1"/>
           <p:cNvSpPr/>
           <p:nvPr/>
         </p:nvSpPr>
         <p:spPr>
           <a:xfrm>
-            <a:off x="548640" y="868680"/>
-            <a:ext cx="1828800" cy="73152"/>
+            <a:off x="0" y="0"/>
+            <a:ext cx="12191695" cy="384048"/>
           </a:xfrm>
           <a:prstGeom prst="rect">
             <a:avLst/>
@@ -4796,14 +4870,14 @@
       </p:sp>
       <p:sp>
         <p:nvSpPr>
-          <p:cNvPr id="4" name="TextBox 3"/>
+          <p:cNvPr id="3" name="TextBox 2"/>
           <p:cNvSpPr txBox="1"/>
           <p:nvPr/>
         </p:nvSpPr>
         <p:spPr>
           <a:xfrm>
-            <a:off x="731520" y="1463040"/>
-            <a:ext cx="5212080" cy="3840480"/>
+            <a:off x="548640" y="502920"/>
+            <a:ext cx="7315200" cy="640080"/>
           </a:xfrm>
           <a:prstGeom prst="rect">
             <a:avLst/>
@@ -4816,137 +4890,59 @@
           </a:bodyPr>
           <a:lstStyle/>
           <a:p>
-            <a:pPr algn="l">
-              <a:lnSpc>
-                <a:spcPct val="115000"/>
-              </a:lnSpc>
-              <a:spcAft>
-                <a:spcPts val="800"/>
-              </a:spcAft>
-            </a:pPr>
-            <a:r>
-              <a:rPr sz="1800">
+            <a:pPr algn="l"/>
+            <a:r>
+              <a:rPr sz="2400" b="1">
                 <a:solidFill>
                   <a:srgbClr val="0F172A"/>
                 </a:solidFill>
                 <a:latin typeface="Arial"/>
               </a:rPr>
-              <a:t>Frontend / Experience: Streamlit</a:t>
-            </a:r>
-          </a:p>
-          <a:p>
-            <a:pPr algn="l">
-              <a:lnSpc>
-                <a:spcPct val="115000"/>
-              </a:lnSpc>
-              <a:spcAft>
-                <a:spcPts val="800"/>
-              </a:spcAft>
-            </a:pPr>
-            <a:r>
-              <a:rPr sz="1800">
-                <a:solidFill>
-                  <a:srgbClr val="0F172A"/>
-                </a:solidFill>
-                <a:latin typeface="Arial"/>
-              </a:rPr>
-              <a:t>Agent Orchestration: LangGraph, LangChain</a:t>
-            </a:r>
-          </a:p>
-          <a:p>
-            <a:pPr algn="l">
-              <a:lnSpc>
-                <a:spcPct val="115000"/>
-              </a:lnSpc>
-              <a:spcAft>
-                <a:spcPts val="800"/>
-              </a:spcAft>
-            </a:pPr>
-            <a:r>
-              <a:rPr sz="1800">
-                <a:solidFill>
-                  <a:srgbClr val="0F172A"/>
-                </a:solidFill>
-                <a:latin typeface="Arial"/>
-              </a:rPr>
-              <a:t>Tool Integration: MCP / Tool layer</a:t>
-            </a:r>
-          </a:p>
-          <a:p>
-            <a:pPr algn="l">
-              <a:lnSpc>
-                <a:spcPct val="115000"/>
-              </a:lnSpc>
-              <a:spcAft>
-                <a:spcPts val="800"/>
-              </a:spcAft>
-            </a:pPr>
-            <a:r>
-              <a:rPr sz="1800">
-                <a:solidFill>
-                  <a:srgbClr val="0F172A"/>
-                </a:solidFill>
-                <a:latin typeface="Arial"/>
-              </a:rPr>
-              <a:t>AI Model Layer: Azure OpenAI</a:t>
-            </a:r>
-          </a:p>
-          <a:p>
-            <a:pPr algn="l">
-              <a:lnSpc>
-                <a:spcPct val="115000"/>
-              </a:lnSpc>
-              <a:spcAft>
-                <a:spcPts val="800"/>
-              </a:spcAft>
-            </a:pPr>
-            <a:r>
-              <a:rPr sz="1800">
-                <a:solidFill>
-                  <a:srgbClr val="0F172A"/>
-                </a:solidFill>
-                <a:latin typeface="Arial"/>
-              </a:rPr>
-              <a:t>Application Runtime: Python</a:t>
-            </a:r>
-          </a:p>
-          <a:p>
-            <a:pPr algn="l">
-              <a:lnSpc>
-                <a:spcPct val="115000"/>
-              </a:lnSpc>
-              <a:spcAft>
-                <a:spcPts val="800"/>
-              </a:spcAft>
-            </a:pPr>
-            <a:r>
-              <a:rPr sz="1800">
-                <a:solidFill>
-                  <a:srgbClr val="0F172A"/>
-                </a:solidFill>
-                <a:latin typeface="Arial"/>
-              </a:rPr>
-              <a:t>Database: SQLite</a:t>
-            </a:r>
-          </a:p>
-          <a:p>
-            <a:pPr algn="l">
-              <a:lnSpc>
-                <a:spcPct val="115000"/>
-              </a:lnSpc>
-              <a:spcAft>
-                <a:spcPts val="800"/>
-              </a:spcAft>
-            </a:pPr>
-            <a:r>
-              <a:rPr sz="1800">
-                <a:solidFill>
-                  <a:srgbClr val="0F172A"/>
-                </a:solidFill>
-                <a:latin typeface="Arial"/>
-              </a:rPr>
-              <a:t>Email &amp; Notifications: SMTP / Email service</a:t>
-            </a:r>
+              <a:t>Core Features</a:t>
+            </a:r>
+          </a:p>
+        </p:txBody>
+      </p:sp>
+      <p:sp>
+        <p:nvSpPr>
+          <p:cNvPr id="4" name="Rectangle 3"/>
+          <p:cNvSpPr/>
+          <p:nvPr/>
+        </p:nvSpPr>
+        <p:spPr>
+          <a:xfrm>
+            <a:off x="548640" y="914400"/>
+            <a:ext cx="1920240" cy="73152"/>
+          </a:xfrm>
+          <a:prstGeom prst="rect">
+            <a:avLst/>
+          </a:prstGeom>
+          <a:solidFill>
+            <a:srgbClr val="0EA5E9"/>
+          </a:solidFill>
+          <a:ln>
+            <a:noFill/>
+          </a:ln>
+        </p:spPr>
+        <p:style>
+          <a:lnRef idx="1">
+            <a:schemeClr val="accent1"/>
+          </a:lnRef>
+          <a:fillRef idx="3">
+            <a:schemeClr val="accent1"/>
+          </a:fillRef>
+          <a:effectRef idx="2">
+            <a:schemeClr val="accent1"/>
+          </a:effectRef>
+          <a:fontRef idx="minor">
+            <a:schemeClr val="lt1"/>
+          </a:fontRef>
+        </p:style>
+        <p:txBody>
+          <a:bodyPr rtlCol="0" anchor="ctr"/>
+          <a:lstStyle/>
+          <a:p>
+            <a:pPr algn="ctr"/>
           </a:p>
         </p:txBody>
       </p:sp>
@@ -4958,8 +4954,8 @@
         </p:nvSpPr>
         <p:spPr>
           <a:xfrm>
-            <a:off x="6309360" y="1463040"/>
-            <a:ext cx="5120640" cy="3840480"/>
+            <a:off x="640080" y="1371600"/>
+            <a:ext cx="5212080" cy="4389120"/>
           </a:xfrm>
           <a:prstGeom prst="rect">
             <a:avLst/>
@@ -4974,115 +4970,115 @@
           <a:p>
             <a:pPr algn="l">
               <a:lnSpc>
-                <a:spcPct val="115000"/>
+                <a:spcPct val="112000"/>
               </a:lnSpc>
               <a:spcAft>
-                <a:spcPts val="800"/>
+                <a:spcPts val="700"/>
               </a:spcAft>
             </a:pPr>
             <a:r>
-              <a:rPr sz="1800">
-                <a:solidFill>
-                  <a:srgbClr val="0F172A"/>
+              <a:rPr sz="1800" b="1">
+                <a:solidFill>
+                  <a:srgbClr val="005EB8"/>
                 </a:solidFill>
                 <a:latin typeface="Arial"/>
               </a:rPr>
-              <a:t>Containerization: Docker</a:t>
+              <a:t>Operational Functions</a:t>
             </a:r>
           </a:p>
           <a:p>
             <a:pPr algn="l">
               <a:lnSpc>
-                <a:spcPct val="115000"/>
+                <a:spcPct val="112000"/>
               </a:lnSpc>
               <a:spcAft>
-                <a:spcPts val="800"/>
+                <a:spcPts val="700"/>
               </a:spcAft>
             </a:pPr>
             <a:r>
-              <a:rPr sz="1800">
+              <a:rPr sz="1600" b="0">
                 <a:solidFill>
                   <a:srgbClr val="0F172A"/>
                 </a:solidFill>
                 <a:latin typeface="Arial"/>
               </a:rPr>
-              <a:t>Cloud Platform: Microsoft Azure</a:t>
+              <a:t>Knowledge search and IT guidance lookup</a:t>
             </a:r>
           </a:p>
           <a:p>
             <a:pPr algn="l">
               <a:lnSpc>
-                <a:spcPct val="115000"/>
+                <a:spcPct val="112000"/>
               </a:lnSpc>
               <a:spcAft>
-                <a:spcPts val="800"/>
+                <a:spcPts val="700"/>
               </a:spcAft>
             </a:pPr>
             <a:r>
-              <a:rPr sz="1800">
+              <a:rPr sz="1600" b="0">
                 <a:solidFill>
                   <a:srgbClr val="0F172A"/>
                 </a:solidFill>
                 <a:latin typeface="Arial"/>
               </a:rPr>
-              <a:t>Azure Services: App Service, Container Apps, Container Registry</a:t>
+              <a:t>Ticket lookup, creation, and status tracking</a:t>
             </a:r>
           </a:p>
           <a:p>
             <a:pPr algn="l">
               <a:lnSpc>
-                <a:spcPct val="115000"/>
+                <a:spcPct val="112000"/>
               </a:lnSpc>
               <a:spcAft>
-                <a:spcPts val="800"/>
+                <a:spcPts val="700"/>
               </a:spcAft>
             </a:pPr>
             <a:r>
-              <a:rPr sz="1800">
+              <a:rPr sz="1600" b="0">
                 <a:solidFill>
                   <a:srgbClr val="0F172A"/>
                 </a:solidFill>
                 <a:latin typeface="Arial"/>
               </a:rPr>
-              <a:t>Deployment Automation: GitHub Actions</a:t>
+              <a:t>Employee registration and database persistence</a:t>
             </a:r>
           </a:p>
           <a:p>
             <a:pPr algn="l">
               <a:lnSpc>
-                <a:spcPct val="115000"/>
+                <a:spcPct val="112000"/>
               </a:lnSpc>
               <a:spcAft>
-                <a:spcPts val="800"/>
+                <a:spcPts val="700"/>
               </a:spcAft>
             </a:pPr>
             <a:r>
-              <a:rPr sz="1800">
+              <a:rPr sz="1600" b="0">
                 <a:solidFill>
                   <a:srgbClr val="0F172A"/>
                 </a:solidFill>
                 <a:latin typeface="Arial"/>
               </a:rPr>
-              <a:t>Source Control: GitHub</a:t>
+              <a:t>VPN first-time setup and password reset workflows</a:t>
             </a:r>
           </a:p>
           <a:p>
             <a:pPr algn="l">
               <a:lnSpc>
-                <a:spcPct val="115000"/>
+                <a:spcPct val="112000"/>
               </a:lnSpc>
               <a:spcAft>
-                <a:spcPts val="800"/>
+                <a:spcPts val="700"/>
               </a:spcAft>
             </a:pPr>
             <a:r>
-              <a:rPr sz="1800">
+              <a:rPr sz="1600" b="0">
                 <a:solidFill>
                   <a:srgbClr val="0F172A"/>
                 </a:solidFill>
                 <a:latin typeface="Arial"/>
               </a:rPr>
-              <a:t>Production Pattern: CI/CD + environment secrets</a:t>
+              <a:t>Email dispatch for password and approval actions</a:t>
             </a:r>
           </a:p>
         </p:txBody>
@@ -5095,8 +5091,145 @@
         </p:nvSpPr>
         <p:spPr>
           <a:xfrm>
-            <a:off x="164592" y="6473952"/>
-            <a:ext cx="11795760" cy="256032"/>
+            <a:off x="6217920" y="1371600"/>
+            <a:ext cx="5120640" cy="4389120"/>
+          </a:xfrm>
+          <a:prstGeom prst="rect">
+            <a:avLst/>
+          </a:prstGeom>
+          <a:noFill/>
+        </p:spPr>
+        <p:txBody>
+          <a:bodyPr wrap="none">
+            <a:spAutoFit/>
+          </a:bodyPr>
+          <a:lstStyle/>
+          <a:p>
+            <a:pPr algn="l">
+              <a:lnSpc>
+                <a:spcPct val="112000"/>
+              </a:lnSpc>
+              <a:spcAft>
+                <a:spcPts val="700"/>
+              </a:spcAft>
+            </a:pPr>
+            <a:r>
+              <a:rPr sz="1800" b="1">
+                <a:solidFill>
+                  <a:srgbClr val="005EB8"/>
+                </a:solidFill>
+                <a:latin typeface="Arial"/>
+              </a:rPr>
+              <a:t>Security and Governance</a:t>
+            </a:r>
+          </a:p>
+          <a:p>
+            <a:pPr algn="l">
+              <a:lnSpc>
+                <a:spcPct val="112000"/>
+              </a:lnSpc>
+              <a:spcAft>
+                <a:spcPts val="700"/>
+              </a:spcAft>
+            </a:pPr>
+            <a:r>
+              <a:rPr sz="1600" b="0">
+                <a:solidFill>
+                  <a:srgbClr val="0F172A"/>
+                </a:solidFill>
+                <a:latin typeface="Arial"/>
+              </a:rPr>
+              <a:t>Secure login and sign-up with hashed passwords</a:t>
+            </a:r>
+          </a:p>
+          <a:p>
+            <a:pPr algn="l">
+              <a:lnSpc>
+                <a:spcPct val="112000"/>
+              </a:lnSpc>
+              <a:spcAft>
+                <a:spcPts val="700"/>
+              </a:spcAft>
+            </a:pPr>
+            <a:r>
+              <a:rPr sz="1600" b="0">
+                <a:solidFill>
+                  <a:srgbClr val="0F172A"/>
+                </a:solidFill>
+                <a:latin typeface="Arial"/>
+              </a:rPr>
+              <a:t>Admin-only approval and rejection control</a:t>
+            </a:r>
+          </a:p>
+          <a:p>
+            <a:pPr algn="l">
+              <a:lnSpc>
+                <a:spcPct val="112000"/>
+              </a:lnSpc>
+              <a:spcAft>
+                <a:spcPts val="700"/>
+              </a:spcAft>
+            </a:pPr>
+            <a:r>
+              <a:rPr sz="1600" b="0">
+                <a:solidFill>
+                  <a:srgbClr val="0F172A"/>
+                </a:solidFill>
+                <a:latin typeface="Arial"/>
+              </a:rPr>
+              <a:t>Protected admin profile and user-level access rules</a:t>
+            </a:r>
+          </a:p>
+          <a:p>
+            <a:pPr algn="l">
+              <a:lnSpc>
+                <a:spcPct val="112000"/>
+              </a:lnSpc>
+              <a:spcAft>
+                <a:spcPts val="700"/>
+              </a:spcAft>
+            </a:pPr>
+            <a:r>
+              <a:rPr sz="1600" b="0">
+                <a:solidFill>
+                  <a:srgbClr val="0F172A"/>
+                </a:solidFill>
+                <a:latin typeface="Arial"/>
+              </a:rPr>
+              <a:t>Password reset token handling with expiry and validation</a:t>
+            </a:r>
+          </a:p>
+          <a:p>
+            <a:pPr algn="l">
+              <a:lnSpc>
+                <a:spcPct val="112000"/>
+              </a:lnSpc>
+              <a:spcAft>
+                <a:spcPts val="700"/>
+              </a:spcAft>
+            </a:pPr>
+            <a:r>
+              <a:rPr sz="1600" b="0">
+                <a:solidFill>
+                  <a:srgbClr val="0F172A"/>
+                </a:solidFill>
+                <a:latin typeface="Arial"/>
+              </a:rPr>
+              <a:t>Safe DB initialization and deployment hardening</a:t>
+            </a:r>
+          </a:p>
+        </p:txBody>
+      </p:sp>
+      <p:sp>
+        <p:nvSpPr>
+          <p:cNvPr id="7" name="TextBox 6"/>
+          <p:cNvSpPr txBox="1"/>
+          <p:nvPr/>
+        </p:nvSpPr>
+        <p:spPr>
+          <a:xfrm>
+            <a:off x="137160" y="6473952"/>
+            <a:ext cx="11795760" cy="237744"/>
           </a:xfrm>
           <a:prstGeom prst="rect">
             <a:avLst/>
@@ -5150,49 +5283,14 @@
       <p:grpSpPr/>
       <p:sp>
         <p:nvSpPr>
-          <p:cNvPr id="2" name="TextBox 1"/>
-          <p:cNvSpPr txBox="1"/>
-          <p:nvPr/>
-        </p:nvSpPr>
-        <p:spPr>
-          <a:xfrm>
-            <a:off x="548640" y="228600"/>
-            <a:ext cx="8229600" cy="640080"/>
-          </a:xfrm>
-          <a:prstGeom prst="rect">
-            <a:avLst/>
-          </a:prstGeom>
-          <a:noFill/>
-        </p:spPr>
-        <p:txBody>
-          <a:bodyPr wrap="none">
-            <a:spAutoFit/>
-          </a:bodyPr>
-          <a:lstStyle/>
-          <a:p>
-            <a:pPr algn="l"/>
-            <a:r>
-              <a:rPr sz="2400" b="1">
-                <a:solidFill>
-                  <a:srgbClr val="0F172A"/>
-                </a:solidFill>
-                <a:latin typeface="Arial"/>
-              </a:rPr>
-              <a:t>Containerization and CI/CD</a:t>
-            </a:r>
-          </a:p>
-        </p:txBody>
-      </p:sp>
-      <p:sp>
-        <p:nvSpPr>
-          <p:cNvPr id="3" name="Rectangle 2"/>
+          <p:cNvPr id="2" name="Rectangle 1"/>
           <p:cNvSpPr/>
           <p:nvPr/>
         </p:nvSpPr>
         <p:spPr>
           <a:xfrm>
-            <a:off x="548640" y="868680"/>
-            <a:ext cx="1828800" cy="73152"/>
+            <a:off x="0" y="0"/>
+            <a:ext cx="12191695" cy="384048"/>
           </a:xfrm>
           <a:prstGeom prst="rect">
             <a:avLst/>
@@ -5228,14 +5326,14 @@
       </p:sp>
       <p:sp>
         <p:nvSpPr>
-          <p:cNvPr id="4" name="TextBox 3"/>
+          <p:cNvPr id="3" name="TextBox 2"/>
           <p:cNvSpPr txBox="1"/>
           <p:nvPr/>
         </p:nvSpPr>
         <p:spPr>
           <a:xfrm>
-            <a:off x="731520" y="1371600"/>
-            <a:ext cx="10698480" cy="4206240"/>
+            <a:off x="548640" y="502920"/>
+            <a:ext cx="7315200" cy="640080"/>
           </a:xfrm>
           <a:prstGeom prst="rect">
             <a:avLst/>
@@ -5243,60 +5341,316 @@
           <a:noFill/>
         </p:spPr>
         <p:txBody>
-          <a:bodyPr wrap="square">
+          <a:bodyPr wrap="none">
             <a:spAutoFit/>
           </a:bodyPr>
           <a:lstStyle/>
           <a:p>
+            <a:pPr algn="l"/>
+            <a:r>
+              <a:rPr sz="2400" b="1">
+                <a:solidFill>
+                  <a:srgbClr val="0F172A"/>
+                </a:solidFill>
+                <a:latin typeface="Arial"/>
+              </a:rPr>
+              <a:t>Deployment &amp; Live URL</a:t>
+            </a:r>
+          </a:p>
+        </p:txBody>
+      </p:sp>
+      <p:sp>
+        <p:nvSpPr>
+          <p:cNvPr id="4" name="Rectangle 3"/>
+          <p:cNvSpPr/>
+          <p:nvPr/>
+        </p:nvSpPr>
+        <p:spPr>
+          <a:xfrm>
+            <a:off x="548640" y="914400"/>
+            <a:ext cx="1920240" cy="73152"/>
+          </a:xfrm>
+          <a:prstGeom prst="rect">
+            <a:avLst/>
+          </a:prstGeom>
+          <a:solidFill>
+            <a:srgbClr val="0EA5E9"/>
+          </a:solidFill>
+          <a:ln>
+            <a:noFill/>
+          </a:ln>
+        </p:spPr>
+        <p:style>
+          <a:lnRef idx="1">
+            <a:schemeClr val="accent1"/>
+          </a:lnRef>
+          <a:fillRef idx="3">
+            <a:schemeClr val="accent1"/>
+          </a:fillRef>
+          <a:effectRef idx="2">
+            <a:schemeClr val="accent1"/>
+          </a:effectRef>
+          <a:fontRef idx="minor">
+            <a:schemeClr val="lt1"/>
+          </a:fontRef>
+        </p:style>
+        <p:txBody>
+          <a:bodyPr rtlCol="0" anchor="ctr"/>
+          <a:lstStyle/>
+          <a:p>
+            <a:pPr algn="ctr"/>
+          </a:p>
+        </p:txBody>
+      </p:sp>
+      <p:sp>
+        <p:nvSpPr>
+          <p:cNvPr id="5" name="Rounded Rectangle 4"/>
+          <p:cNvSpPr/>
+          <p:nvPr/>
+        </p:nvSpPr>
+        <p:spPr>
+          <a:xfrm>
+            <a:off x="731520" y="1554480"/>
+            <a:ext cx="10698480" cy="3474720"/>
+          </a:xfrm>
+          <a:prstGeom prst="roundRect">
+            <a:avLst/>
+          </a:prstGeom>
+          <a:solidFill>
+            <a:srgbClr val="F0F7FF"/>
+          </a:solidFill>
+          <a:ln>
+            <a:solidFill>
+              <a:srgbClr val="005EB8"/>
+            </a:solidFill>
+          </a:ln>
+        </p:spPr>
+        <p:style>
+          <a:lnRef idx="1">
+            <a:schemeClr val="accent1"/>
+          </a:lnRef>
+          <a:fillRef idx="3">
+            <a:schemeClr val="accent1"/>
+          </a:fillRef>
+          <a:effectRef idx="2">
+            <a:schemeClr val="accent1"/>
+          </a:effectRef>
+          <a:fontRef idx="minor">
+            <a:schemeClr val="lt1"/>
+          </a:fontRef>
+        </p:style>
+        <p:txBody>
+          <a:bodyPr rtlCol="0" anchor="ctr"/>
+          <a:lstStyle/>
+          <a:p>
+            <a:pPr algn="ctr"/>
+          </a:p>
+        </p:txBody>
+      </p:sp>
+      <p:sp>
+        <p:nvSpPr>
+          <p:cNvPr id="6" name="TextBox 5"/>
+          <p:cNvSpPr txBox="1"/>
+          <p:nvPr/>
+        </p:nvSpPr>
+        <p:spPr>
+          <a:xfrm>
+            <a:off x="1005840" y="1828800"/>
+            <a:ext cx="10058400" cy="2834640"/>
+          </a:xfrm>
+          <a:prstGeom prst="rect">
+            <a:avLst/>
+          </a:prstGeom>
+          <a:noFill/>
+        </p:spPr>
+        <p:txBody>
+          <a:bodyPr wrap="none">
+            <a:spAutoFit/>
+          </a:bodyPr>
+          <a:lstStyle/>
+          <a:p>
+            <a:pPr algn="l">
+              <a:lnSpc>
+                <a:spcPct val="110000"/>
+              </a:lnSpc>
+              <a:spcAft>
+                <a:spcPts val="500"/>
+              </a:spcAft>
+            </a:pPr>
+            <a:r>
+              <a:rPr sz="1700" b="1">
+                <a:solidFill>
+                  <a:srgbClr val="005EB8"/>
+                </a:solidFill>
+                <a:latin typeface="Arial"/>
+              </a:rPr>
+              <a:t>Live Application URL:</a:t>
+            </a:r>
+          </a:p>
+          <a:p>
+            <a:pPr algn="l">
+              <a:lnSpc>
+                <a:spcPct val="110000"/>
+              </a:lnSpc>
+              <a:spcAft>
+                <a:spcPts val="500"/>
+              </a:spcAft>
+            </a:pPr>
+            <a:r>
+              <a:rPr sz="1500">
+                <a:solidFill>
+                  <a:srgbClr val="0F172A"/>
+                </a:solidFill>
+                <a:latin typeface="Arial"/>
+              </a:rPr>
+              <a:t>https://it-support-ajay-001.azurewebsites.net/</a:t>
+            </a:r>
+          </a:p>
+          <a:p>
+            <a:pPr algn="l">
+              <a:lnSpc>
+                <a:spcPct val="110000"/>
+              </a:lnSpc>
+              <a:spcAft>
+                <a:spcPts val="500"/>
+              </a:spcAft>
+            </a:pPr>
+            <a:r>
+              <a:rPr sz="1700" b="1">
+                <a:solidFill>
+                  <a:srgbClr val="005EB8"/>
+                </a:solidFill>
+                <a:latin typeface="Arial"/>
+              </a:rPr>
+              <a:t>GitHub Repository:</a:t>
+            </a:r>
+          </a:p>
+          <a:p>
+            <a:pPr algn="l">
+              <a:lnSpc>
+                <a:spcPct val="110000"/>
+              </a:lnSpc>
+              <a:spcAft>
+                <a:spcPts val="500"/>
+              </a:spcAft>
+            </a:pPr>
+            <a:r>
+              <a:rPr sz="1500">
+                <a:solidFill>
+                  <a:srgbClr val="0F172A"/>
+                </a:solidFill>
+                <a:latin typeface="Arial"/>
+              </a:rPr>
+              <a:t>https://github.com/helloajay21-max/-it-support-assistant</a:t>
+            </a:r>
+          </a:p>
+          <a:p>
+            <a:pPr algn="l">
+              <a:lnSpc>
+                <a:spcPct val="110000"/>
+              </a:lnSpc>
+              <a:spcAft>
+                <a:spcPts val="500"/>
+              </a:spcAft>
+            </a:pPr>
+            <a:r>
+              <a:rPr sz="1700" b="1">
+                <a:solidFill>
+                  <a:srgbClr val="005EB8"/>
+                </a:solidFill>
+                <a:latin typeface="Arial"/>
+              </a:rPr>
+              <a:t>Deployment Model:</a:t>
+            </a:r>
+          </a:p>
+          <a:p>
             <a:pPr algn="just">
               <a:lnSpc>
-                <a:spcPct val="115000"/>
+                <a:spcPct val="110000"/>
               </a:lnSpc>
               <a:spcAft>
-                <a:spcPts val="600"/>
+                <a:spcPts val="500"/>
               </a:spcAft>
             </a:pPr>
             <a:r>
-              <a:rPr sz="1900">
+              <a:rPr sz="1400">
                 <a:solidFill>
                   <a:srgbClr val="0F172A"/>
                 </a:solidFill>
                 <a:latin typeface="Arial"/>
               </a:rPr>
-              <a:t>Source code is managed in GitHub and built into a reproducible Docker image. The pipeline automates image creation, pushes it to the registry, and deploys the application to Azure. This enables consistent, repeatable delivery and production deployment without manual configuration inside the source code.</a:t>
+              <a:t>? GitHub push triggers GitHub Actions</a:t>
             </a:r>
           </a:p>
           <a:p>
             <a:pPr algn="just">
               <a:lnSpc>
-                <a:spcPct val="115000"/>
+                <a:spcPct val="110000"/>
               </a:lnSpc>
               <a:spcAft>
-                <a:spcPts val="600"/>
+                <a:spcPts val="500"/>
               </a:spcAft>
             </a:pPr>
             <a:r>
-              <a:rPr sz="1900">
+              <a:rPr sz="1400">
                 <a:solidFill>
                   <a:srgbClr val="0F172A"/>
                 </a:solidFill>
                 <a:latin typeface="Arial"/>
               </a:rPr>
-              <a:t>The deployment workflow integrates Azure App Service and container-based runtime services while keeping environment-specific values such as API keys, SMTP configuration, and the admin password in secure GitHub and Azure settings.</a:t>
-            </a:r>
-          </a:p>
-        </p:txBody>
-      </p:sp>
-      <p:sp>
-        <p:nvSpPr>
-          <p:cNvPr id="5" name="TextBox 4"/>
+              <a:t>? Docker image is built and uploaded to Docker Hub</a:t>
+            </a:r>
+          </a:p>
+          <a:p>
+            <a:pPr algn="just">
+              <a:lnSpc>
+                <a:spcPct val="110000"/>
+              </a:lnSpc>
+              <a:spcAft>
+                <a:spcPts val="500"/>
+              </a:spcAft>
+            </a:pPr>
+            <a:r>
+              <a:rPr sz="1400">
+                <a:solidFill>
+                  <a:srgbClr val="0F172A"/>
+                </a:solidFill>
+                <a:latin typeface="Arial"/>
+              </a:rPr>
+              <a:t>? Azure App Service updates automatically</a:t>
+            </a:r>
+          </a:p>
+          <a:p>
+            <a:pPr algn="just">
+              <a:lnSpc>
+                <a:spcPct val="110000"/>
+              </a:lnSpc>
+              <a:spcAft>
+                <a:spcPts val="500"/>
+              </a:spcAft>
+            </a:pPr>
+            <a:r>
+              <a:rPr sz="1400">
+                <a:solidFill>
+                  <a:srgbClr val="0F172A"/>
+                </a:solidFill>
+                <a:latin typeface="Arial"/>
+              </a:rPr>
+              <a:t>? Application restarts after successful deployment</a:t>
+            </a:r>
+          </a:p>
+        </p:txBody>
+      </p:sp>
+      <p:sp>
+        <p:nvSpPr>
+          <p:cNvPr id="7" name="TextBox 6"/>
           <p:cNvSpPr txBox="1"/>
           <p:nvPr/>
         </p:nvSpPr>
         <p:spPr>
           <a:xfrm>
-            <a:off x="164592" y="6473952"/>
-            <a:ext cx="11795760" cy="256032"/>
+            <a:off x="137160" y="6473952"/>
+            <a:ext cx="11795760" cy="237744"/>
           </a:xfrm>
           <a:prstGeom prst="rect">
             <a:avLst/>
@@ -5350,49 +5704,14 @@
       <p:grpSpPr/>
       <p:sp>
         <p:nvSpPr>
-          <p:cNvPr id="2" name="TextBox 1"/>
-          <p:cNvSpPr txBox="1"/>
-          <p:nvPr/>
-        </p:nvSpPr>
-        <p:spPr>
-          <a:xfrm>
-            <a:off x="548640" y="228600"/>
-            <a:ext cx="8229600" cy="640080"/>
-          </a:xfrm>
-          <a:prstGeom prst="rect">
-            <a:avLst/>
-          </a:prstGeom>
-          <a:noFill/>
-        </p:spPr>
-        <p:txBody>
-          <a:bodyPr wrap="none">
-            <a:spAutoFit/>
-          </a:bodyPr>
-          <a:lstStyle/>
-          <a:p>
-            <a:pPr algn="l"/>
-            <a:r>
-              <a:rPr sz="2400" b="1">
-                <a:solidFill>
-                  <a:srgbClr val="0F172A"/>
-                </a:solidFill>
-                <a:latin typeface="Arial"/>
-              </a:rPr>
-              <a:t>Conclusion</a:t>
-            </a:r>
-          </a:p>
-        </p:txBody>
-      </p:sp>
-      <p:sp>
-        <p:nvSpPr>
-          <p:cNvPr id="3" name="Rectangle 2"/>
+          <p:cNvPr id="2" name="Rectangle 1"/>
           <p:cNvSpPr/>
           <p:nvPr/>
         </p:nvSpPr>
         <p:spPr>
           <a:xfrm>
-            <a:off x="548640" y="868680"/>
-            <a:ext cx="1828800" cy="73152"/>
+            <a:off x="0" y="0"/>
+            <a:ext cx="12191695" cy="384048"/>
           </a:xfrm>
           <a:prstGeom prst="rect">
             <a:avLst/>
@@ -5428,14 +5747,14 @@
       </p:sp>
       <p:sp>
         <p:nvSpPr>
-          <p:cNvPr id="4" name="TextBox 3"/>
+          <p:cNvPr id="3" name="TextBox 2"/>
           <p:cNvSpPr txBox="1"/>
           <p:nvPr/>
         </p:nvSpPr>
         <p:spPr>
           <a:xfrm>
-            <a:off x="731520" y="1554480"/>
-            <a:ext cx="10698480" cy="4023360"/>
+            <a:off x="548640" y="502920"/>
+            <a:ext cx="7315200" cy="640080"/>
           </a:xfrm>
           <a:prstGeom prst="rect">
             <a:avLst/>
@@ -5443,6 +5762,84 @@
           <a:noFill/>
         </p:spPr>
         <p:txBody>
+          <a:bodyPr wrap="none">
+            <a:spAutoFit/>
+          </a:bodyPr>
+          <a:lstStyle/>
+          <a:p>
+            <a:pPr algn="l"/>
+            <a:r>
+              <a:rPr sz="2400" b="1">
+                <a:solidFill>
+                  <a:srgbClr val="0F172A"/>
+                </a:solidFill>
+                <a:latin typeface="Arial"/>
+              </a:rPr>
+              <a:t>Conclusion</a:t>
+            </a:r>
+          </a:p>
+        </p:txBody>
+      </p:sp>
+      <p:sp>
+        <p:nvSpPr>
+          <p:cNvPr id="4" name="Rectangle 3"/>
+          <p:cNvSpPr/>
+          <p:nvPr/>
+        </p:nvSpPr>
+        <p:spPr>
+          <a:xfrm>
+            <a:off x="548640" y="914400"/>
+            <a:ext cx="1920240" cy="73152"/>
+          </a:xfrm>
+          <a:prstGeom prst="rect">
+            <a:avLst/>
+          </a:prstGeom>
+          <a:solidFill>
+            <a:srgbClr val="0EA5E9"/>
+          </a:solidFill>
+          <a:ln>
+            <a:noFill/>
+          </a:ln>
+        </p:spPr>
+        <p:style>
+          <a:lnRef idx="1">
+            <a:schemeClr val="accent1"/>
+          </a:lnRef>
+          <a:fillRef idx="3">
+            <a:schemeClr val="accent1"/>
+          </a:fillRef>
+          <a:effectRef idx="2">
+            <a:schemeClr val="accent1"/>
+          </a:effectRef>
+          <a:fontRef idx="minor">
+            <a:schemeClr val="lt1"/>
+          </a:fontRef>
+        </p:style>
+        <p:txBody>
+          <a:bodyPr rtlCol="0" anchor="ctr"/>
+          <a:lstStyle/>
+          <a:p>
+            <a:pPr algn="ctr"/>
+          </a:p>
+        </p:txBody>
+      </p:sp>
+      <p:sp>
+        <p:nvSpPr>
+          <p:cNvPr id="5" name="TextBox 4"/>
+          <p:cNvSpPr txBox="1"/>
+          <p:nvPr/>
+        </p:nvSpPr>
+        <p:spPr>
+          <a:xfrm>
+            <a:off x="731520" y="1645920"/>
+            <a:ext cx="10698480" cy="3931920"/>
+          </a:xfrm>
+          <a:prstGeom prst="rect">
+            <a:avLst/>
+          </a:prstGeom>
+          <a:noFill/>
+        </p:spPr>
+        <p:txBody>
           <a:bodyPr wrap="square">
             <a:spAutoFit/>
           </a:bodyPr>
@@ -5450,53 +5847,72 @@
           <a:p>
             <a:pPr algn="just">
               <a:lnSpc>
-                <a:spcPct val="115000"/>
+                <a:spcPct val="110000"/>
               </a:lnSpc>
               <a:spcAft>
-                <a:spcPts val="600"/>
+                <a:spcPts val="800"/>
               </a:spcAft>
             </a:pPr>
             <a:r>
-              <a:rPr sz="2000">
+              <a:rPr sz="2000" b="0">
                 <a:solidFill>
                   <a:srgbClr val="0F172A"/>
                 </a:solidFill>
                 <a:latin typeface="Arial"/>
               </a:rPr>
-              <a:t>The IT Support Assistant delivers an agentic AI-powered support experience combining secure access, action execution, knowledge assistance, ticket handling, employee lifecycle management, VPN operations, and Azure deployment.</a:t>
+              <a:t>The AI Operations Assistant delivers a secure, role-based, operationally useful support system with admin approval control, encrypted password storage, direct VPN email actions, and a reliable password reset flow.</a:t>
             </a:r>
           </a:p>
           <a:p>
             <a:pPr algn="just">
               <a:lnSpc>
-                <a:spcPct val="115000"/>
+                <a:spcPct val="110000"/>
               </a:lnSpc>
               <a:spcAft>
-                <a:spcPts val="600"/>
+                <a:spcPts val="800"/>
               </a:spcAft>
             </a:pPr>
             <a:r>
-              <a:rPr sz="2000">
+              <a:rPr sz="2000" b="0">
                 <a:solidFill>
                   <a:srgbClr val="0F172A"/>
                 </a:solidFill>
                 <a:latin typeface="Arial"/>
               </a:rPr>
-              <a:t>It provides an enterprise-ready, scalable foundation for intelligent IT operations, with strong governance, secure workflow execution, and practical business value.</a:t>
-            </a:r>
-          </a:p>
-        </p:txBody>
-      </p:sp>
-      <p:sp>
-        <p:nvSpPr>
-          <p:cNvPr id="5" name="TextBox 4"/>
+              <a:t>It also improves employee and ticket visibility, strengthens security, and ensures production-ready deployment on Azure using CI/CD automation.</a:t>
+            </a:r>
+          </a:p>
+          <a:p>
+            <a:pPr algn="just">
+              <a:lnSpc>
+                <a:spcPct val="110000"/>
+              </a:lnSpc>
+              <a:spcAft>
+                <a:spcPts val="800"/>
+              </a:spcAft>
+            </a:pPr>
+            <a:r>
+              <a:rPr sz="2000" b="0">
+                <a:solidFill>
+                  <a:srgbClr val="0F172A"/>
+                </a:solidFill>
+                <a:latin typeface="Arial"/>
+              </a:rPr>
+              <a:t>Overall, the solution is ready for real-world business use and presents a professional, scalable foundation for future enhancements.</a:t>
+            </a:r>
+          </a:p>
+        </p:txBody>
+      </p:sp>
+      <p:sp>
+        <p:nvSpPr>
+          <p:cNvPr id="6" name="TextBox 5"/>
           <p:cNvSpPr txBox="1"/>
           <p:nvPr/>
         </p:nvSpPr>
         <p:spPr>
           <a:xfrm>
-            <a:off x="164592" y="6473952"/>
-            <a:ext cx="11795760" cy="256032"/>
+            <a:off x="137160" y="6473952"/>
+            <a:ext cx="11795760" cy="237744"/>
           </a:xfrm>
           <a:prstGeom prst="rect">
             <a:avLst/>

</xml_diff>

<commit_message>
Fix final deck layout and GitHub/Azure title slide
Co-authored-by: Copilot <223556219+Copilot@users.noreply.github.com>
</commit_message>
<xml_diff>
--- a/AI_Operations_Assistant_Presentation.pptx
+++ b/AI_Operations_Assistant_Presentation.pptx
@@ -3153,8 +3153,8 @@
         </p:nvSpPr>
         <p:spPr>
           <a:xfrm>
-            <a:off x="822960" y="1097280"/>
-            <a:ext cx="10515600" cy="3017520"/>
+            <a:off x="822960" y="1005840"/>
+            <a:ext cx="10515600" cy="2926080"/>
           </a:xfrm>
           <a:prstGeom prst="roundRect">
             <a:avLst/>
@@ -3198,8 +3198,8 @@
         </p:nvSpPr>
         <p:spPr>
           <a:xfrm>
-            <a:off x="1097280" y="1645920"/>
-            <a:ext cx="9692640" cy="914400"/>
+            <a:off x="1188720" y="1645920"/>
+            <a:ext cx="9601200" cy="914400"/>
           </a:xfrm>
           <a:prstGeom prst="rect">
             <a:avLst/>
@@ -3233,8 +3233,8 @@
         </p:nvSpPr>
         <p:spPr>
           <a:xfrm>
-            <a:off x="1097280" y="2560320"/>
-            <a:ext cx="9692640" cy="457200"/>
+            <a:off x="1188720" y="2606040"/>
+            <a:ext cx="9601200" cy="457200"/>
           </a:xfrm>
           <a:prstGeom prst="rect">
             <a:avLst/>
@@ -3268,62 +3268,8 @@
         </p:nvSpPr>
         <p:spPr>
           <a:xfrm>
-            <a:off x="1097280" y="4023360"/>
-            <a:ext cx="9966960" cy="685800"/>
-          </a:xfrm>
-          <a:prstGeom prst="rect">
-            <a:avLst/>
-          </a:prstGeom>
-          <a:solidFill>
-            <a:srgbClr val="E0EFFF"/>
-          </a:solidFill>
-          <a:ln>
-            <a:solidFill>
-              <a:srgbClr val="005EB8"/>
-            </a:solidFill>
-          </a:ln>
-        </p:spPr>
-        <p:style>
-          <a:lnRef idx="1">
-            <a:schemeClr val="accent1"/>
-          </a:lnRef>
-          <a:fillRef idx="3">
-            <a:schemeClr val="accent1"/>
-          </a:fillRef>
-          <a:effectRef idx="2">
-            <a:schemeClr val="accent1"/>
-          </a:effectRef>
-          <a:fontRef idx="minor">
-            <a:schemeClr val="lt1"/>
-          </a:fontRef>
-        </p:style>
-        <p:txBody>
-          <a:bodyPr rtlCol="0" anchor="ctr"/>
-          <a:lstStyle/>
-          <a:p>
-            <a:pPr algn="ctr"/>
-            <a:r>
-              <a:rPr sz="1100" b="1">
-                <a:solidFill>
-                  <a:srgbClr val="005EB8"/>
-                </a:solidFill>
-                <a:latin typeface="Arial"/>
-              </a:rPr>
-              <a:t>Tech Stack: LangGraph ? LangChain ? MCP ? Streamlit ? Azure OpenAI ? Docker ? Azure Container Registry ? Azure Container Apps ? GitHub Actions ? SQLite</a:t>
-            </a:r>
-          </a:p>
-        </p:txBody>
-      </p:sp>
-      <p:sp>
-        <p:nvSpPr>
-          <p:cNvPr id="7" name="Rectangle 6"/>
-          <p:cNvSpPr/>
-          <p:nvPr/>
-        </p:nvSpPr>
-        <p:spPr>
-          <a:xfrm>
-            <a:off x="1280160" y="4983480"/>
-            <a:ext cx="9601200" cy="548640"/>
+            <a:off x="1371600" y="4114800"/>
+            <a:ext cx="9326880" cy="548640"/>
           </a:xfrm>
           <a:prstGeom prst="rect">
             <a:avLst/>
@@ -3370,35 +3316,64 @@
       </p:sp>
       <p:sp>
         <p:nvSpPr>
-          <p:cNvPr id="8" name="TextBox 7"/>
-          <p:cNvSpPr txBox="1"/>
+          <p:cNvPr id="7" name="Rounded Rectangle 6"/>
+          <p:cNvSpPr/>
           <p:nvPr/>
         </p:nvSpPr>
         <p:spPr>
           <a:xfrm>
-            <a:off x="137160" y="6473952"/>
-            <a:ext cx="11795760" cy="237744"/>
+            <a:off x="1005840" y="4846320"/>
+            <a:ext cx="10149840" cy="914400"/>
           </a:xfrm>
-          <a:prstGeom prst="rect">
+          <a:prstGeom prst="roundRect">
             <a:avLst/>
           </a:prstGeom>
-          <a:noFill/>
+          <a:solidFill>
+            <a:srgbClr val="E4EFFF"/>
+          </a:solidFill>
+          <a:ln>
+            <a:solidFill>
+              <a:srgbClr val="005EB8"/>
+            </a:solidFill>
+          </a:ln>
         </p:spPr>
-        <p:txBody>
-          <a:bodyPr wrap="none">
-            <a:spAutoFit/>
-          </a:bodyPr>
+        <p:style>
+          <a:lnRef idx="1">
+            <a:schemeClr val="accent1"/>
+          </a:lnRef>
+          <a:fillRef idx="3">
+            <a:schemeClr val="accent1"/>
+          </a:fillRef>
+          <a:effectRef idx="2">
+            <a:schemeClr val="accent1"/>
+          </a:effectRef>
+          <a:fontRef idx="minor">
+            <a:schemeClr val="lt1"/>
+          </a:fontRef>
+        </p:style>
+        <p:txBody>
+          <a:bodyPr rtlCol="0" anchor="ctr"/>
           <a:lstStyle/>
           <a:p>
             <a:pPr algn="ctr"/>
             <a:r>
-              <a:rPr sz="900" b="1">
-                <a:solidFill>
-                  <a:srgbClr val="475569"/>
-                </a:solidFill>
-                <a:latin typeface="Arial"/>
-              </a:rPr>
-              <a:t>Owner: Ajay Kumar | Email: helloajay21@gmail.com | Batch 1 | Project: AI Operations Assistant Using Agentic AI | GitHub: https://github.com/helloajay21-max/-it-support-assistant | Azure: https://it-support-ajay-001.azurewebsites.net/</a:t>
+              <a:rPr sz="1200" b="1">
+                <a:solidFill>
+                  <a:srgbClr val="005EB8"/>
+                </a:solidFill>
+                <a:latin typeface="Arial"/>
+              </a:rPr>
+              <a:t>GitHub: https://github.com/helloajay21-max/-it-support-assistant</a:t>
+            </a:r>
+            <a:br/>
+            <a:r>
+              <a:rPr sz="1200" b="1">
+                <a:solidFill>
+                  <a:srgbClr val="005EB8"/>
+                </a:solidFill>
+                <a:latin typeface="Arial"/>
+              </a:rPr>
+              <a:t>Azure: https://it-support-ajay-001.azurewebsites.net/</a:t>
             </a:r>
           </a:p>
         </p:txBody>
@@ -3431,14 +3406,49 @@
       <p:grpSpPr/>
       <p:sp>
         <p:nvSpPr>
-          <p:cNvPr id="2" name="Rectangle 1"/>
+          <p:cNvPr id="2" name="TextBox 1"/>
+          <p:cNvSpPr txBox="1"/>
+          <p:nvPr/>
+        </p:nvSpPr>
+        <p:spPr>
+          <a:xfrm>
+            <a:off x="548640" y="347472"/>
+            <a:ext cx="8229600" cy="640080"/>
+          </a:xfrm>
+          <a:prstGeom prst="rect">
+            <a:avLst/>
+          </a:prstGeom>
+          <a:noFill/>
+        </p:spPr>
+        <p:txBody>
+          <a:bodyPr wrap="none">
+            <a:spAutoFit/>
+          </a:bodyPr>
+          <a:lstStyle/>
+          <a:p>
+            <a:pPr algn="l"/>
+            <a:r>
+              <a:rPr sz="2400" b="1">
+                <a:solidFill>
+                  <a:srgbClr val="0F172A"/>
+                </a:solidFill>
+                <a:latin typeface="Arial"/>
+              </a:rPr>
+              <a:t>Business Problem &amp; Solution</a:t>
+            </a:r>
+          </a:p>
+        </p:txBody>
+      </p:sp>
+      <p:sp>
+        <p:nvSpPr>
+          <p:cNvPr id="3" name="Rectangle 2"/>
           <p:cNvSpPr/>
           <p:nvPr/>
         </p:nvSpPr>
         <p:spPr>
           <a:xfrm>
-            <a:off x="0" y="0"/>
-            <a:ext cx="12191695" cy="384048"/>
+            <a:off x="548640" y="868680"/>
+            <a:ext cx="1920240" cy="73152"/>
           </a:xfrm>
           <a:prstGeom prst="rect">
             <a:avLst/>
@@ -3474,14 +3484,14 @@
       </p:sp>
       <p:sp>
         <p:nvSpPr>
-          <p:cNvPr id="3" name="TextBox 2"/>
+          <p:cNvPr id="4" name="TextBox 3"/>
           <p:cNvSpPr txBox="1"/>
           <p:nvPr/>
         </p:nvSpPr>
         <p:spPr>
           <a:xfrm>
-            <a:off x="548640" y="502920"/>
-            <a:ext cx="7315200" cy="640080"/>
+            <a:off x="731520" y="1371600"/>
+            <a:ext cx="10698480" cy="4389120"/>
           </a:xfrm>
           <a:prstGeom prst="rect">
             <a:avLst/>
@@ -3489,84 +3499,6 @@
           <a:noFill/>
         </p:spPr>
         <p:txBody>
-          <a:bodyPr wrap="none">
-            <a:spAutoFit/>
-          </a:bodyPr>
-          <a:lstStyle/>
-          <a:p>
-            <a:pPr algn="l"/>
-            <a:r>
-              <a:rPr sz="2400" b="1">
-                <a:solidFill>
-                  <a:srgbClr val="0F172A"/>
-                </a:solidFill>
-                <a:latin typeface="Arial"/>
-              </a:rPr>
-              <a:t>Business Problem &amp; Solution</a:t>
-            </a:r>
-          </a:p>
-        </p:txBody>
-      </p:sp>
-      <p:sp>
-        <p:nvSpPr>
-          <p:cNvPr id="4" name="Rectangle 3"/>
-          <p:cNvSpPr/>
-          <p:nvPr/>
-        </p:nvSpPr>
-        <p:spPr>
-          <a:xfrm>
-            <a:off x="548640" y="914400"/>
-            <a:ext cx="1920240" cy="73152"/>
-          </a:xfrm>
-          <a:prstGeom prst="rect">
-            <a:avLst/>
-          </a:prstGeom>
-          <a:solidFill>
-            <a:srgbClr val="0EA5E9"/>
-          </a:solidFill>
-          <a:ln>
-            <a:noFill/>
-          </a:ln>
-        </p:spPr>
-        <p:style>
-          <a:lnRef idx="1">
-            <a:schemeClr val="accent1"/>
-          </a:lnRef>
-          <a:fillRef idx="3">
-            <a:schemeClr val="accent1"/>
-          </a:fillRef>
-          <a:effectRef idx="2">
-            <a:schemeClr val="accent1"/>
-          </a:effectRef>
-          <a:fontRef idx="minor">
-            <a:schemeClr val="lt1"/>
-          </a:fontRef>
-        </p:style>
-        <p:txBody>
-          <a:bodyPr rtlCol="0" anchor="ctr"/>
-          <a:lstStyle/>
-          <a:p>
-            <a:pPr algn="ctr"/>
-          </a:p>
-        </p:txBody>
-      </p:sp>
-      <p:sp>
-        <p:nvSpPr>
-          <p:cNvPr id="5" name="TextBox 4"/>
-          <p:cNvSpPr txBox="1"/>
-          <p:nvPr/>
-        </p:nvSpPr>
-        <p:spPr>
-          <a:xfrm>
-            <a:off x="731520" y="1371600"/>
-            <a:ext cx="10698480" cy="4297680"/>
-          </a:xfrm>
-          <a:prstGeom prst="rect">
-            <a:avLst/>
-          </a:prstGeom>
-          <a:noFill/>
-        </p:spPr>
-        <p:txBody>
           <a:bodyPr wrap="square">
             <a:spAutoFit/>
           </a:bodyPr>
@@ -3574,14 +3506,14 @@
           <a:p>
             <a:pPr algn="just">
               <a:lnSpc>
-                <a:spcPct val="110000"/>
+                <a:spcPct val="112000"/>
               </a:lnSpc>
               <a:spcAft>
-                <a:spcPts val="800"/>
+                <a:spcPts val="500"/>
               </a:spcAft>
             </a:pPr>
             <a:r>
-              <a:rPr sz="2000" b="0">
+              <a:rPr sz="2000">
                 <a:solidFill>
                   <a:srgbClr val="0F172A"/>
                 </a:solidFill>
@@ -3593,55 +3525,20 @@
           <a:p>
             <a:pPr algn="just">
               <a:lnSpc>
-                <a:spcPct val="110000"/>
+                <a:spcPct val="112000"/>
               </a:lnSpc>
               <a:spcAft>
-                <a:spcPts val="800"/>
+                <a:spcPts val="500"/>
               </a:spcAft>
             </a:pPr>
             <a:r>
-              <a:rPr sz="2000" b="0">
+              <a:rPr sz="2000">
                 <a:solidFill>
                   <a:srgbClr val="0F172A"/>
                 </a:solidFill>
                 <a:latin typeface="Arial"/>
               </a:rPr>
               <a:t>The proposed solution transforms repetitive support activities into an intelligent conversational workflow driven by an agentic AI assistant that understands user intent, maintains conversational state, routes requests to the correct tools, and performs the right operational actions securely.</a:t>
-            </a:r>
-          </a:p>
-        </p:txBody>
-      </p:sp>
-      <p:sp>
-        <p:nvSpPr>
-          <p:cNvPr id="6" name="TextBox 5"/>
-          <p:cNvSpPr txBox="1"/>
-          <p:nvPr/>
-        </p:nvSpPr>
-        <p:spPr>
-          <a:xfrm>
-            <a:off x="137160" y="6473952"/>
-            <a:ext cx="11795760" cy="237744"/>
-          </a:xfrm>
-          <a:prstGeom prst="rect">
-            <a:avLst/>
-          </a:prstGeom>
-          <a:noFill/>
-        </p:spPr>
-        <p:txBody>
-          <a:bodyPr wrap="none">
-            <a:spAutoFit/>
-          </a:bodyPr>
-          <a:lstStyle/>
-          <a:p>
-            <a:pPr algn="ctr"/>
-            <a:r>
-              <a:rPr sz="900" b="1">
-                <a:solidFill>
-                  <a:srgbClr val="475569"/>
-                </a:solidFill>
-                <a:latin typeface="Arial"/>
-              </a:rPr>
-              <a:t>Owner: Ajay Kumar | Email: helloajay21@gmail.com | Batch 1 | Project: AI Operations Assistant Using Agentic AI | GitHub: https://github.com/helloajay21-max/-it-support-assistant | Azure: https://it-support-ajay-001.azurewebsites.net/</a:t>
             </a:r>
           </a:p>
         </p:txBody>
@@ -3674,14 +3571,49 @@
       <p:grpSpPr/>
       <p:sp>
         <p:nvSpPr>
-          <p:cNvPr id="2" name="Rectangle 1"/>
+          <p:cNvPr id="2" name="TextBox 1"/>
+          <p:cNvSpPr txBox="1"/>
+          <p:nvPr/>
+        </p:nvSpPr>
+        <p:spPr>
+          <a:xfrm>
+            <a:off x="548640" y="347472"/>
+            <a:ext cx="8229600" cy="640080"/>
+          </a:xfrm>
+          <a:prstGeom prst="rect">
+            <a:avLst/>
+          </a:prstGeom>
+          <a:noFill/>
+        </p:spPr>
+        <p:txBody>
+          <a:bodyPr wrap="none">
+            <a:spAutoFit/>
+          </a:bodyPr>
+          <a:lstStyle/>
+          <a:p>
+            <a:pPr algn="l"/>
+            <a:r>
+              <a:rPr sz="2400" b="1">
+                <a:solidFill>
+                  <a:srgbClr val="0F172A"/>
+                </a:solidFill>
+                <a:latin typeface="Arial"/>
+              </a:rPr>
+              <a:t>Agentic AI Solution Architecture</a:t>
+            </a:r>
+          </a:p>
+        </p:txBody>
+      </p:sp>
+      <p:sp>
+        <p:nvSpPr>
+          <p:cNvPr id="3" name="Rectangle 2"/>
           <p:cNvSpPr/>
           <p:nvPr/>
         </p:nvSpPr>
         <p:spPr>
           <a:xfrm>
-            <a:off x="0" y="0"/>
-            <a:ext cx="12191695" cy="384048"/>
+            <a:off x="548640" y="868680"/>
+            <a:ext cx="1920240" cy="73152"/>
           </a:xfrm>
           <a:prstGeom prst="rect">
             <a:avLst/>
@@ -3717,188 +3649,13 @@
       </p:sp>
       <p:sp>
         <p:nvSpPr>
-          <p:cNvPr id="3" name="TextBox 2"/>
-          <p:cNvSpPr txBox="1"/>
-          <p:nvPr/>
-        </p:nvSpPr>
-        <p:spPr>
-          <a:xfrm>
-            <a:off x="548640" y="502920"/>
-            <a:ext cx="7315200" cy="640080"/>
-          </a:xfrm>
-          <a:prstGeom prst="rect">
-            <a:avLst/>
-          </a:prstGeom>
-          <a:noFill/>
-        </p:spPr>
-        <p:txBody>
-          <a:bodyPr wrap="none">
-            <a:spAutoFit/>
-          </a:bodyPr>
-          <a:lstStyle/>
-          <a:p>
-            <a:pPr algn="l"/>
-            <a:r>
-              <a:rPr sz="2400" b="1">
-                <a:solidFill>
-                  <a:srgbClr val="0F172A"/>
-                </a:solidFill>
-                <a:latin typeface="Arial"/>
-              </a:rPr>
-              <a:t>Agentic AI Solution Architecture</a:t>
-            </a:r>
-          </a:p>
-        </p:txBody>
-      </p:sp>
-      <p:sp>
-        <p:nvSpPr>
-          <p:cNvPr id="4" name="Rectangle 3"/>
-          <p:cNvSpPr/>
-          <p:nvPr/>
-        </p:nvSpPr>
-        <p:spPr>
-          <a:xfrm>
-            <a:off x="548640" y="914400"/>
-            <a:ext cx="1920240" cy="73152"/>
-          </a:xfrm>
-          <a:prstGeom prst="rect">
-            <a:avLst/>
-          </a:prstGeom>
-          <a:solidFill>
-            <a:srgbClr val="0EA5E9"/>
-          </a:solidFill>
-          <a:ln>
-            <a:noFill/>
-          </a:ln>
-        </p:spPr>
-        <p:style>
-          <a:lnRef idx="1">
-            <a:schemeClr val="accent1"/>
-          </a:lnRef>
-          <a:fillRef idx="3">
-            <a:schemeClr val="accent1"/>
-          </a:fillRef>
-          <a:effectRef idx="2">
-            <a:schemeClr val="accent1"/>
-          </a:effectRef>
-          <a:fontRef idx="minor">
-            <a:schemeClr val="lt1"/>
-          </a:fontRef>
-        </p:style>
-        <p:txBody>
-          <a:bodyPr rtlCol="0" anchor="ctr"/>
-          <a:lstStyle/>
-          <a:p>
-            <a:pPr algn="ctr"/>
-          </a:p>
-        </p:txBody>
-      </p:sp>
-      <p:sp>
-        <p:nvSpPr>
-          <p:cNvPr id="5" name="Rounded Rectangle 4"/>
+          <p:cNvPr id="4" name="Rounded Rectangle 3"/>
           <p:cNvSpPr/>
           <p:nvPr/>
         </p:nvSpPr>
         <p:spPr>
           <a:xfrm>
             <a:off x="731520" y="2377440"/>
-            <a:ext cx="1371600" cy="822960"/>
-          </a:xfrm>
-          <a:prstGeom prst="roundRect">
-            <a:avLst/>
-          </a:prstGeom>
-          <a:solidFill>
-            <a:srgbClr val="005EB8"/>
-          </a:solidFill>
-          <a:ln>
-            <a:solidFill>
-              <a:srgbClr val="005EB8"/>
-            </a:solidFill>
-          </a:ln>
-        </p:spPr>
-        <p:style>
-          <a:lnRef idx="1">
-            <a:schemeClr val="accent1"/>
-          </a:lnRef>
-          <a:fillRef idx="3">
-            <a:schemeClr val="accent1"/>
-          </a:fillRef>
-          <a:effectRef idx="2">
-            <a:schemeClr val="accent1"/>
-          </a:effectRef>
-          <a:fontRef idx="minor">
-            <a:schemeClr val="lt1"/>
-          </a:fontRef>
-        </p:style>
-        <p:txBody>
-          <a:bodyPr rtlCol="0" anchor="ctr"/>
-          <a:lstStyle/>
-          <a:p>
-            <a:pPr algn="ctr"/>
-            <a:r>
-              <a:rPr sz="1100" b="1">
-                <a:solidFill>
-                  <a:srgbClr val="FFFFFF"/>
-                </a:solidFill>
-                <a:latin typeface="Arial"/>
-              </a:rPr>
-              <a:t>Streamlit UI</a:t>
-            </a:r>
-          </a:p>
-        </p:txBody>
-      </p:sp>
-      <p:sp>
-        <p:nvSpPr>
-          <p:cNvPr id="6" name="Right Arrow 5"/>
-          <p:cNvSpPr/>
-          <p:nvPr/>
-        </p:nvSpPr>
-        <p:spPr>
-          <a:xfrm>
-            <a:off x="2103120" y="2697480"/>
-            <a:ext cx="457200" cy="182880"/>
-          </a:xfrm>
-          <a:prstGeom prst="rightArrow">
-            <a:avLst/>
-          </a:prstGeom>
-          <a:solidFill>
-            <a:srgbClr val="475569"/>
-          </a:solidFill>
-          <a:ln>
-            <a:noFill/>
-          </a:ln>
-        </p:spPr>
-        <p:style>
-          <a:lnRef idx="1">
-            <a:schemeClr val="accent1"/>
-          </a:lnRef>
-          <a:fillRef idx="3">
-            <a:schemeClr val="accent1"/>
-          </a:fillRef>
-          <a:effectRef idx="2">
-            <a:schemeClr val="accent1"/>
-          </a:effectRef>
-          <a:fontRef idx="minor">
-            <a:schemeClr val="lt1"/>
-          </a:fontRef>
-        </p:style>
-        <p:txBody>
-          <a:bodyPr rtlCol="0" anchor="ctr"/>
-          <a:lstStyle/>
-          <a:p>
-            <a:pPr algn="ctr"/>
-          </a:p>
-        </p:txBody>
-      </p:sp>
-      <p:sp>
-        <p:nvSpPr>
-          <p:cNvPr id="7" name="Rounded Rectangle 6"/>
-          <p:cNvSpPr/>
-          <p:nvPr/>
-        </p:nvSpPr>
-        <p:spPr>
-          <a:xfrm>
-            <a:off x="2377440" y="2377440"/>
             <a:ext cx="1463040" cy="822960"/>
           </a:xfrm>
           <a:prstGeom prst="roundRect">
@@ -3939,21 +3696,21 @@
                 </a:solidFill>
                 <a:latin typeface="Arial"/>
               </a:rPr>
-              <a:t>Intent + State</a:t>
-            </a:r>
-          </a:p>
-        </p:txBody>
-      </p:sp>
-      <p:sp>
-        <p:nvSpPr>
-          <p:cNvPr id="8" name="Right Arrow 7"/>
+              <a:t>Streamlit UI</a:t>
+            </a:r>
+          </a:p>
+        </p:txBody>
+      </p:sp>
+      <p:sp>
+        <p:nvSpPr>
+          <p:cNvPr id="5" name="Right Arrow 4"/>
           <p:cNvSpPr/>
           <p:nvPr/>
         </p:nvSpPr>
         <p:spPr>
           <a:xfrm>
-            <a:off x="3840480" y="2697480"/>
-            <a:ext cx="457200" cy="182880"/>
+            <a:off x="2148840" y="2788920"/>
+            <a:ext cx="548640" cy="164592"/>
           </a:xfrm>
           <a:prstGeom prst="rightArrow">
             <a:avLst/>
@@ -3989,14 +3746,14 @@
       </p:sp>
       <p:sp>
         <p:nvSpPr>
-          <p:cNvPr id="9" name="Rounded Rectangle 8"/>
+          <p:cNvPr id="6" name="Rounded Rectangle 5"/>
           <p:cNvSpPr/>
           <p:nvPr/>
         </p:nvSpPr>
         <p:spPr>
           <a:xfrm>
-            <a:off x="4114800" y="2377440"/>
-            <a:ext cx="1554480" cy="822960"/>
+            <a:off x="2468880" y="2377440"/>
+            <a:ext cx="1463040" cy="822960"/>
           </a:xfrm>
           <a:prstGeom prst="roundRect">
             <a:avLst/>
@@ -4036,21 +3793,21 @@
                 </a:solidFill>
                 <a:latin typeface="Arial"/>
               </a:rPr>
-              <a:t>LangGraph Router</a:t>
-            </a:r>
-          </a:p>
-        </p:txBody>
-      </p:sp>
-      <p:sp>
-        <p:nvSpPr>
-          <p:cNvPr id="10" name="Right Arrow 9"/>
+              <a:t>Intent + State</a:t>
+            </a:r>
+          </a:p>
+        </p:txBody>
+      </p:sp>
+      <p:sp>
+        <p:nvSpPr>
+          <p:cNvPr id="7" name="Right Arrow 6"/>
           <p:cNvSpPr/>
           <p:nvPr/>
         </p:nvSpPr>
         <p:spPr>
           <a:xfrm>
-            <a:off x="5669280" y="2697480"/>
-            <a:ext cx="457200" cy="182880"/>
+            <a:off x="3886200" y="2788920"/>
+            <a:ext cx="548640" cy="164592"/>
           </a:xfrm>
           <a:prstGeom prst="rightArrow">
             <a:avLst/>
@@ -4086,14 +3843,14 @@
       </p:sp>
       <p:sp>
         <p:nvSpPr>
-          <p:cNvPr id="11" name="Rounded Rectangle 10"/>
+          <p:cNvPr id="8" name="Rounded Rectangle 7"/>
           <p:cNvSpPr/>
           <p:nvPr/>
         </p:nvSpPr>
         <p:spPr>
           <a:xfrm>
-            <a:off x="6035040" y="2377440"/>
-            <a:ext cx="1645920" cy="822960"/>
+            <a:off x="4389120" y="2377440"/>
+            <a:ext cx="1463040" cy="822960"/>
           </a:xfrm>
           <a:prstGeom prst="roundRect">
             <a:avLst/>
@@ -4133,21 +3890,21 @@
                 </a:solidFill>
                 <a:latin typeface="Arial"/>
               </a:rPr>
-              <a:t>MCP / Tool Layer</a:t>
-            </a:r>
-          </a:p>
-        </p:txBody>
-      </p:sp>
-      <p:sp>
-        <p:nvSpPr>
-          <p:cNvPr id="12" name="Right Arrow 11"/>
+              <a:t>LangGraph Router</a:t>
+            </a:r>
+          </a:p>
+        </p:txBody>
+      </p:sp>
+      <p:sp>
+        <p:nvSpPr>
+          <p:cNvPr id="9" name="Right Arrow 8"/>
           <p:cNvSpPr/>
           <p:nvPr/>
         </p:nvSpPr>
         <p:spPr>
           <a:xfrm>
-            <a:off x="7680960" y="2697480"/>
-            <a:ext cx="457200" cy="182880"/>
+            <a:off x="5806440" y="2788920"/>
+            <a:ext cx="548640" cy="164592"/>
           </a:xfrm>
           <a:prstGeom prst="rightArrow">
             <a:avLst/>
@@ -4183,14 +3940,14 @@
       </p:sp>
       <p:sp>
         <p:nvSpPr>
-          <p:cNvPr id="13" name="Rounded Rectangle 12"/>
+          <p:cNvPr id="10" name="Rounded Rectangle 9"/>
           <p:cNvSpPr/>
           <p:nvPr/>
         </p:nvSpPr>
         <p:spPr>
           <a:xfrm>
-            <a:off x="8138160" y="2377440"/>
-            <a:ext cx="1828800" cy="822960"/>
+            <a:off x="6309360" y="2377440"/>
+            <a:ext cx="1463040" cy="822960"/>
           </a:xfrm>
           <a:prstGeom prst="roundRect">
             <a:avLst/>
@@ -4230,6 +3987,103 @@
                 </a:solidFill>
                 <a:latin typeface="Arial"/>
               </a:rPr>
+              <a:t>MCP / Tool Layer</a:t>
+            </a:r>
+          </a:p>
+        </p:txBody>
+      </p:sp>
+      <p:sp>
+        <p:nvSpPr>
+          <p:cNvPr id="11" name="Right Arrow 10"/>
+          <p:cNvSpPr/>
+          <p:nvPr/>
+        </p:nvSpPr>
+        <p:spPr>
+          <a:xfrm>
+            <a:off x="7726680" y="2788920"/>
+            <a:ext cx="548640" cy="164592"/>
+          </a:xfrm>
+          <a:prstGeom prst="rightArrow">
+            <a:avLst/>
+          </a:prstGeom>
+          <a:solidFill>
+            <a:srgbClr val="475569"/>
+          </a:solidFill>
+          <a:ln>
+            <a:noFill/>
+          </a:ln>
+        </p:spPr>
+        <p:style>
+          <a:lnRef idx="1">
+            <a:schemeClr val="accent1"/>
+          </a:lnRef>
+          <a:fillRef idx="3">
+            <a:schemeClr val="accent1"/>
+          </a:fillRef>
+          <a:effectRef idx="2">
+            <a:schemeClr val="accent1"/>
+          </a:effectRef>
+          <a:fontRef idx="minor">
+            <a:schemeClr val="lt1"/>
+          </a:fontRef>
+        </p:style>
+        <p:txBody>
+          <a:bodyPr rtlCol="0" anchor="ctr"/>
+          <a:lstStyle/>
+          <a:p>
+            <a:pPr algn="ctr"/>
+          </a:p>
+        </p:txBody>
+      </p:sp>
+      <p:sp>
+        <p:nvSpPr>
+          <p:cNvPr id="12" name="Rounded Rectangle 11"/>
+          <p:cNvSpPr/>
+          <p:nvPr/>
+        </p:nvSpPr>
+        <p:spPr>
+          <a:xfrm>
+            <a:off x="8321040" y="2377440"/>
+            <a:ext cx="1463040" cy="822960"/>
+          </a:xfrm>
+          <a:prstGeom prst="roundRect">
+            <a:avLst/>
+          </a:prstGeom>
+          <a:solidFill>
+            <a:srgbClr val="005EB8"/>
+          </a:solidFill>
+          <a:ln>
+            <a:solidFill>
+              <a:srgbClr val="005EB8"/>
+            </a:solidFill>
+          </a:ln>
+        </p:spPr>
+        <p:style>
+          <a:lnRef idx="1">
+            <a:schemeClr val="accent1"/>
+          </a:lnRef>
+          <a:fillRef idx="3">
+            <a:schemeClr val="accent1"/>
+          </a:fillRef>
+          <a:effectRef idx="2">
+            <a:schemeClr val="accent1"/>
+          </a:effectRef>
+          <a:fontRef idx="minor">
+            <a:schemeClr val="lt1"/>
+          </a:fontRef>
+        </p:style>
+        <p:txBody>
+          <a:bodyPr rtlCol="0" anchor="ctr"/>
+          <a:lstStyle/>
+          <a:p>
+            <a:pPr algn="ctr"/>
+            <a:r>
+              <a:rPr sz="1100" b="1">
+                <a:solidFill>
+                  <a:srgbClr val="FFFFFF"/>
+                </a:solidFill>
+                <a:latin typeface="Arial"/>
+              </a:rPr>
               <a:t>Operational Systems</a:t>
             </a:r>
           </a:p>
@@ -4237,14 +4091,14 @@
       </p:sp>
       <p:sp>
         <p:nvSpPr>
-          <p:cNvPr id="14" name="TextBox 13"/>
+          <p:cNvPr id="13" name="TextBox 12"/>
           <p:cNvSpPr txBox="1"/>
           <p:nvPr/>
         </p:nvSpPr>
         <p:spPr>
           <a:xfrm>
             <a:off x="731520" y="3931920"/>
-            <a:ext cx="10789920" cy="1920240"/>
+            <a:ext cx="10698480" cy="1920240"/>
           </a:xfrm>
           <a:prstGeom prst="rect">
             <a:avLst/>
@@ -4259,14 +4113,14 @@
           <a:p>
             <a:pPr algn="just">
               <a:lnSpc>
-                <a:spcPct val="110000"/>
+                <a:spcPct val="112000"/>
               </a:lnSpc>
               <a:spcAft>
-                <a:spcPts val="800"/>
+                <a:spcPts val="500"/>
               </a:spcAft>
             </a:pPr>
             <a:r>
-              <a:rPr sz="1700" b="0">
+              <a:rPr sz="1700">
                 <a:solidFill>
                   <a:srgbClr val="0F172A"/>
                 </a:solidFill>
@@ -4274,52 +4128,62 @@
               </a:rPr>
               <a:t>Understand: Natural-language intent and request context</a:t>
             </a:r>
-            <a:br/>
-            <a:r>
+          </a:p>
+          <a:p>
+            <a:pPr algn="just">
+              <a:lnSpc>
+                <a:spcPct val="112000"/>
+              </a:lnSpc>
+              <a:spcAft>
+                <a:spcPts val="500"/>
+              </a:spcAft>
+            </a:pPr>
+            <a:r>
+              <a:rPr sz="1700">
+                <a:solidFill>
+                  <a:srgbClr val="0F172A"/>
+                </a:solidFill>
+                <a:latin typeface="Arial"/>
+              </a:rPr>
               <a:t>Orchestrate: LangGraph reasoning, state management, and conditional routing</a:t>
             </a:r>
-            <a:br/>
-            <a:r>
+          </a:p>
+          <a:p>
+            <a:pPr algn="just">
+              <a:lnSpc>
+                <a:spcPct val="112000"/>
+              </a:lnSpc>
+              <a:spcAft>
+                <a:spcPts val="500"/>
+              </a:spcAft>
+            </a:pPr>
+            <a:r>
+              <a:rPr sz="1700">
+                <a:solidFill>
+                  <a:srgbClr val="0F172A"/>
+                </a:solidFill>
+                <a:latin typeface="Arial"/>
+              </a:rPr>
               <a:t>Act: Knowledge lookup, ticket operations, employee actions, VPN requests, and email dispatch</a:t>
             </a:r>
-            <a:br/>
-            <a:r>
+          </a:p>
+          <a:p>
+            <a:pPr algn="just">
+              <a:lnSpc>
+                <a:spcPct val="112000"/>
+              </a:lnSpc>
+              <a:spcAft>
+                <a:spcPts val="500"/>
+              </a:spcAft>
+            </a:pPr>
+            <a:r>
+              <a:rPr sz="1700">
+                <a:solidFill>
+                  <a:srgbClr val="0F172A"/>
+                </a:solidFill>
+                <a:latin typeface="Arial"/>
+              </a:rPr>
               <a:t>Result: Context-aware responses with workflow execution and secure validation</a:t>
-            </a:r>
-          </a:p>
-        </p:txBody>
-      </p:sp>
-      <p:sp>
-        <p:nvSpPr>
-          <p:cNvPr id="15" name="TextBox 14"/>
-          <p:cNvSpPr txBox="1"/>
-          <p:nvPr/>
-        </p:nvSpPr>
-        <p:spPr>
-          <a:xfrm>
-            <a:off x="137160" y="6473952"/>
-            <a:ext cx="11795760" cy="237744"/>
-          </a:xfrm>
-          <a:prstGeom prst="rect">
-            <a:avLst/>
-          </a:prstGeom>
-          <a:noFill/>
-        </p:spPr>
-        <p:txBody>
-          <a:bodyPr wrap="none">
-            <a:spAutoFit/>
-          </a:bodyPr>
-          <a:lstStyle/>
-          <a:p>
-            <a:pPr algn="ctr"/>
-            <a:r>
-              <a:rPr sz="900" b="1">
-                <a:solidFill>
-                  <a:srgbClr val="475569"/>
-                </a:solidFill>
-                <a:latin typeface="Arial"/>
-              </a:rPr>
-              <a:t>Owner: Ajay Kumar | Email: helloajay21@gmail.com | Batch 1 | Project: AI Operations Assistant Using Agentic AI | GitHub: https://github.com/helloajay21-max/-it-support-assistant | Azure: https://it-support-ajay-001.azurewebsites.net/</a:t>
             </a:r>
           </a:p>
         </p:txBody>
@@ -4352,14 +4216,49 @@
       <p:grpSpPr/>
       <p:sp>
         <p:nvSpPr>
-          <p:cNvPr id="2" name="Rectangle 1"/>
+          <p:cNvPr id="2" name="TextBox 1"/>
+          <p:cNvSpPr txBox="1"/>
+          <p:nvPr/>
+        </p:nvSpPr>
+        <p:spPr>
+          <a:xfrm>
+            <a:off x="548640" y="347472"/>
+            <a:ext cx="8229600" cy="640080"/>
+          </a:xfrm>
+          <a:prstGeom prst="rect">
+            <a:avLst/>
+          </a:prstGeom>
+          <a:noFill/>
+        </p:spPr>
+        <p:txBody>
+          <a:bodyPr wrap="none">
+            <a:spAutoFit/>
+          </a:bodyPr>
+          <a:lstStyle/>
+          <a:p>
+            <a:pPr algn="l"/>
+            <a:r>
+              <a:rPr sz="2400" b="1">
+                <a:solidFill>
+                  <a:srgbClr val="0F172A"/>
+                </a:solidFill>
+                <a:latin typeface="Arial"/>
+              </a:rPr>
+              <a:t>Technology Stack</a:t>
+            </a:r>
+          </a:p>
+        </p:txBody>
+      </p:sp>
+      <p:sp>
+        <p:nvSpPr>
+          <p:cNvPr id="3" name="Rectangle 2"/>
           <p:cNvSpPr/>
           <p:nvPr/>
         </p:nvSpPr>
         <p:spPr>
           <a:xfrm>
-            <a:off x="0" y="0"/>
-            <a:ext cx="12191695" cy="384048"/>
+            <a:off x="548640" y="868680"/>
+            <a:ext cx="1920240" cy="73152"/>
           </a:xfrm>
           <a:prstGeom prst="rect">
             <a:avLst/>
@@ -4395,14 +4294,14 @@
       </p:sp>
       <p:sp>
         <p:nvSpPr>
-          <p:cNvPr id="3" name="TextBox 2"/>
+          <p:cNvPr id="4" name="TextBox 3"/>
           <p:cNvSpPr txBox="1"/>
           <p:nvPr/>
         </p:nvSpPr>
         <p:spPr>
           <a:xfrm>
-            <a:off x="548640" y="502920"/>
-            <a:ext cx="7315200" cy="640080"/>
+            <a:off x="731520" y="1463040"/>
+            <a:ext cx="5120640" cy="3749039"/>
           </a:xfrm>
           <a:prstGeom prst="rect">
             <a:avLst/>
@@ -4415,59 +4314,137 @@
           </a:bodyPr>
           <a:lstStyle/>
           <a:p>
-            <a:pPr algn="l"/>
-            <a:r>
-              <a:rPr sz="2400" b="1">
+            <a:pPr algn="l">
+              <a:lnSpc>
+                <a:spcPct val="110000"/>
+              </a:lnSpc>
+              <a:spcAft>
+                <a:spcPts val="700"/>
+              </a:spcAft>
+            </a:pPr>
+            <a:r>
+              <a:rPr sz="1700">
                 <a:solidFill>
                   <a:srgbClr val="0F172A"/>
                 </a:solidFill>
                 <a:latin typeface="Arial"/>
               </a:rPr>
-              <a:t>Technology Stack</a:t>
-            </a:r>
-          </a:p>
-        </p:txBody>
-      </p:sp>
-      <p:sp>
-        <p:nvSpPr>
-          <p:cNvPr id="4" name="Rectangle 3"/>
-          <p:cNvSpPr/>
-          <p:nvPr/>
-        </p:nvSpPr>
-        <p:spPr>
-          <a:xfrm>
-            <a:off x="548640" y="914400"/>
-            <a:ext cx="1920240" cy="73152"/>
-          </a:xfrm>
-          <a:prstGeom prst="rect">
-            <a:avLst/>
-          </a:prstGeom>
-          <a:solidFill>
-            <a:srgbClr val="0EA5E9"/>
-          </a:solidFill>
-          <a:ln>
-            <a:noFill/>
-          </a:ln>
-        </p:spPr>
-        <p:style>
-          <a:lnRef idx="1">
-            <a:schemeClr val="accent1"/>
-          </a:lnRef>
-          <a:fillRef idx="3">
-            <a:schemeClr val="accent1"/>
-          </a:fillRef>
-          <a:effectRef idx="2">
-            <a:schemeClr val="accent1"/>
-          </a:effectRef>
-          <a:fontRef idx="minor">
-            <a:schemeClr val="lt1"/>
-          </a:fontRef>
-        </p:style>
-        <p:txBody>
-          <a:bodyPr rtlCol="0" anchor="ctr"/>
-          <a:lstStyle/>
-          <a:p>
-            <a:pPr algn="ctr"/>
+              <a:t>Frontend / Experience: Streamlit</a:t>
+            </a:r>
+          </a:p>
+          <a:p>
+            <a:pPr algn="l">
+              <a:lnSpc>
+                <a:spcPct val="110000"/>
+              </a:lnSpc>
+              <a:spcAft>
+                <a:spcPts val="700"/>
+              </a:spcAft>
+            </a:pPr>
+            <a:r>
+              <a:rPr sz="1700">
+                <a:solidFill>
+                  <a:srgbClr val="0F172A"/>
+                </a:solidFill>
+                <a:latin typeface="Arial"/>
+              </a:rPr>
+              <a:t>Agent Orchestration: LangGraph, LangChain</a:t>
+            </a:r>
+          </a:p>
+          <a:p>
+            <a:pPr algn="l">
+              <a:lnSpc>
+                <a:spcPct val="110000"/>
+              </a:lnSpc>
+              <a:spcAft>
+                <a:spcPts val="700"/>
+              </a:spcAft>
+            </a:pPr>
+            <a:r>
+              <a:rPr sz="1700">
+                <a:solidFill>
+                  <a:srgbClr val="0F172A"/>
+                </a:solidFill>
+                <a:latin typeface="Arial"/>
+              </a:rPr>
+              <a:t>Tool Integration: MCP / Tool layer</a:t>
+            </a:r>
+          </a:p>
+          <a:p>
+            <a:pPr algn="l">
+              <a:lnSpc>
+                <a:spcPct val="110000"/>
+              </a:lnSpc>
+              <a:spcAft>
+                <a:spcPts val="700"/>
+              </a:spcAft>
+            </a:pPr>
+            <a:r>
+              <a:rPr sz="1700">
+                <a:solidFill>
+                  <a:srgbClr val="0F172A"/>
+                </a:solidFill>
+                <a:latin typeface="Arial"/>
+              </a:rPr>
+              <a:t>AI Model Layer: Azure OpenAI</a:t>
+            </a:r>
+          </a:p>
+          <a:p>
+            <a:pPr algn="l">
+              <a:lnSpc>
+                <a:spcPct val="110000"/>
+              </a:lnSpc>
+              <a:spcAft>
+                <a:spcPts val="700"/>
+              </a:spcAft>
+            </a:pPr>
+            <a:r>
+              <a:rPr sz="1700">
+                <a:solidFill>
+                  <a:srgbClr val="0F172A"/>
+                </a:solidFill>
+                <a:latin typeface="Arial"/>
+              </a:rPr>
+              <a:t>Application Runtime: Python</a:t>
+            </a:r>
+          </a:p>
+          <a:p>
+            <a:pPr algn="l">
+              <a:lnSpc>
+                <a:spcPct val="110000"/>
+              </a:lnSpc>
+              <a:spcAft>
+                <a:spcPts val="700"/>
+              </a:spcAft>
+            </a:pPr>
+            <a:r>
+              <a:rPr sz="1700">
+                <a:solidFill>
+                  <a:srgbClr val="0F172A"/>
+                </a:solidFill>
+                <a:latin typeface="Arial"/>
+              </a:rPr>
+              <a:t>Database: SQLite</a:t>
+            </a:r>
+          </a:p>
+          <a:p>
+            <a:pPr algn="l">
+              <a:lnSpc>
+                <a:spcPct val="110000"/>
+              </a:lnSpc>
+              <a:spcAft>
+                <a:spcPts val="700"/>
+              </a:spcAft>
+            </a:pPr>
+            <a:r>
+              <a:rPr sz="1700">
+                <a:solidFill>
+                  <a:srgbClr val="0F172A"/>
+                </a:solidFill>
+                <a:latin typeface="Arial"/>
+              </a:rPr>
+              <a:t>Email &amp; Notifications: SMTP / Email service</a:t>
+            </a:r>
           </a:p>
         </p:txBody>
       </p:sp>
@@ -4479,8 +4456,8 @@
         </p:nvSpPr>
         <p:spPr>
           <a:xfrm>
-            <a:off x="731520" y="1463040"/>
-            <a:ext cx="5212080" cy="3749039"/>
+            <a:off x="6217920" y="1463040"/>
+            <a:ext cx="5029200" cy="3749039"/>
           </a:xfrm>
           <a:prstGeom prst="rect">
             <a:avLst/>
@@ -4498,17 +4475,17 @@
                 <a:spcPct val="110000"/>
               </a:lnSpc>
               <a:spcAft>
-                <a:spcPts val="800"/>
+                <a:spcPts val="700"/>
               </a:spcAft>
             </a:pPr>
             <a:r>
-              <a:rPr sz="1800">
+              <a:rPr sz="1700">
                 <a:solidFill>
                   <a:srgbClr val="0F172A"/>
                 </a:solidFill>
                 <a:latin typeface="Arial"/>
               </a:rPr>
-              <a:t>Frontend / Experience: Streamlit</a:t>
+              <a:t>Containerization: Docker</a:t>
             </a:r>
           </a:p>
           <a:p>
@@ -4517,17 +4494,17 @@
                 <a:spcPct val="110000"/>
               </a:lnSpc>
               <a:spcAft>
-                <a:spcPts val="800"/>
+                <a:spcPts val="700"/>
               </a:spcAft>
             </a:pPr>
             <a:r>
-              <a:rPr sz="1800">
+              <a:rPr sz="1700">
                 <a:solidFill>
                   <a:srgbClr val="0F172A"/>
                 </a:solidFill>
                 <a:latin typeface="Arial"/>
               </a:rPr>
-              <a:t>Agent Orchestration: LangGraph, LangChain</a:t>
+              <a:t>Cloud Platform: Microsoft Azure</a:t>
             </a:r>
           </a:p>
           <a:p>
@@ -4536,17 +4513,17 @@
                 <a:spcPct val="110000"/>
               </a:lnSpc>
               <a:spcAft>
-                <a:spcPts val="800"/>
+                <a:spcPts val="700"/>
               </a:spcAft>
             </a:pPr>
             <a:r>
-              <a:rPr sz="1800">
+              <a:rPr sz="1700">
                 <a:solidFill>
                   <a:srgbClr val="0F172A"/>
                 </a:solidFill>
                 <a:latin typeface="Arial"/>
               </a:rPr>
-              <a:t>Tool Integration: MCP / Tool layer</a:t>
+              <a:t>Azure Services: App Service, Container Apps, Container Registry</a:t>
             </a:r>
           </a:p>
           <a:p>
@@ -4555,17 +4532,17 @@
                 <a:spcPct val="110000"/>
               </a:lnSpc>
               <a:spcAft>
-                <a:spcPts val="800"/>
+                <a:spcPts val="700"/>
               </a:spcAft>
             </a:pPr>
             <a:r>
-              <a:rPr sz="1800">
+              <a:rPr sz="1700">
                 <a:solidFill>
                   <a:srgbClr val="0F172A"/>
                 </a:solidFill>
                 <a:latin typeface="Arial"/>
               </a:rPr>
-              <a:t>AI Model Layer: Azure OpenAI</a:t>
+              <a:t>Deployment Automation: GitHub Actions</a:t>
             </a:r>
           </a:p>
           <a:p>
@@ -4574,17 +4551,17 @@
                 <a:spcPct val="110000"/>
               </a:lnSpc>
               <a:spcAft>
-                <a:spcPts val="800"/>
+                <a:spcPts val="700"/>
               </a:spcAft>
             </a:pPr>
             <a:r>
-              <a:rPr sz="1800">
+              <a:rPr sz="1700">
                 <a:solidFill>
                   <a:srgbClr val="0F172A"/>
                 </a:solidFill>
                 <a:latin typeface="Arial"/>
               </a:rPr>
-              <a:t>Application Runtime: Python</a:t>
+              <a:t>Source Control: GitHub</a:t>
             </a:r>
           </a:p>
           <a:p>
@@ -4593,208 +4570,17 @@
                 <a:spcPct val="110000"/>
               </a:lnSpc>
               <a:spcAft>
-                <a:spcPts val="800"/>
+                <a:spcPts val="700"/>
               </a:spcAft>
             </a:pPr>
             <a:r>
-              <a:rPr sz="1800">
+              <a:rPr sz="1700">
                 <a:solidFill>
                   <a:srgbClr val="0F172A"/>
                 </a:solidFill>
                 <a:latin typeface="Arial"/>
               </a:rPr>
-              <a:t>Database: SQLite</a:t>
-            </a:r>
-          </a:p>
-          <a:p>
-            <a:pPr algn="l">
-              <a:lnSpc>
-                <a:spcPct val="110000"/>
-              </a:lnSpc>
-              <a:spcAft>
-                <a:spcPts val="800"/>
-              </a:spcAft>
-            </a:pPr>
-            <a:r>
-              <a:rPr sz="1800">
-                <a:solidFill>
-                  <a:srgbClr val="0F172A"/>
-                </a:solidFill>
-                <a:latin typeface="Arial"/>
-              </a:rPr>
-              <a:t>Email &amp; Notifications: SMTP / Email service</a:t>
-            </a:r>
-          </a:p>
-        </p:txBody>
-      </p:sp>
-      <p:sp>
-        <p:nvSpPr>
-          <p:cNvPr id="6" name="TextBox 5"/>
-          <p:cNvSpPr txBox="1"/>
-          <p:nvPr/>
-        </p:nvSpPr>
-        <p:spPr>
-          <a:xfrm>
-            <a:off x="6309360" y="1463040"/>
-            <a:ext cx="4937760" cy="3749039"/>
-          </a:xfrm>
-          <a:prstGeom prst="rect">
-            <a:avLst/>
-          </a:prstGeom>
-          <a:noFill/>
-        </p:spPr>
-        <p:txBody>
-          <a:bodyPr wrap="none">
-            <a:spAutoFit/>
-          </a:bodyPr>
-          <a:lstStyle/>
-          <a:p>
-            <a:pPr algn="l">
-              <a:lnSpc>
-                <a:spcPct val="110000"/>
-              </a:lnSpc>
-              <a:spcAft>
-                <a:spcPts val="800"/>
-              </a:spcAft>
-            </a:pPr>
-            <a:r>
-              <a:rPr sz="1800">
-                <a:solidFill>
-                  <a:srgbClr val="0F172A"/>
-                </a:solidFill>
-                <a:latin typeface="Arial"/>
-              </a:rPr>
-              <a:t>Containerization: Docker</a:t>
-            </a:r>
-          </a:p>
-          <a:p>
-            <a:pPr algn="l">
-              <a:lnSpc>
-                <a:spcPct val="110000"/>
-              </a:lnSpc>
-              <a:spcAft>
-                <a:spcPts val="800"/>
-              </a:spcAft>
-            </a:pPr>
-            <a:r>
-              <a:rPr sz="1800">
-                <a:solidFill>
-                  <a:srgbClr val="0F172A"/>
-                </a:solidFill>
-                <a:latin typeface="Arial"/>
-              </a:rPr>
-              <a:t>Cloud Platform: Microsoft Azure</a:t>
-            </a:r>
-          </a:p>
-          <a:p>
-            <a:pPr algn="l">
-              <a:lnSpc>
-                <a:spcPct val="110000"/>
-              </a:lnSpc>
-              <a:spcAft>
-                <a:spcPts val="800"/>
-              </a:spcAft>
-            </a:pPr>
-            <a:r>
-              <a:rPr sz="1800">
-                <a:solidFill>
-                  <a:srgbClr val="0F172A"/>
-                </a:solidFill>
-                <a:latin typeface="Arial"/>
-              </a:rPr>
-              <a:t>Azure Services: App Service, Container Apps, Container Registry</a:t>
-            </a:r>
-          </a:p>
-          <a:p>
-            <a:pPr algn="l">
-              <a:lnSpc>
-                <a:spcPct val="110000"/>
-              </a:lnSpc>
-              <a:spcAft>
-                <a:spcPts val="800"/>
-              </a:spcAft>
-            </a:pPr>
-            <a:r>
-              <a:rPr sz="1800">
-                <a:solidFill>
-                  <a:srgbClr val="0F172A"/>
-                </a:solidFill>
-                <a:latin typeface="Arial"/>
-              </a:rPr>
-              <a:t>Deployment Automation: GitHub Actions</a:t>
-            </a:r>
-          </a:p>
-          <a:p>
-            <a:pPr algn="l">
-              <a:lnSpc>
-                <a:spcPct val="110000"/>
-              </a:lnSpc>
-              <a:spcAft>
-                <a:spcPts val="800"/>
-              </a:spcAft>
-            </a:pPr>
-            <a:r>
-              <a:rPr sz="1800">
-                <a:solidFill>
-                  <a:srgbClr val="0F172A"/>
-                </a:solidFill>
-                <a:latin typeface="Arial"/>
-              </a:rPr>
-              <a:t>Source Control: GitHub</a:t>
-            </a:r>
-          </a:p>
-          <a:p>
-            <a:pPr algn="l">
-              <a:lnSpc>
-                <a:spcPct val="110000"/>
-              </a:lnSpc>
-              <a:spcAft>
-                <a:spcPts val="800"/>
-              </a:spcAft>
-            </a:pPr>
-            <a:r>
-              <a:rPr sz="1800">
-                <a:solidFill>
-                  <a:srgbClr val="0F172A"/>
-                </a:solidFill>
-                <a:latin typeface="Arial"/>
-              </a:rPr>
               <a:t>Production Pattern: CI/CD + environment secrets</a:t>
-            </a:r>
-          </a:p>
-        </p:txBody>
-      </p:sp>
-      <p:sp>
-        <p:nvSpPr>
-          <p:cNvPr id="7" name="TextBox 6"/>
-          <p:cNvSpPr txBox="1"/>
-          <p:nvPr/>
-        </p:nvSpPr>
-        <p:spPr>
-          <a:xfrm>
-            <a:off x="137160" y="6473952"/>
-            <a:ext cx="11795760" cy="237744"/>
-          </a:xfrm>
-          <a:prstGeom prst="rect">
-            <a:avLst/>
-          </a:prstGeom>
-          <a:noFill/>
-        </p:spPr>
-        <p:txBody>
-          <a:bodyPr wrap="none">
-            <a:spAutoFit/>
-          </a:bodyPr>
-          <a:lstStyle/>
-          <a:p>
-            <a:pPr algn="ctr"/>
-            <a:r>
-              <a:rPr sz="900" b="1">
-                <a:solidFill>
-                  <a:srgbClr val="475569"/>
-                </a:solidFill>
-                <a:latin typeface="Arial"/>
-              </a:rPr>
-              <a:t>Owner: Ajay Kumar | Email: helloajay21@gmail.com | Batch 1 | Project: AI Operations Assistant Using Agentic AI | GitHub: https://github.com/helloajay21-max/-it-support-assistant | Azure: https://it-support-ajay-001.azurewebsites.net/</a:t>
             </a:r>
           </a:p>
         </p:txBody>
@@ -4827,14 +4613,49 @@
       <p:grpSpPr/>
       <p:sp>
         <p:nvSpPr>
-          <p:cNvPr id="2" name="Rectangle 1"/>
+          <p:cNvPr id="2" name="TextBox 1"/>
+          <p:cNvSpPr txBox="1"/>
+          <p:nvPr/>
+        </p:nvSpPr>
+        <p:spPr>
+          <a:xfrm>
+            <a:off x="548640" y="347472"/>
+            <a:ext cx="8229600" cy="640080"/>
+          </a:xfrm>
+          <a:prstGeom prst="rect">
+            <a:avLst/>
+          </a:prstGeom>
+          <a:noFill/>
+        </p:spPr>
+        <p:txBody>
+          <a:bodyPr wrap="none">
+            <a:spAutoFit/>
+          </a:bodyPr>
+          <a:lstStyle/>
+          <a:p>
+            <a:pPr algn="l"/>
+            <a:r>
+              <a:rPr sz="2400" b="1">
+                <a:solidFill>
+                  <a:srgbClr val="0F172A"/>
+                </a:solidFill>
+                <a:latin typeface="Arial"/>
+              </a:rPr>
+              <a:t>Core Features</a:t>
+            </a:r>
+          </a:p>
+        </p:txBody>
+      </p:sp>
+      <p:sp>
+        <p:nvSpPr>
+          <p:cNvPr id="3" name="Rectangle 2"/>
           <p:cNvSpPr/>
           <p:nvPr/>
         </p:nvSpPr>
         <p:spPr>
           <a:xfrm>
-            <a:off x="0" y="0"/>
-            <a:ext cx="12191695" cy="384048"/>
+            <a:off x="548640" y="868680"/>
+            <a:ext cx="1920240" cy="73152"/>
           </a:xfrm>
           <a:prstGeom prst="rect">
             <a:avLst/>
@@ -4870,85 +4691,7 @@
       </p:sp>
       <p:sp>
         <p:nvSpPr>
-          <p:cNvPr id="3" name="TextBox 2"/>
-          <p:cNvSpPr txBox="1"/>
-          <p:nvPr/>
-        </p:nvSpPr>
-        <p:spPr>
-          <a:xfrm>
-            <a:off x="548640" y="502920"/>
-            <a:ext cx="7315200" cy="640080"/>
-          </a:xfrm>
-          <a:prstGeom prst="rect">
-            <a:avLst/>
-          </a:prstGeom>
-          <a:noFill/>
-        </p:spPr>
-        <p:txBody>
-          <a:bodyPr wrap="none">
-            <a:spAutoFit/>
-          </a:bodyPr>
-          <a:lstStyle/>
-          <a:p>
-            <a:pPr algn="l"/>
-            <a:r>
-              <a:rPr sz="2400" b="1">
-                <a:solidFill>
-                  <a:srgbClr val="0F172A"/>
-                </a:solidFill>
-                <a:latin typeface="Arial"/>
-              </a:rPr>
-              <a:t>Core Features</a:t>
-            </a:r>
-          </a:p>
-        </p:txBody>
-      </p:sp>
-      <p:sp>
-        <p:nvSpPr>
-          <p:cNvPr id="4" name="Rectangle 3"/>
-          <p:cNvSpPr/>
-          <p:nvPr/>
-        </p:nvSpPr>
-        <p:spPr>
-          <a:xfrm>
-            <a:off x="548640" y="914400"/>
-            <a:ext cx="1920240" cy="73152"/>
-          </a:xfrm>
-          <a:prstGeom prst="rect">
-            <a:avLst/>
-          </a:prstGeom>
-          <a:solidFill>
-            <a:srgbClr val="0EA5E9"/>
-          </a:solidFill>
-          <a:ln>
-            <a:noFill/>
-          </a:ln>
-        </p:spPr>
-        <p:style>
-          <a:lnRef idx="1">
-            <a:schemeClr val="accent1"/>
-          </a:lnRef>
-          <a:fillRef idx="3">
-            <a:schemeClr val="accent1"/>
-          </a:fillRef>
-          <a:effectRef idx="2">
-            <a:schemeClr val="accent1"/>
-          </a:effectRef>
-          <a:fontRef idx="minor">
-            <a:schemeClr val="lt1"/>
-          </a:fontRef>
-        </p:style>
-        <p:txBody>
-          <a:bodyPr rtlCol="0" anchor="ctr"/>
-          <a:lstStyle/>
-          <a:p>
-            <a:pPr algn="ctr"/>
-          </a:p>
-        </p:txBody>
-      </p:sp>
-      <p:sp>
-        <p:nvSpPr>
-          <p:cNvPr id="5" name="TextBox 4"/>
+          <p:cNvPr id="4" name="TextBox 3"/>
           <p:cNvSpPr txBox="1"/>
           <p:nvPr/>
         </p:nvSpPr>
@@ -4963,121 +4706,118 @@
           <a:noFill/>
         </p:spPr>
         <p:txBody>
-          <a:bodyPr wrap="none">
+          <a:bodyPr wrap="square">
             <a:spAutoFit/>
           </a:bodyPr>
           <a:lstStyle/>
           <a:p>
             <a:pPr algn="l">
+              <a:spcAft>
+                <a:spcPts val="800"/>
+              </a:spcAft>
+            </a:pPr>
+            <a:r>
+              <a:rPr sz="1800" b="1">
+                <a:solidFill>
+                  <a:srgbClr val="005EB8"/>
+                </a:solidFill>
+                <a:latin typeface="Arial"/>
+              </a:rPr>
+              <a:t>Operational Functions</a:t>
+            </a:r>
+          </a:p>
+          <a:p>
+            <a:pPr algn="just">
               <a:lnSpc>
-                <a:spcPct val="112000"/>
+                <a:spcPct val="110000"/>
               </a:lnSpc>
               <a:spcAft>
-                <a:spcPts val="700"/>
+                <a:spcPts val="600"/>
               </a:spcAft>
             </a:pPr>
             <a:r>
-              <a:rPr sz="1800" b="1">
-                <a:solidFill>
-                  <a:srgbClr val="005EB8"/>
-                </a:solidFill>
-                <a:latin typeface="Arial"/>
-              </a:rPr>
-              <a:t>Operational Functions</a:t>
-            </a:r>
-          </a:p>
-          <a:p>
-            <a:pPr algn="l">
+              <a:rPr sz="1500">
+                <a:solidFill>
+                  <a:srgbClr val="0F172A"/>
+                </a:solidFill>
+                <a:latin typeface="Arial"/>
+              </a:rPr>
+              <a:t>Knowledge search and IT guidance lookup</a:t>
+            </a:r>
+          </a:p>
+          <a:p>
+            <a:pPr algn="just">
               <a:lnSpc>
-                <a:spcPct val="112000"/>
+                <a:spcPct val="110000"/>
               </a:lnSpc>
               <a:spcAft>
-                <a:spcPts val="700"/>
+                <a:spcPts val="600"/>
               </a:spcAft>
             </a:pPr>
             <a:r>
-              <a:rPr sz="1600" b="0">
+              <a:rPr sz="1500">
                 <a:solidFill>
                   <a:srgbClr val="0F172A"/>
                 </a:solidFill>
                 <a:latin typeface="Arial"/>
               </a:rPr>
-              <a:t>Knowledge search and IT guidance lookup</a:t>
-            </a:r>
-          </a:p>
-          <a:p>
-            <a:pPr algn="l">
+              <a:t>Ticket lookup, creation, and status tracking</a:t>
+            </a:r>
+          </a:p>
+          <a:p>
+            <a:pPr algn="just">
               <a:lnSpc>
-                <a:spcPct val="112000"/>
+                <a:spcPct val="110000"/>
               </a:lnSpc>
               <a:spcAft>
-                <a:spcPts val="700"/>
+                <a:spcPts val="600"/>
               </a:spcAft>
             </a:pPr>
             <a:r>
-              <a:rPr sz="1600" b="0">
+              <a:rPr sz="1500">
                 <a:solidFill>
                   <a:srgbClr val="0F172A"/>
                 </a:solidFill>
                 <a:latin typeface="Arial"/>
               </a:rPr>
-              <a:t>Ticket lookup, creation, and status tracking</a:t>
-            </a:r>
-          </a:p>
-          <a:p>
-            <a:pPr algn="l">
+              <a:t>Employee registration and database persistence</a:t>
+            </a:r>
+          </a:p>
+          <a:p>
+            <a:pPr algn="just">
               <a:lnSpc>
-                <a:spcPct val="112000"/>
+                <a:spcPct val="110000"/>
               </a:lnSpc>
               <a:spcAft>
-                <a:spcPts val="700"/>
+                <a:spcPts val="600"/>
               </a:spcAft>
             </a:pPr>
             <a:r>
-              <a:rPr sz="1600" b="0">
+              <a:rPr sz="1500">
                 <a:solidFill>
                   <a:srgbClr val="0F172A"/>
                 </a:solidFill>
                 <a:latin typeface="Arial"/>
               </a:rPr>
-              <a:t>Employee registration and database persistence</a:t>
-            </a:r>
-          </a:p>
-          <a:p>
-            <a:pPr algn="l">
+              <a:t>VPN first-time setup and password reset workflows</a:t>
+            </a:r>
+          </a:p>
+          <a:p>
+            <a:pPr algn="just">
               <a:lnSpc>
-                <a:spcPct val="112000"/>
+                <a:spcPct val="110000"/>
               </a:lnSpc>
               <a:spcAft>
-                <a:spcPts val="700"/>
+                <a:spcPts val="600"/>
               </a:spcAft>
             </a:pPr>
             <a:r>
-              <a:rPr sz="1600" b="0">
+              <a:rPr sz="1500">
                 <a:solidFill>
                   <a:srgbClr val="0F172A"/>
                 </a:solidFill>
                 <a:latin typeface="Arial"/>
               </a:rPr>
-              <a:t>VPN first-time setup and password reset workflows</a:t>
-            </a:r>
-          </a:p>
-          <a:p>
-            <a:pPr algn="l">
-              <a:lnSpc>
-                <a:spcPct val="112000"/>
-              </a:lnSpc>
-              <a:spcAft>
-                <a:spcPts val="700"/>
-              </a:spcAft>
-            </a:pPr>
-            <a:r>
-              <a:rPr sz="1600" b="0">
-                <a:solidFill>
-                  <a:srgbClr val="0F172A"/>
-                </a:solidFill>
-                <a:latin typeface="Arial"/>
-              </a:rPr>
               <a:t>Email dispatch for password and approval actions</a:t>
             </a:r>
           </a:p>
@@ -5085,7 +4825,7 @@
       </p:sp>
       <p:sp>
         <p:nvSpPr>
-          <p:cNvPr id="6" name="TextBox 5"/>
+          <p:cNvPr id="5" name="TextBox 4"/>
           <p:cNvSpPr txBox="1"/>
           <p:nvPr/>
         </p:nvSpPr>
@@ -5100,157 +4840,119 @@
           <a:noFill/>
         </p:spPr>
         <p:txBody>
-          <a:bodyPr wrap="none">
+          <a:bodyPr wrap="square">
             <a:spAutoFit/>
           </a:bodyPr>
           <a:lstStyle/>
           <a:p>
             <a:pPr algn="l">
+              <a:spcAft>
+                <a:spcPts val="800"/>
+              </a:spcAft>
+            </a:pPr>
+            <a:r>
+              <a:rPr sz="1800" b="1">
+                <a:solidFill>
+                  <a:srgbClr val="005EB8"/>
+                </a:solidFill>
+                <a:latin typeface="Arial"/>
+              </a:rPr>
+              <a:t>Security and Governance</a:t>
+            </a:r>
+          </a:p>
+          <a:p>
+            <a:pPr algn="just">
               <a:lnSpc>
-                <a:spcPct val="112000"/>
+                <a:spcPct val="110000"/>
               </a:lnSpc>
               <a:spcAft>
-                <a:spcPts val="700"/>
+                <a:spcPts val="600"/>
               </a:spcAft>
             </a:pPr>
             <a:r>
-              <a:rPr sz="1800" b="1">
-                <a:solidFill>
-                  <a:srgbClr val="005EB8"/>
-                </a:solidFill>
-                <a:latin typeface="Arial"/>
-              </a:rPr>
-              <a:t>Security and Governance</a:t>
-            </a:r>
-          </a:p>
-          <a:p>
-            <a:pPr algn="l">
+              <a:rPr sz="1500">
+                <a:solidFill>
+                  <a:srgbClr val="0F172A"/>
+                </a:solidFill>
+                <a:latin typeface="Arial"/>
+              </a:rPr>
+              <a:t>Secure login and sign-up with hashed passwords</a:t>
+            </a:r>
+          </a:p>
+          <a:p>
+            <a:pPr algn="just">
               <a:lnSpc>
-                <a:spcPct val="112000"/>
+                <a:spcPct val="110000"/>
               </a:lnSpc>
               <a:spcAft>
-                <a:spcPts val="700"/>
+                <a:spcPts val="600"/>
               </a:spcAft>
             </a:pPr>
             <a:r>
-              <a:rPr sz="1600" b="0">
+              <a:rPr sz="1500">
                 <a:solidFill>
                   <a:srgbClr val="0F172A"/>
                 </a:solidFill>
                 <a:latin typeface="Arial"/>
               </a:rPr>
-              <a:t>Secure login and sign-up with hashed passwords</a:t>
-            </a:r>
-          </a:p>
-          <a:p>
-            <a:pPr algn="l">
+              <a:t>Admin-only approval and rejection control</a:t>
+            </a:r>
+          </a:p>
+          <a:p>
+            <a:pPr algn="just">
               <a:lnSpc>
-                <a:spcPct val="112000"/>
+                <a:spcPct val="110000"/>
               </a:lnSpc>
               <a:spcAft>
-                <a:spcPts val="700"/>
+                <a:spcPts val="600"/>
               </a:spcAft>
             </a:pPr>
             <a:r>
-              <a:rPr sz="1600" b="0">
+              <a:rPr sz="1500">
                 <a:solidFill>
                   <a:srgbClr val="0F172A"/>
                 </a:solidFill>
                 <a:latin typeface="Arial"/>
               </a:rPr>
-              <a:t>Admin-only approval and rejection control</a:t>
-            </a:r>
-          </a:p>
-          <a:p>
-            <a:pPr algn="l">
+              <a:t>Protected admin profile and user-level access rules</a:t>
+            </a:r>
+          </a:p>
+          <a:p>
+            <a:pPr algn="just">
               <a:lnSpc>
-                <a:spcPct val="112000"/>
+                <a:spcPct val="110000"/>
               </a:lnSpc>
               <a:spcAft>
-                <a:spcPts val="700"/>
+                <a:spcPts val="600"/>
               </a:spcAft>
             </a:pPr>
             <a:r>
-              <a:rPr sz="1600" b="0">
+              <a:rPr sz="1500">
                 <a:solidFill>
                   <a:srgbClr val="0F172A"/>
                 </a:solidFill>
                 <a:latin typeface="Arial"/>
               </a:rPr>
-              <a:t>Protected admin profile and user-level access rules</a:t>
-            </a:r>
-          </a:p>
-          <a:p>
-            <a:pPr algn="l">
+              <a:t>Password reset token handling with expiry and validation</a:t>
+            </a:r>
+          </a:p>
+          <a:p>
+            <a:pPr algn="just">
               <a:lnSpc>
-                <a:spcPct val="112000"/>
+                <a:spcPct val="110000"/>
               </a:lnSpc>
               <a:spcAft>
-                <a:spcPts val="700"/>
+                <a:spcPts val="600"/>
               </a:spcAft>
             </a:pPr>
             <a:r>
-              <a:rPr sz="1600" b="0">
+              <a:rPr sz="1500">
                 <a:solidFill>
                   <a:srgbClr val="0F172A"/>
                 </a:solidFill>
                 <a:latin typeface="Arial"/>
               </a:rPr>
-              <a:t>Password reset token handling with expiry and validation</a:t>
-            </a:r>
-          </a:p>
-          <a:p>
-            <a:pPr algn="l">
-              <a:lnSpc>
-                <a:spcPct val="112000"/>
-              </a:lnSpc>
-              <a:spcAft>
-                <a:spcPts val="700"/>
-              </a:spcAft>
-            </a:pPr>
-            <a:r>
-              <a:rPr sz="1600" b="0">
-                <a:solidFill>
-                  <a:srgbClr val="0F172A"/>
-                </a:solidFill>
-                <a:latin typeface="Arial"/>
-              </a:rPr>
               <a:t>Safe DB initialization and deployment hardening</a:t>
-            </a:r>
-          </a:p>
-        </p:txBody>
-      </p:sp>
-      <p:sp>
-        <p:nvSpPr>
-          <p:cNvPr id="7" name="TextBox 6"/>
-          <p:cNvSpPr txBox="1"/>
-          <p:nvPr/>
-        </p:nvSpPr>
-        <p:spPr>
-          <a:xfrm>
-            <a:off x="137160" y="6473952"/>
-            <a:ext cx="11795760" cy="237744"/>
-          </a:xfrm>
-          <a:prstGeom prst="rect">
-            <a:avLst/>
-          </a:prstGeom>
-          <a:noFill/>
-        </p:spPr>
-        <p:txBody>
-          <a:bodyPr wrap="none">
-            <a:spAutoFit/>
-          </a:bodyPr>
-          <a:lstStyle/>
-          <a:p>
-            <a:pPr algn="ctr"/>
-            <a:r>
-              <a:rPr sz="900" b="1">
-                <a:solidFill>
-                  <a:srgbClr val="475569"/>
-                </a:solidFill>
-                <a:latin typeface="Arial"/>
-              </a:rPr>
-              <a:t>Owner: Ajay Kumar | Email: helloajay21@gmail.com | Batch 1 | Project: AI Operations Assistant Using Agentic AI | GitHub: https://github.com/helloajay21-max/-it-support-assistant | Azure: https://it-support-ajay-001.azurewebsites.net/</a:t>
             </a:r>
           </a:p>
         </p:txBody>
@@ -5283,14 +4985,49 @@
       <p:grpSpPr/>
       <p:sp>
         <p:nvSpPr>
-          <p:cNvPr id="2" name="Rectangle 1"/>
+          <p:cNvPr id="2" name="TextBox 1"/>
+          <p:cNvSpPr txBox="1"/>
+          <p:nvPr/>
+        </p:nvSpPr>
+        <p:spPr>
+          <a:xfrm>
+            <a:off x="548640" y="347472"/>
+            <a:ext cx="8229600" cy="640080"/>
+          </a:xfrm>
+          <a:prstGeom prst="rect">
+            <a:avLst/>
+          </a:prstGeom>
+          <a:noFill/>
+        </p:spPr>
+        <p:txBody>
+          <a:bodyPr wrap="none">
+            <a:spAutoFit/>
+          </a:bodyPr>
+          <a:lstStyle/>
+          <a:p>
+            <a:pPr algn="l"/>
+            <a:r>
+              <a:rPr sz="2400" b="1">
+                <a:solidFill>
+                  <a:srgbClr val="0F172A"/>
+                </a:solidFill>
+                <a:latin typeface="Arial"/>
+              </a:rPr>
+              <a:t>Deployment &amp; Live URL</a:t>
+            </a:r>
+          </a:p>
+        </p:txBody>
+      </p:sp>
+      <p:sp>
+        <p:nvSpPr>
+          <p:cNvPr id="3" name="Rectangle 2"/>
           <p:cNvSpPr/>
           <p:nvPr/>
         </p:nvSpPr>
         <p:spPr>
           <a:xfrm>
-            <a:off x="0" y="0"/>
-            <a:ext cx="12191695" cy="384048"/>
+            <a:off x="548640" y="868680"/>
+            <a:ext cx="1920240" cy="73152"/>
           </a:xfrm>
           <a:prstGeom prst="rect">
             <a:avLst/>
@@ -5326,14 +5063,14 @@
       </p:sp>
       <p:sp>
         <p:nvSpPr>
-          <p:cNvPr id="3" name="TextBox 2"/>
+          <p:cNvPr id="4" name="TextBox 3"/>
           <p:cNvSpPr txBox="1"/>
           <p:nvPr/>
         </p:nvSpPr>
         <p:spPr>
           <a:xfrm>
-            <a:off x="548640" y="502920"/>
-            <a:ext cx="7315200" cy="640080"/>
+            <a:off x="731520" y="1554480"/>
+            <a:ext cx="10607040" cy="3840480"/>
           </a:xfrm>
           <a:prstGeom prst="rect">
             <a:avLst/>
@@ -5346,139 +5083,16 @@
           </a:bodyPr>
           <a:lstStyle/>
           <a:p>
-            <a:pPr algn="l"/>
-            <a:r>
-              <a:rPr sz="2400" b="1">
-                <a:solidFill>
-                  <a:srgbClr val="0F172A"/>
-                </a:solidFill>
-                <a:latin typeface="Arial"/>
-              </a:rPr>
-              <a:t>Deployment &amp; Live URL</a:t>
-            </a:r>
-          </a:p>
-        </p:txBody>
-      </p:sp>
-      <p:sp>
-        <p:nvSpPr>
-          <p:cNvPr id="4" name="Rectangle 3"/>
-          <p:cNvSpPr/>
-          <p:nvPr/>
-        </p:nvSpPr>
-        <p:spPr>
-          <a:xfrm>
-            <a:off x="548640" y="914400"/>
-            <a:ext cx="1920240" cy="73152"/>
-          </a:xfrm>
-          <a:prstGeom prst="rect">
-            <a:avLst/>
-          </a:prstGeom>
-          <a:solidFill>
-            <a:srgbClr val="0EA5E9"/>
-          </a:solidFill>
-          <a:ln>
-            <a:noFill/>
-          </a:ln>
-        </p:spPr>
-        <p:style>
-          <a:lnRef idx="1">
-            <a:schemeClr val="accent1"/>
-          </a:lnRef>
-          <a:fillRef idx="3">
-            <a:schemeClr val="accent1"/>
-          </a:fillRef>
-          <a:effectRef idx="2">
-            <a:schemeClr val="accent1"/>
-          </a:effectRef>
-          <a:fontRef idx="minor">
-            <a:schemeClr val="lt1"/>
-          </a:fontRef>
-        </p:style>
-        <p:txBody>
-          <a:bodyPr rtlCol="0" anchor="ctr"/>
-          <a:lstStyle/>
-          <a:p>
-            <a:pPr algn="ctr"/>
-          </a:p>
-        </p:txBody>
-      </p:sp>
-      <p:sp>
-        <p:nvSpPr>
-          <p:cNvPr id="5" name="Rounded Rectangle 4"/>
-          <p:cNvSpPr/>
-          <p:nvPr/>
-        </p:nvSpPr>
-        <p:spPr>
-          <a:xfrm>
-            <a:off x="731520" y="1554480"/>
-            <a:ext cx="10698480" cy="3474720"/>
-          </a:xfrm>
-          <a:prstGeom prst="roundRect">
-            <a:avLst/>
-          </a:prstGeom>
-          <a:solidFill>
-            <a:srgbClr val="F0F7FF"/>
-          </a:solidFill>
-          <a:ln>
-            <a:solidFill>
-              <a:srgbClr val="005EB8"/>
-            </a:solidFill>
-          </a:ln>
-        </p:spPr>
-        <p:style>
-          <a:lnRef idx="1">
-            <a:schemeClr val="accent1"/>
-          </a:lnRef>
-          <a:fillRef idx="3">
-            <a:schemeClr val="accent1"/>
-          </a:fillRef>
-          <a:effectRef idx="2">
-            <a:schemeClr val="accent1"/>
-          </a:effectRef>
-          <a:fontRef idx="minor">
-            <a:schemeClr val="lt1"/>
-          </a:fontRef>
-        </p:style>
-        <p:txBody>
-          <a:bodyPr rtlCol="0" anchor="ctr"/>
-          <a:lstStyle/>
-          <a:p>
-            <a:pPr algn="ctr"/>
-          </a:p>
-        </p:txBody>
-      </p:sp>
-      <p:sp>
-        <p:nvSpPr>
-          <p:cNvPr id="6" name="TextBox 5"/>
-          <p:cNvSpPr txBox="1"/>
-          <p:nvPr/>
-        </p:nvSpPr>
-        <p:spPr>
-          <a:xfrm>
-            <a:off x="1005840" y="1828800"/>
-            <a:ext cx="10058400" cy="2834640"/>
-          </a:xfrm>
-          <a:prstGeom prst="rect">
-            <a:avLst/>
-          </a:prstGeom>
-          <a:noFill/>
-        </p:spPr>
-        <p:txBody>
-          <a:bodyPr wrap="none">
-            <a:spAutoFit/>
-          </a:bodyPr>
-          <a:lstStyle/>
-          <a:p>
             <a:pPr algn="l">
               <a:lnSpc>
                 <a:spcPct val="110000"/>
               </a:lnSpc>
               <a:spcAft>
-                <a:spcPts val="500"/>
+                <a:spcPts val="600"/>
               </a:spcAft>
             </a:pPr>
             <a:r>
-              <a:rPr sz="1700" b="1">
+              <a:rPr sz="1800" b="1">
                 <a:solidFill>
                   <a:srgbClr val="005EB8"/>
                 </a:solidFill>
@@ -5493,11 +5107,11 @@
                 <a:spcPct val="110000"/>
               </a:lnSpc>
               <a:spcAft>
-                <a:spcPts val="500"/>
+                <a:spcPts val="600"/>
               </a:spcAft>
             </a:pPr>
             <a:r>
-              <a:rPr sz="1500">
+              <a:rPr sz="1600">
                 <a:solidFill>
                   <a:srgbClr val="0F172A"/>
                 </a:solidFill>
@@ -5512,11 +5126,11 @@
                 <a:spcPct val="110000"/>
               </a:lnSpc>
               <a:spcAft>
-                <a:spcPts val="500"/>
+                <a:spcPts val="600"/>
               </a:spcAft>
             </a:pPr>
             <a:r>
-              <a:rPr sz="1700" b="1">
+              <a:rPr sz="1800" b="1">
                 <a:solidFill>
                   <a:srgbClr val="005EB8"/>
                 </a:solidFill>
@@ -5531,11 +5145,11 @@
                 <a:spcPct val="110000"/>
               </a:lnSpc>
               <a:spcAft>
-                <a:spcPts val="500"/>
+                <a:spcPts val="600"/>
               </a:spcAft>
             </a:pPr>
             <a:r>
-              <a:rPr sz="1500">
+              <a:rPr sz="1600">
                 <a:solidFill>
                   <a:srgbClr val="0F172A"/>
                 </a:solidFill>
@@ -5550,11 +5164,11 @@
                 <a:spcPct val="110000"/>
               </a:lnSpc>
               <a:spcAft>
-                <a:spcPts val="500"/>
+                <a:spcPts val="600"/>
               </a:spcAft>
             </a:pPr>
             <a:r>
-              <a:rPr sz="1700" b="1">
+              <a:rPr sz="1800" b="1">
                 <a:solidFill>
                   <a:srgbClr val="005EB8"/>
                 </a:solidFill>
@@ -5569,7 +5183,7 @@
                 <a:spcPct val="110000"/>
               </a:lnSpc>
               <a:spcAft>
-                <a:spcPts val="500"/>
+                <a:spcPts val="600"/>
               </a:spcAft>
             </a:pPr>
             <a:r>
@@ -5588,7 +5202,7 @@
                 <a:spcPct val="110000"/>
               </a:lnSpc>
               <a:spcAft>
-                <a:spcPts val="500"/>
+                <a:spcPts val="600"/>
               </a:spcAft>
             </a:pPr>
             <a:r>
@@ -5607,7 +5221,7 @@
                 <a:spcPct val="110000"/>
               </a:lnSpc>
               <a:spcAft>
-                <a:spcPts val="500"/>
+                <a:spcPts val="600"/>
               </a:spcAft>
             </a:pPr>
             <a:r>
@@ -5626,7 +5240,7 @@
                 <a:spcPct val="110000"/>
               </a:lnSpc>
               <a:spcAft>
-                <a:spcPts val="500"/>
+                <a:spcPts val="600"/>
               </a:spcAft>
             </a:pPr>
             <a:r>
@@ -5637,41 +5251,6 @@
                 <a:latin typeface="Arial"/>
               </a:rPr>
               <a:t>? Application restarts after successful deployment</a:t>
-            </a:r>
-          </a:p>
-        </p:txBody>
-      </p:sp>
-      <p:sp>
-        <p:nvSpPr>
-          <p:cNvPr id="7" name="TextBox 6"/>
-          <p:cNvSpPr txBox="1"/>
-          <p:nvPr/>
-        </p:nvSpPr>
-        <p:spPr>
-          <a:xfrm>
-            <a:off x="137160" y="6473952"/>
-            <a:ext cx="11795760" cy="237744"/>
-          </a:xfrm>
-          <a:prstGeom prst="rect">
-            <a:avLst/>
-          </a:prstGeom>
-          <a:noFill/>
-        </p:spPr>
-        <p:txBody>
-          <a:bodyPr wrap="none">
-            <a:spAutoFit/>
-          </a:bodyPr>
-          <a:lstStyle/>
-          <a:p>
-            <a:pPr algn="ctr"/>
-            <a:r>
-              <a:rPr sz="900" b="1">
-                <a:solidFill>
-                  <a:srgbClr val="475569"/>
-                </a:solidFill>
-                <a:latin typeface="Arial"/>
-              </a:rPr>
-              <a:t>Owner: Ajay Kumar | Email: helloajay21@gmail.com | Batch 1 | Project: AI Operations Assistant Using Agentic AI | GitHub: https://github.com/helloajay21-max/-it-support-assistant | Azure: https://it-support-ajay-001.azurewebsites.net/</a:t>
             </a:r>
           </a:p>
         </p:txBody>
@@ -5704,14 +5283,49 @@
       <p:grpSpPr/>
       <p:sp>
         <p:nvSpPr>
-          <p:cNvPr id="2" name="Rectangle 1"/>
+          <p:cNvPr id="2" name="TextBox 1"/>
+          <p:cNvSpPr txBox="1"/>
+          <p:nvPr/>
+        </p:nvSpPr>
+        <p:spPr>
+          <a:xfrm>
+            <a:off x="548640" y="347472"/>
+            <a:ext cx="8229600" cy="640080"/>
+          </a:xfrm>
+          <a:prstGeom prst="rect">
+            <a:avLst/>
+          </a:prstGeom>
+          <a:noFill/>
+        </p:spPr>
+        <p:txBody>
+          <a:bodyPr wrap="none">
+            <a:spAutoFit/>
+          </a:bodyPr>
+          <a:lstStyle/>
+          <a:p>
+            <a:pPr algn="l"/>
+            <a:r>
+              <a:rPr sz="2400" b="1">
+                <a:solidFill>
+                  <a:srgbClr val="0F172A"/>
+                </a:solidFill>
+                <a:latin typeface="Arial"/>
+              </a:rPr>
+              <a:t>Conclusion</a:t>
+            </a:r>
+          </a:p>
+        </p:txBody>
+      </p:sp>
+      <p:sp>
+        <p:nvSpPr>
+          <p:cNvPr id="3" name="Rectangle 2"/>
           <p:cNvSpPr/>
           <p:nvPr/>
         </p:nvSpPr>
         <p:spPr>
           <a:xfrm>
-            <a:off x="0" y="0"/>
-            <a:ext cx="12191695" cy="384048"/>
+            <a:off x="548640" y="868680"/>
+            <a:ext cx="1920240" cy="73152"/>
           </a:xfrm>
           <a:prstGeom prst="rect">
             <a:avLst/>
@@ -5747,91 +5361,13 @@
       </p:sp>
       <p:sp>
         <p:nvSpPr>
-          <p:cNvPr id="3" name="TextBox 2"/>
+          <p:cNvPr id="4" name="TextBox 3"/>
           <p:cNvSpPr txBox="1"/>
           <p:nvPr/>
         </p:nvSpPr>
         <p:spPr>
           <a:xfrm>
-            <a:off x="548640" y="502920"/>
-            <a:ext cx="7315200" cy="640080"/>
-          </a:xfrm>
-          <a:prstGeom prst="rect">
-            <a:avLst/>
-          </a:prstGeom>
-          <a:noFill/>
-        </p:spPr>
-        <p:txBody>
-          <a:bodyPr wrap="none">
-            <a:spAutoFit/>
-          </a:bodyPr>
-          <a:lstStyle/>
-          <a:p>
-            <a:pPr algn="l"/>
-            <a:r>
-              <a:rPr sz="2400" b="1">
-                <a:solidFill>
-                  <a:srgbClr val="0F172A"/>
-                </a:solidFill>
-                <a:latin typeface="Arial"/>
-              </a:rPr>
-              <a:t>Conclusion</a:t>
-            </a:r>
-          </a:p>
-        </p:txBody>
-      </p:sp>
-      <p:sp>
-        <p:nvSpPr>
-          <p:cNvPr id="4" name="Rectangle 3"/>
-          <p:cNvSpPr/>
-          <p:nvPr/>
-        </p:nvSpPr>
-        <p:spPr>
-          <a:xfrm>
-            <a:off x="548640" y="914400"/>
-            <a:ext cx="1920240" cy="73152"/>
-          </a:xfrm>
-          <a:prstGeom prst="rect">
-            <a:avLst/>
-          </a:prstGeom>
-          <a:solidFill>
-            <a:srgbClr val="0EA5E9"/>
-          </a:solidFill>
-          <a:ln>
-            <a:noFill/>
-          </a:ln>
-        </p:spPr>
-        <p:style>
-          <a:lnRef idx="1">
-            <a:schemeClr val="accent1"/>
-          </a:lnRef>
-          <a:fillRef idx="3">
-            <a:schemeClr val="accent1"/>
-          </a:fillRef>
-          <a:effectRef idx="2">
-            <a:schemeClr val="accent1"/>
-          </a:effectRef>
-          <a:fontRef idx="minor">
-            <a:schemeClr val="lt1"/>
-          </a:fontRef>
-        </p:style>
-        <p:txBody>
-          <a:bodyPr rtlCol="0" anchor="ctr"/>
-          <a:lstStyle/>
-          <a:p>
-            <a:pPr algn="ctr"/>
-          </a:p>
-        </p:txBody>
-      </p:sp>
-      <p:sp>
-        <p:nvSpPr>
-          <p:cNvPr id="5" name="TextBox 4"/>
-          <p:cNvSpPr txBox="1"/>
-          <p:nvPr/>
-        </p:nvSpPr>
-        <p:spPr>
-          <a:xfrm>
-            <a:off x="731520" y="1645920"/>
+            <a:off x="731520" y="1463040"/>
             <a:ext cx="10698480" cy="3931920"/>
           </a:xfrm>
           <a:prstGeom prst="rect">
@@ -5847,14 +5383,14 @@
           <a:p>
             <a:pPr algn="just">
               <a:lnSpc>
-                <a:spcPct val="110000"/>
+                <a:spcPct val="112000"/>
               </a:lnSpc>
               <a:spcAft>
-                <a:spcPts val="800"/>
+                <a:spcPts val="500"/>
               </a:spcAft>
             </a:pPr>
             <a:r>
-              <a:rPr sz="2000" b="0">
+              <a:rPr sz="2000">
                 <a:solidFill>
                   <a:srgbClr val="0F172A"/>
                 </a:solidFill>
@@ -5866,14 +5402,14 @@
           <a:p>
             <a:pPr algn="just">
               <a:lnSpc>
-                <a:spcPct val="110000"/>
+                <a:spcPct val="112000"/>
               </a:lnSpc>
               <a:spcAft>
-                <a:spcPts val="800"/>
+                <a:spcPts val="500"/>
               </a:spcAft>
             </a:pPr>
             <a:r>
-              <a:rPr sz="2000" b="0">
+              <a:rPr sz="2000">
                 <a:solidFill>
                   <a:srgbClr val="0F172A"/>
                 </a:solidFill>
@@ -5885,55 +5421,20 @@
           <a:p>
             <a:pPr algn="just">
               <a:lnSpc>
-                <a:spcPct val="110000"/>
+                <a:spcPct val="112000"/>
               </a:lnSpc>
               <a:spcAft>
-                <a:spcPts val="800"/>
+                <a:spcPts val="500"/>
               </a:spcAft>
             </a:pPr>
             <a:r>
-              <a:rPr sz="2000" b="0">
+              <a:rPr sz="2000">
                 <a:solidFill>
                   <a:srgbClr val="0F172A"/>
                 </a:solidFill>
                 <a:latin typeface="Arial"/>
               </a:rPr>
               <a:t>Overall, the solution is ready for real-world business use and presents a professional, scalable foundation for future enhancements.</a:t>
-            </a:r>
-          </a:p>
-        </p:txBody>
-      </p:sp>
-      <p:sp>
-        <p:nvSpPr>
-          <p:cNvPr id="6" name="TextBox 5"/>
-          <p:cNvSpPr txBox="1"/>
-          <p:nvPr/>
-        </p:nvSpPr>
-        <p:spPr>
-          <a:xfrm>
-            <a:off x="137160" y="6473952"/>
-            <a:ext cx="11795760" cy="237744"/>
-          </a:xfrm>
-          <a:prstGeom prst="rect">
-            <a:avLst/>
-          </a:prstGeom>
-          <a:noFill/>
-        </p:spPr>
-        <p:txBody>
-          <a:bodyPr wrap="none">
-            <a:spAutoFit/>
-          </a:bodyPr>
-          <a:lstStyle/>
-          <a:p>
-            <a:pPr algn="ctr"/>
-            <a:r>
-              <a:rPr sz="900" b="1">
-                <a:solidFill>
-                  <a:srgbClr val="475569"/>
-                </a:solidFill>
-                <a:latin typeface="Arial"/>
-              </a:rPr>
-              <a:t>Owner: Ajay Kumar | Email: helloajay21@gmail.com | Batch 1 | Project: AI Operations Assistant Using Agentic AI | GitHub: https://github.com/helloajay21-max/-it-support-assistant | Azure: https://it-support-ajay-001.azurewebsites.net/</a:t>
             </a:r>
           </a:p>
         </p:txBody>

</xml_diff>